<commit_message>
Add visible bullets to module slides
</commit_message>
<xml_diff>
--- a/downloads/presentations/modules/anl-220.pptx
+++ b/downloads/presentations/modules/anl-220.pptx
@@ -3353,49 +3353,58 @@
           <a:ln/>
         </p:spPr>
         <p:txBody>
-          <a:bodyPr wrap="square" lIns="635" tIns="635" rIns="635" bIns="635" rtlCol="0" anchor="t">
+          <a:bodyPr wrap="square" lIns="1016" tIns="1016" rIns="1016" bIns="1016" rtlCol="0" anchor="t">
             <a:normAutofit/>
           </a:bodyPr>
           <a:lstStyle/>
           <a:p>
+            <a:pPr indent="0" marL="0">
+              <a:buNone/>
+            </a:pPr>
             <a:r>
               <a:rPr lang="en-US" sz="2100" dirty="0">
                 <a:solidFill>
-                  <a:srgbClr val="17364A"/>
-                </a:solidFill>
-                <a:latin typeface="Aptos" pitchFamily="34" charset="0"/>
-                <a:ea typeface="Aptos" pitchFamily="34" charset="-122"/>
-                <a:cs typeface="Aptos" pitchFamily="34" charset="-120"/>
-              </a:rPr>
-              <a:t>A predictive workflow begins with the outcome.</a:t>
+                  <a:srgbClr val="003A63"/>
+                </a:solidFill>
+                <a:latin typeface="Aptos" pitchFamily="34" charset="0"/>
+                <a:ea typeface="Aptos" pitchFamily="34" charset="-122"/>
+                <a:cs typeface="Aptos" pitchFamily="34" charset="-120"/>
+              </a:rPr>
+              <a:t>• A predictive workflow begins with the outcome.</a:t>
             </a:r>
             <a:endParaRPr lang="en-US" sz="2100" dirty="0"/>
           </a:p>
           <a:p>
+            <a:pPr indent="0" marL="0">
+              <a:buNone/>
+            </a:pPr>
             <a:r>
               <a:rPr lang="en-US" sz="2100" dirty="0">
                 <a:solidFill>
-                  <a:srgbClr val="17364A"/>
-                </a:solidFill>
-                <a:latin typeface="Aptos" pitchFamily="34" charset="0"/>
-                <a:ea typeface="Aptos" pitchFamily="34" charset="-122"/>
-                <a:cs typeface="Aptos" pitchFamily="34" charset="-120"/>
-              </a:rPr>
-              <a:t>The outcome must be specific, measurable, and aligned with a public health action.</a:t>
+                  <a:srgbClr val="003A63"/>
+                </a:solidFill>
+                <a:latin typeface="Aptos" pitchFamily="34" charset="0"/>
+                <a:ea typeface="Aptos" pitchFamily="34" charset="-122"/>
+                <a:cs typeface="Aptos" pitchFamily="34" charset="-120"/>
+              </a:rPr>
+              <a:t>• The outcome must be specific, measurable, and aligned with a public health action.</a:t>
             </a:r>
             <a:endParaRPr lang="en-US" sz="2100" dirty="0"/>
           </a:p>
           <a:p>
+            <a:pPr indent="0" marL="0">
+              <a:buNone/>
+            </a:pPr>
             <a:r>
               <a:rPr lang="en-US" sz="2100" dirty="0">
                 <a:solidFill>
-                  <a:srgbClr val="17364A"/>
-                </a:solidFill>
-                <a:latin typeface="Aptos" pitchFamily="34" charset="0"/>
-                <a:ea typeface="Aptos" pitchFamily="34" charset="-122"/>
-                <a:cs typeface="Aptos" pitchFamily="34" charset="-120"/>
-              </a:rPr>
-              <a:t>Predicting “risk” is not enough.</a:t>
+                  <a:srgbClr val="003A63"/>
+                </a:solidFill>
+                <a:latin typeface="Aptos" pitchFamily="34" charset="0"/>
+                <a:ea typeface="Aptos" pitchFamily="34" charset="-122"/>
+                <a:cs typeface="Aptos" pitchFamily="34" charset="-120"/>
+              </a:rPr>
+              <a:t>• Predicting “risk” is not enough.</a:t>
             </a:r>
             <a:endParaRPr lang="en-US" sz="2100" dirty="0"/>
           </a:p>
@@ -3475,17 +3484,17 @@
         </p:nvSpPr>
         <p:spPr>
           <a:xfrm>
-            <a:off x="7799832" y="1828800"/>
-            <a:ext cx="3145536" cy="685800"/>
-          </a:xfrm>
-          <a:prstGeom prst="rect">
-            <a:avLst/>
-          </a:prstGeom>
-          <a:noFill/>
-          <a:ln/>
-        </p:spPr>
-        <p:txBody>
-          <a:bodyPr wrap="square" lIns="0" tIns="0" rIns="0" bIns="0" rtlCol="0" anchor="t">
+            <a:off x="7799832" y="1801368"/>
+            <a:ext cx="3145536" cy="758952"/>
+          </a:xfrm>
+          <a:prstGeom prst="rect">
+            <a:avLst/>
+          </a:prstGeom>
+          <a:noFill/>
+          <a:ln/>
+        </p:spPr>
+        <p:txBody>
+          <a:bodyPr wrap="square" lIns="254" tIns="254" rIns="254" bIns="254" rtlCol="0" anchor="t">
             <a:normAutofit/>
           </a:bodyPr>
           <a:lstStyle/>
@@ -3494,7 +3503,7 @@
               <a:buNone/>
             </a:pPr>
             <a:r>
-              <a:rPr lang="en-US" sz="1550" dirty="0">
+              <a:rPr lang="en-US" sz="1320" dirty="0">
                 <a:solidFill>
                   <a:srgbClr val="17364A"/>
                 </a:solidFill>
@@ -3504,7 +3513,7 @@
               </a:rPr>
               <a:t>A predictive workflow begins with the outcome.</a:t>
             </a:r>
-            <a:endParaRPr lang="en-US" sz="1550" dirty="0"/>
+            <a:endParaRPr lang="en-US" sz="1320" dirty="0"/>
           </a:p>
         </p:txBody>
       </p:sp>
@@ -3592,13 +3601,16 @@
           <a:ln/>
         </p:spPr>
         <p:txBody>
-          <a:bodyPr wrap="square" lIns="254" tIns="254" rIns="254" bIns="254" rtlCol="0" anchor="t">
+          <a:bodyPr wrap="square" lIns="508" tIns="508" rIns="508" bIns="508" rtlCol="0" anchor="t">
             <a:normAutofit/>
           </a:bodyPr>
           <a:lstStyle/>
           <a:p>
-            <a:r>
-              <a:rPr lang="en-US" sz="1380" dirty="0">
+            <a:pPr indent="0" marL="0">
+              <a:buNone/>
+            </a:pPr>
+            <a:r>
+              <a:rPr lang="en-US" sz="1220" dirty="0">
                 <a:solidFill>
                   <a:srgbClr val="17364A"/>
                 </a:solidFill>
@@ -3606,13 +3618,16 @@
                 <a:ea typeface="Aptos" pitchFamily="34" charset="-122"/>
                 <a:cs typeface="Aptos" pitchFamily="34" charset="-120"/>
               </a:rPr>
-              <a:t>Staff must define risk of what, during what time period, for which population, and for.</a:t>
-            </a:r>
-            <a:endParaRPr lang="en-US" sz="1380" dirty="0"/>
-          </a:p>
-          <a:p>
-            <a:r>
-              <a:rPr lang="en-US" sz="1380" dirty="0">
+              <a:t>Staff must define risk of what, during what time period, for which.</a:t>
+            </a:r>
+            <a:endParaRPr lang="en-US" sz="1220" dirty="0"/>
+          </a:p>
+          <a:p>
+            <a:pPr indent="0" marL="0">
+              <a:buNone/>
+            </a:pPr>
+            <a:r>
+              <a:rPr lang="en-US" sz="1220" dirty="0">
                 <a:solidFill>
                   <a:srgbClr val="17364A"/>
                 </a:solidFill>
@@ -3620,13 +3635,16 @@
                 <a:ea typeface="Aptos" pitchFamily="34" charset="-122"/>
                 <a:cs typeface="Aptos" pitchFamily="34" charset="-120"/>
               </a:rPr>
-              <a:t>A model predicting hospitalization within 30 days is different from one predicting delayed.</a:t>
-            </a:r>
-            <a:endParaRPr lang="en-US" sz="1380" dirty="0"/>
-          </a:p>
-          <a:p>
-            <a:r>
-              <a:rPr lang="en-US" sz="1380" dirty="0">
+              <a:t>A model predicting hospitalization within 30 days is different.</a:t>
+            </a:r>
+            <a:endParaRPr lang="en-US" sz="1220" dirty="0"/>
+          </a:p>
+          <a:p>
+            <a:pPr indent="0" marL="0">
+              <a:buNone/>
+            </a:pPr>
+            <a:r>
+              <a:rPr lang="en-US" sz="1220" dirty="0">
                 <a:solidFill>
                   <a:srgbClr val="17364A"/>
                 </a:solidFill>
@@ -3634,9 +3652,9 @@
                 <a:ea typeface="Aptos" pitchFamily="34" charset="-122"/>
                 <a:cs typeface="Aptos" pitchFamily="34" charset="-120"/>
               </a:rPr>
-              <a:t>Feature selection should be reviewed for both technical and ethical implications.</a:t>
-            </a:r>
-            <a:endParaRPr lang="en-US" sz="1380" dirty="0"/>
+              <a:t>Feature selection should be reviewed for both technical and.</a:t>
+            </a:r>
+            <a:endParaRPr lang="en-US" sz="1220" dirty="0"/>
           </a:p>
         </p:txBody>
       </p:sp>
@@ -3714,17 +3732,17 @@
         </p:nvSpPr>
         <p:spPr>
           <a:xfrm>
-            <a:off x="7799832" y="5001768"/>
-            <a:ext cx="3145536" cy="502920"/>
-          </a:xfrm>
-          <a:prstGeom prst="rect">
-            <a:avLst/>
-          </a:prstGeom>
-          <a:noFill/>
-          <a:ln/>
-        </p:spPr>
-        <p:txBody>
-          <a:bodyPr wrap="square" lIns="0" tIns="0" rIns="0" bIns="0" rtlCol="0" anchor="t">
+            <a:off x="7799832" y="4974336"/>
+            <a:ext cx="3145536" cy="576072"/>
+          </a:xfrm>
+          <a:prstGeom prst="rect">
+            <a:avLst/>
+          </a:prstGeom>
+          <a:noFill/>
+          <a:ln/>
+        </p:spPr>
+        <p:txBody>
+          <a:bodyPr wrap="square" lIns="254" tIns="254" rIns="254" bIns="254" rtlCol="0" anchor="t">
             <a:normAutofit/>
           </a:bodyPr>
           <a:lstStyle/>
@@ -3733,7 +3751,7 @@
               <a:buNone/>
             </a:pPr>
             <a:r>
-              <a:rPr lang="en-US" sz="1550" dirty="0">
+              <a:rPr lang="en-US" sz="1320" dirty="0">
                 <a:solidFill>
                   <a:srgbClr val="17364A"/>
                 </a:solidFill>
@@ -3741,9 +3759,9 @@
                 <a:ea typeface="Aptos" pitchFamily="34" charset="-122"/>
                 <a:cs typeface="Aptos" pitchFamily="34" charset="-120"/>
               </a:rPr>
-              <a:t>Identify what could go wrong, who could be affected, what safeguards are needed, and what evidence should be reviewed before use expands.</a:t>
-            </a:r>
-            <a:endParaRPr lang="en-US" sz="1550" dirty="0"/>
+              <a:t>Identify what could go wrong, who could be affected, what safeguards are needed, and what evidence should be reviewed.</a:t>
+            </a:r>
+            <a:endParaRPr lang="en-US" sz="1320" dirty="0"/>
           </a:p>
         </p:txBody>
       </p:sp>
@@ -4044,49 +4062,58 @@
           <a:ln/>
         </p:spPr>
         <p:txBody>
-          <a:bodyPr wrap="square" lIns="635" tIns="635" rIns="635" bIns="635" rtlCol="0" anchor="t">
+          <a:bodyPr wrap="square" lIns="1016" tIns="1016" rIns="1016" bIns="1016" rtlCol="0" anchor="t">
             <a:normAutofit/>
           </a:bodyPr>
           <a:lstStyle/>
           <a:p>
+            <a:pPr indent="0" marL="0">
+              <a:buNone/>
+            </a:pPr>
             <a:r>
               <a:rPr lang="en-US" sz="2100" dirty="0">
                 <a:solidFill>
-                  <a:srgbClr val="17364A"/>
-                </a:solidFill>
-                <a:latin typeface="Aptos" pitchFamily="34" charset="0"/>
-                <a:ea typeface="Aptos" pitchFamily="34" charset="-122"/>
-                <a:cs typeface="Aptos" pitchFamily="34" charset="-120"/>
-              </a:rPr>
-              <a:t>Thresholds are policy and workflow decisions as much as technical decisions.</a:t>
+                  <a:srgbClr val="003A63"/>
+                </a:solidFill>
+                <a:latin typeface="Aptos" pitchFamily="34" charset="0"/>
+                <a:ea typeface="Aptos" pitchFamily="34" charset="-122"/>
+                <a:cs typeface="Aptos" pitchFamily="34" charset="-120"/>
+              </a:rPr>
+              <a:t>• Thresholds are policy and workflow decisions as much as technical decisions.</a:t>
             </a:r>
             <a:endParaRPr lang="en-US" sz="2100" dirty="0"/>
           </a:p>
           <a:p>
+            <a:pPr indent="0" marL="0">
+              <a:buNone/>
+            </a:pPr>
             <a:r>
               <a:rPr lang="en-US" sz="2100" dirty="0">
                 <a:solidFill>
-                  <a:srgbClr val="17364A"/>
-                </a:solidFill>
-                <a:latin typeface="Aptos" pitchFamily="34" charset="0"/>
-                <a:ea typeface="Aptos" pitchFamily="34" charset="-122"/>
-                <a:cs typeface="Aptos" pitchFamily="34" charset="-120"/>
-              </a:rPr>
-              <a:t>A lower threshold may catch more true high-risk cases but create more false positives and burden staff.</a:t>
+                  <a:srgbClr val="003A63"/>
+                </a:solidFill>
+                <a:latin typeface="Aptos" pitchFamily="34" charset="0"/>
+                <a:ea typeface="Aptos" pitchFamily="34" charset="-122"/>
+                <a:cs typeface="Aptos" pitchFamily="34" charset="-120"/>
+              </a:rPr>
+              <a:t>• A lower threshold may catch more true high-risk cases but create more false positives and.</a:t>
             </a:r>
             <a:endParaRPr lang="en-US" sz="2100" dirty="0"/>
           </a:p>
           <a:p>
+            <a:pPr indent="0" marL="0">
+              <a:buNone/>
+            </a:pPr>
             <a:r>
               <a:rPr lang="en-US" sz="2100" dirty="0">
                 <a:solidFill>
-                  <a:srgbClr val="17364A"/>
-                </a:solidFill>
-                <a:latin typeface="Aptos" pitchFamily="34" charset="0"/>
-                <a:ea typeface="Aptos" pitchFamily="34" charset="-122"/>
-                <a:cs typeface="Aptos" pitchFamily="34" charset="-120"/>
-              </a:rPr>
-              <a:t>A higher threshold may conserve resources but miss people or places needing support.</a:t>
+                  <a:srgbClr val="003A63"/>
+                </a:solidFill>
+                <a:latin typeface="Aptos" pitchFamily="34" charset="0"/>
+                <a:ea typeface="Aptos" pitchFamily="34" charset="-122"/>
+                <a:cs typeface="Aptos" pitchFamily="34" charset="-120"/>
+              </a:rPr>
+              <a:t>• A higher threshold may conserve resources but miss people or places needing support.</a:t>
             </a:r>
             <a:endParaRPr lang="en-US" sz="2100" dirty="0"/>
           </a:p>
@@ -4166,17 +4193,17 @@
         </p:nvSpPr>
         <p:spPr>
           <a:xfrm>
-            <a:off x="7799832" y="1828800"/>
-            <a:ext cx="3145536" cy="685800"/>
-          </a:xfrm>
-          <a:prstGeom prst="rect">
-            <a:avLst/>
-          </a:prstGeom>
-          <a:noFill/>
-          <a:ln/>
-        </p:spPr>
-        <p:txBody>
-          <a:bodyPr wrap="square" lIns="0" tIns="0" rIns="0" bIns="0" rtlCol="0" anchor="t">
+            <a:off x="7799832" y="1801368"/>
+            <a:ext cx="3145536" cy="758952"/>
+          </a:xfrm>
+          <a:prstGeom prst="rect">
+            <a:avLst/>
+          </a:prstGeom>
+          <a:noFill/>
+          <a:ln/>
+        </p:spPr>
+        <p:txBody>
+          <a:bodyPr wrap="square" lIns="254" tIns="254" rIns="254" bIns="254" rtlCol="0" anchor="t">
             <a:normAutofit/>
           </a:bodyPr>
           <a:lstStyle/>
@@ -4185,7 +4212,7 @@
               <a:buNone/>
             </a:pPr>
             <a:r>
-              <a:rPr lang="en-US" sz="1550" dirty="0">
+              <a:rPr lang="en-US" sz="1320" dirty="0">
                 <a:solidFill>
                   <a:srgbClr val="17364A"/>
                 </a:solidFill>
@@ -4195,7 +4222,7 @@
               </a:rPr>
               <a:t>Thresholds are policy and workflow decisions as much as technical decisions.</a:t>
             </a:r>
-            <a:endParaRPr lang="en-US" sz="1550" dirty="0"/>
+            <a:endParaRPr lang="en-US" sz="1320" dirty="0"/>
           </a:p>
         </p:txBody>
       </p:sp>
@@ -4283,13 +4310,16 @@
           <a:ln/>
         </p:spPr>
         <p:txBody>
-          <a:bodyPr wrap="square" lIns="254" tIns="254" rIns="254" bIns="254" rtlCol="0" anchor="t">
+          <a:bodyPr wrap="square" lIns="508" tIns="508" rIns="508" bIns="508" rtlCol="0" anchor="t">
             <a:normAutofit/>
           </a:bodyPr>
           <a:lstStyle/>
           <a:p>
-            <a:r>
-              <a:rPr lang="en-US" sz="1380" dirty="0">
+            <a:pPr indent="0" marL="0">
+              <a:buNone/>
+            </a:pPr>
+            <a:r>
+              <a:rPr lang="en-US" sz="1220" dirty="0">
                 <a:solidFill>
                   <a:srgbClr val="17364A"/>
                 </a:solidFill>
@@ -4297,13 +4327,16 @@
                 <a:ea typeface="Aptos" pitchFamily="34" charset="-122"/>
                 <a:cs typeface="Aptos" pitchFamily="34" charset="-120"/>
               </a:rPr>
-              <a:t>Threshold selection should consider staffing capacity, consequence severity, equity, and.</a:t>
-            </a:r>
-            <a:endParaRPr lang="en-US" sz="1380" dirty="0"/>
-          </a:p>
-          <a:p>
-            <a:r>
-              <a:rPr lang="en-US" sz="1380" dirty="0">
+              <a:t>Threshold selection should consider staffing capacity, consequence.</a:t>
+            </a:r>
+            <a:endParaRPr lang="en-US" sz="1220" dirty="0"/>
+          </a:p>
+          <a:p>
+            <a:pPr indent="0" marL="0">
+              <a:buNone/>
+            </a:pPr>
+            <a:r>
+              <a:rPr lang="en-US" sz="1220" dirty="0">
                 <a:solidFill>
                   <a:srgbClr val="17364A"/>
                 </a:solidFill>
@@ -4313,11 +4346,14 @@
               </a:rPr>
               <a:t>Post-deployment monitoring is essential.</a:t>
             </a:r>
-            <a:endParaRPr lang="en-US" sz="1380" dirty="0"/>
-          </a:p>
-          <a:p>
-            <a:r>
-              <a:rPr lang="en-US" sz="1380" dirty="0">
+            <a:endParaRPr lang="en-US" sz="1220" dirty="0"/>
+          </a:p>
+          <a:p>
+            <a:pPr indent="0" marL="0">
+              <a:buNone/>
+            </a:pPr>
+            <a:r>
+              <a:rPr lang="en-US" sz="1220" dirty="0">
                 <a:solidFill>
                   <a:srgbClr val="17364A"/>
                 </a:solidFill>
@@ -4325,9 +4361,9 @@
                 <a:ea typeface="Aptos" pitchFamily="34" charset="-122"/>
                 <a:cs typeface="Aptos" pitchFamily="34" charset="-120"/>
               </a:rPr>
-              <a:t>A model that worked during development may degrade as disease patterns, reporting systems,.</a:t>
-            </a:r>
-            <a:endParaRPr lang="en-US" sz="1380" dirty="0"/>
+              <a:t>A model that worked during development may degrade as disease.</a:t>
+            </a:r>
+            <a:endParaRPr lang="en-US" sz="1220" dirty="0"/>
           </a:p>
         </p:txBody>
       </p:sp>
@@ -4405,17 +4441,17 @@
         </p:nvSpPr>
         <p:spPr>
           <a:xfrm>
-            <a:off x="7799832" y="5001768"/>
-            <a:ext cx="3145536" cy="502920"/>
-          </a:xfrm>
-          <a:prstGeom prst="rect">
-            <a:avLst/>
-          </a:prstGeom>
-          <a:noFill/>
-          <a:ln/>
-        </p:spPr>
-        <p:txBody>
-          <a:bodyPr wrap="square" lIns="0" tIns="0" rIns="0" bIns="0" rtlCol="0" anchor="t">
+            <a:off x="7799832" y="4974336"/>
+            <a:ext cx="3145536" cy="576072"/>
+          </a:xfrm>
+          <a:prstGeom prst="rect">
+            <a:avLst/>
+          </a:prstGeom>
+          <a:noFill/>
+          <a:ln/>
+        </p:spPr>
+        <p:txBody>
+          <a:bodyPr wrap="square" lIns="254" tIns="254" rIns="254" bIns="254" rtlCol="0" anchor="t">
             <a:normAutofit/>
           </a:bodyPr>
           <a:lstStyle/>
@@ -4424,7 +4460,7 @@
               <a:buNone/>
             </a:pPr>
             <a:r>
-              <a:rPr lang="en-US" sz="1550" dirty="0">
+              <a:rPr lang="en-US" sz="1320" dirty="0">
                 <a:solidFill>
                   <a:srgbClr val="17364A"/>
                 </a:solidFill>
@@ -4432,9 +4468,9 @@
                 <a:ea typeface="Aptos" pitchFamily="34" charset="-122"/>
                 <a:cs typeface="Aptos" pitchFamily="34" charset="-120"/>
               </a:rPr>
-              <a:t>Identify what could go wrong, who could be affected, what safeguards are needed, and what evidence should be reviewed before use expands.</a:t>
-            </a:r>
-            <a:endParaRPr lang="en-US" sz="1550" dirty="0"/>
+              <a:t>Identify what could go wrong, who could be affected, what safeguards are needed, and what evidence should be reviewed.</a:t>
+            </a:r>
+            <a:endParaRPr lang="en-US" sz="1320" dirty="0"/>
           </a:p>
         </p:txBody>
       </p:sp>
@@ -4735,49 +4771,58 @@
           <a:ln/>
         </p:spPr>
         <p:txBody>
-          <a:bodyPr wrap="square" lIns="635" tIns="635" rIns="635" bIns="635" rtlCol="0" anchor="t">
+          <a:bodyPr wrap="square" lIns="1016" tIns="1016" rIns="1016" bIns="1016" rtlCol="0" anchor="t">
             <a:normAutofit/>
           </a:bodyPr>
           <a:lstStyle/>
           <a:p>
+            <a:pPr indent="0" marL="0">
+              <a:buNone/>
+            </a:pPr>
             <a:r>
               <a:rPr lang="en-US" sz="2100" dirty="0">
                 <a:solidFill>
-                  <a:srgbClr val="17364A"/>
-                </a:solidFill>
-                <a:latin typeface="Aptos" pitchFamily="34" charset="0"/>
-                <a:ea typeface="Aptos" pitchFamily="34" charset="-122"/>
-                <a:cs typeface="Aptos" pitchFamily="34" charset="-120"/>
-              </a:rPr>
-              <a:t>Prediction used as decision.</a:t>
+                  <a:srgbClr val="003A63"/>
+                </a:solidFill>
+                <a:latin typeface="Aptos" pitchFamily="34" charset="0"/>
+                <a:ea typeface="Aptos" pitchFamily="34" charset="-122"/>
+                <a:cs typeface="Aptos" pitchFamily="34" charset="-120"/>
+              </a:rPr>
+              <a:t>• Prediction used as decision.</a:t>
             </a:r>
             <a:endParaRPr lang="en-US" sz="2100" dirty="0"/>
           </a:p>
           <a:p>
+            <a:pPr indent="0" marL="0">
+              <a:buNone/>
+            </a:pPr>
             <a:r>
               <a:rPr lang="en-US" sz="2100" dirty="0">
                 <a:solidFill>
-                  <a:srgbClr val="17364A"/>
-                </a:solidFill>
-                <a:latin typeface="Aptos" pitchFamily="34" charset="0"/>
-                <a:ea typeface="Aptos" pitchFamily="34" charset="-122"/>
-                <a:cs typeface="Aptos" pitchFamily="34" charset="-120"/>
-              </a:rPr>
-              <a:t>A risk score may be treated as a final decision rather than decision support.</a:t>
+                  <a:srgbClr val="003A63"/>
+                </a:solidFill>
+                <a:latin typeface="Aptos" pitchFamily="34" charset="0"/>
+                <a:ea typeface="Aptos" pitchFamily="34" charset="-122"/>
+                <a:cs typeface="Aptos" pitchFamily="34" charset="-120"/>
+              </a:rPr>
+              <a:t>• A risk score may be treated as a final decision rather than decision support.</a:t>
             </a:r>
             <a:endParaRPr lang="en-US" sz="2100" dirty="0"/>
           </a:p>
           <a:p>
+            <a:pPr indent="0" marL="0">
+              <a:buNone/>
+            </a:pPr>
             <a:r>
               <a:rPr lang="en-US" sz="2100" dirty="0">
                 <a:solidFill>
-                  <a:srgbClr val="17364A"/>
-                </a:solidFill>
-                <a:latin typeface="Aptos" pitchFamily="34" charset="0"/>
-                <a:ea typeface="Aptos" pitchFamily="34" charset="-122"/>
-                <a:cs typeface="Aptos" pitchFamily="34" charset="-120"/>
-              </a:rPr>
-              <a:t>Guardrails include role-based guidance, human review, and documentation of final decisions.</a:t>
+                  <a:srgbClr val="003A63"/>
+                </a:solidFill>
+                <a:latin typeface="Aptos" pitchFamily="34" charset="0"/>
+                <a:ea typeface="Aptos" pitchFamily="34" charset="-122"/>
+                <a:cs typeface="Aptos" pitchFamily="34" charset="-120"/>
+              </a:rPr>
+              <a:t>• Guardrails include role-based guidance, human review, and documentation of final decisions.</a:t>
             </a:r>
             <a:endParaRPr lang="en-US" sz="2100" dirty="0"/>
           </a:p>
@@ -4857,17 +4902,17 @@
         </p:nvSpPr>
         <p:spPr>
           <a:xfrm>
-            <a:off x="7799832" y="1828800"/>
-            <a:ext cx="3145536" cy="685800"/>
-          </a:xfrm>
-          <a:prstGeom prst="rect">
-            <a:avLst/>
-          </a:prstGeom>
-          <a:noFill/>
-          <a:ln/>
-        </p:spPr>
-        <p:txBody>
-          <a:bodyPr wrap="square" lIns="0" tIns="0" rIns="0" bIns="0" rtlCol="0" anchor="t">
+            <a:off x="7799832" y="1801368"/>
+            <a:ext cx="3145536" cy="758952"/>
+          </a:xfrm>
+          <a:prstGeom prst="rect">
+            <a:avLst/>
+          </a:prstGeom>
+          <a:noFill/>
+          <a:ln/>
+        </p:spPr>
+        <p:txBody>
+          <a:bodyPr wrap="square" lIns="254" tIns="254" rIns="254" bIns="254" rtlCol="0" anchor="t">
             <a:normAutofit/>
           </a:bodyPr>
           <a:lstStyle/>
@@ -4876,7 +4921,7 @@
               <a:buNone/>
             </a:pPr>
             <a:r>
-              <a:rPr lang="en-US" sz="1550" dirty="0">
+              <a:rPr lang="en-US" sz="1320" dirty="0">
                 <a:solidFill>
                   <a:srgbClr val="17364A"/>
                 </a:solidFill>
@@ -4886,7 +4931,7 @@
               </a:rPr>
               <a:t>Prediction used as decision.</a:t>
             </a:r>
-            <a:endParaRPr lang="en-US" sz="1550" dirty="0"/>
+            <a:endParaRPr lang="en-US" sz="1320" dirty="0"/>
           </a:p>
         </p:txBody>
       </p:sp>
@@ -4974,13 +5019,16 @@
           <a:ln/>
         </p:spPr>
         <p:txBody>
-          <a:bodyPr wrap="square" lIns="254" tIns="254" rIns="254" bIns="254" rtlCol="0" anchor="t">
+          <a:bodyPr wrap="square" lIns="508" tIns="508" rIns="508" bIns="508" rtlCol="0" anchor="t">
             <a:normAutofit/>
           </a:bodyPr>
           <a:lstStyle/>
           <a:p>
-            <a:r>
-              <a:rPr lang="en-US" sz="1380" dirty="0">
+            <a:pPr indent="0" marL="0">
+              <a:buNone/>
+            </a:pPr>
+            <a:r>
+              <a:rPr lang="en-US" sz="1220" dirty="0">
                 <a:solidFill>
                   <a:srgbClr val="17364A"/>
                 </a:solidFill>
@@ -4990,11 +5038,14 @@
               </a:rPr>
               <a:t>Equity distortion.</a:t>
             </a:r>
-            <a:endParaRPr lang="en-US" sz="1380" dirty="0"/>
-          </a:p>
-          <a:p>
-            <a:r>
-              <a:rPr lang="en-US" sz="1380" dirty="0">
+            <a:endParaRPr lang="en-US" sz="1220" dirty="0"/>
+          </a:p>
+          <a:p>
+            <a:pPr indent="0" marL="0">
+              <a:buNone/>
+            </a:pPr>
+            <a:r>
+              <a:rPr lang="en-US" sz="1220" dirty="0">
                 <a:solidFill>
                   <a:srgbClr val="17364A"/>
                 </a:solidFill>
@@ -5002,13 +5053,16 @@
                 <a:ea typeface="Aptos" pitchFamily="34" charset="-122"/>
                 <a:cs typeface="Aptos" pitchFamily="34" charset="-120"/>
               </a:rPr>
-              <a:t>Risk models may reflect unequal data availability or historical inequities.</a:t>
-            </a:r>
-            <a:endParaRPr lang="en-US" sz="1380" dirty="0"/>
-          </a:p>
-          <a:p>
-            <a:r>
-              <a:rPr lang="en-US" sz="1380" dirty="0">
+              <a:t>Risk models may reflect unequal data availability or historical.</a:t>
+            </a:r>
+            <a:endParaRPr lang="en-US" sz="1220" dirty="0"/>
+          </a:p>
+          <a:p>
+            <a:pPr indent="0" marL="0">
+              <a:buNone/>
+            </a:pPr>
+            <a:r>
+              <a:rPr lang="en-US" sz="1220" dirty="0">
                 <a:solidFill>
                   <a:srgbClr val="17364A"/>
                 </a:solidFill>
@@ -5016,9 +5070,9 @@
                 <a:ea typeface="Aptos" pitchFamily="34" charset="-122"/>
                 <a:cs typeface="Aptos" pitchFamily="34" charset="-120"/>
               </a:rPr>
-              <a:t>Guardrails include subgroup analysis, community review, and restrictions on punitive uses.</a:t>
-            </a:r>
-            <a:endParaRPr lang="en-US" sz="1380" dirty="0"/>
+              <a:t>Guardrails include subgroup analysis, community review, and.</a:t>
+            </a:r>
+            <a:endParaRPr lang="en-US" sz="1220" dirty="0"/>
           </a:p>
         </p:txBody>
       </p:sp>
@@ -5096,17 +5150,17 @@
         </p:nvSpPr>
         <p:spPr>
           <a:xfrm>
-            <a:off x="7799832" y="5001768"/>
-            <a:ext cx="3145536" cy="502920"/>
-          </a:xfrm>
-          <a:prstGeom prst="rect">
-            <a:avLst/>
-          </a:prstGeom>
-          <a:noFill/>
-          <a:ln/>
-        </p:spPr>
-        <p:txBody>
-          <a:bodyPr wrap="square" lIns="0" tIns="0" rIns="0" bIns="0" rtlCol="0" anchor="t">
+            <a:off x="7799832" y="4974336"/>
+            <a:ext cx="3145536" cy="576072"/>
+          </a:xfrm>
+          <a:prstGeom prst="rect">
+            <a:avLst/>
+          </a:prstGeom>
+          <a:noFill/>
+          <a:ln/>
+        </p:spPr>
+        <p:txBody>
+          <a:bodyPr wrap="square" lIns="254" tIns="254" rIns="254" bIns="254" rtlCol="0" anchor="t">
             <a:normAutofit/>
           </a:bodyPr>
           <a:lstStyle/>
@@ -5115,7 +5169,7 @@
               <a:buNone/>
             </a:pPr>
             <a:r>
-              <a:rPr lang="en-US" sz="1550" dirty="0">
+              <a:rPr lang="en-US" sz="1320" dirty="0">
                 <a:solidFill>
                   <a:srgbClr val="17364A"/>
                 </a:solidFill>
@@ -5123,9 +5177,9 @@
                 <a:ea typeface="Aptos" pitchFamily="34" charset="-122"/>
                 <a:cs typeface="Aptos" pitchFamily="34" charset="-120"/>
               </a:rPr>
-              <a:t>Identify what could go wrong, who could be affected, what safeguards are needed, and what evidence should be reviewed before use expands.</a:t>
-            </a:r>
-            <a:endParaRPr lang="en-US" sz="1550" dirty="0"/>
+              <a:t>Identify what could go wrong, who could be affected, what safeguards are needed, and what evidence should be reviewed.</a:t>
+            </a:r>
+            <a:endParaRPr lang="en-US" sz="1320" dirty="0"/>
           </a:p>
         </p:txBody>
       </p:sp>
@@ -5426,49 +5480,58 @@
           <a:ln/>
         </p:spPr>
         <p:txBody>
-          <a:bodyPr wrap="square" lIns="635" tIns="635" rIns="635" bIns="635" rtlCol="0" anchor="t">
+          <a:bodyPr wrap="square" lIns="1016" tIns="1016" rIns="1016" bIns="1016" rtlCol="0" anchor="t">
             <a:normAutofit/>
           </a:bodyPr>
           <a:lstStyle/>
           <a:p>
+            <a:pPr indent="0" marL="0">
+              <a:buNone/>
+            </a:pPr>
             <a:r>
               <a:rPr lang="en-US" sz="2100" dirty="0">
                 <a:solidFill>
-                  <a:srgbClr val="17364A"/>
-                </a:solidFill>
-                <a:latin typeface="Aptos" pitchFamily="34" charset="0"/>
-                <a:ea typeface="Aptos" pitchFamily="34" charset="-122"/>
-                <a:cs typeface="Aptos" pitchFamily="34" charset="-120"/>
-              </a:rPr>
-              <a:t>Model drift.</a:t>
+                  <a:srgbClr val="003A63"/>
+                </a:solidFill>
+                <a:latin typeface="Aptos" pitchFamily="34" charset="0"/>
+                <a:ea typeface="Aptos" pitchFamily="34" charset="-122"/>
+                <a:cs typeface="Aptos" pitchFamily="34" charset="-120"/>
+              </a:rPr>
+              <a:t>• Model drift.</a:t>
             </a:r>
             <a:endParaRPr lang="en-US" sz="2100" dirty="0"/>
           </a:p>
           <a:p>
+            <a:pPr indent="0" marL="0">
+              <a:buNone/>
+            </a:pPr>
             <a:r>
               <a:rPr lang="en-US" sz="2100" dirty="0">
                 <a:solidFill>
-                  <a:srgbClr val="17364A"/>
-                </a:solidFill>
-                <a:latin typeface="Aptos" pitchFamily="34" charset="0"/>
-                <a:ea typeface="Aptos" pitchFamily="34" charset="-122"/>
-                <a:cs typeface="Aptos" pitchFamily="34" charset="-120"/>
-              </a:rPr>
-              <a:t>Performance may change over time.</a:t>
+                  <a:srgbClr val="003A63"/>
+                </a:solidFill>
+                <a:latin typeface="Aptos" pitchFamily="34" charset="0"/>
+                <a:ea typeface="Aptos" pitchFamily="34" charset="-122"/>
+                <a:cs typeface="Aptos" pitchFamily="34" charset="-120"/>
+              </a:rPr>
+              <a:t>• Performance may change over time.</a:t>
             </a:r>
             <a:endParaRPr lang="en-US" sz="2100" dirty="0"/>
           </a:p>
           <a:p>
+            <a:pPr indent="0" marL="0">
+              <a:buNone/>
+            </a:pPr>
             <a:r>
               <a:rPr lang="en-US" sz="2100" dirty="0">
                 <a:solidFill>
-                  <a:srgbClr val="17364A"/>
-                </a:solidFill>
-                <a:latin typeface="Aptos" pitchFamily="34" charset="0"/>
-                <a:ea typeface="Aptos" pitchFamily="34" charset="-122"/>
-                <a:cs typeface="Aptos" pitchFamily="34" charset="-120"/>
-              </a:rPr>
-              <a:t>Guardrails include periodic recalibration, drift monitoring, and authority to pause or modify use.</a:t>
+                  <a:srgbClr val="003A63"/>
+                </a:solidFill>
+                <a:latin typeface="Aptos" pitchFamily="34" charset="0"/>
+                <a:ea typeface="Aptos" pitchFamily="34" charset="-122"/>
+                <a:cs typeface="Aptos" pitchFamily="34" charset="-120"/>
+              </a:rPr>
+              <a:t>• Guardrails include periodic recalibration, drift monitoring, and authority to pause or modify.</a:t>
             </a:r>
             <a:endParaRPr lang="en-US" sz="2100" dirty="0"/>
           </a:p>
@@ -5548,17 +5611,17 @@
         </p:nvSpPr>
         <p:spPr>
           <a:xfrm>
-            <a:off x="7799832" y="1828800"/>
-            <a:ext cx="3145536" cy="685800"/>
-          </a:xfrm>
-          <a:prstGeom prst="rect">
-            <a:avLst/>
-          </a:prstGeom>
-          <a:noFill/>
-          <a:ln/>
-        </p:spPr>
-        <p:txBody>
-          <a:bodyPr wrap="square" lIns="0" tIns="0" rIns="0" bIns="0" rtlCol="0" anchor="t">
+            <a:off x="7799832" y="1801368"/>
+            <a:ext cx="3145536" cy="758952"/>
+          </a:xfrm>
+          <a:prstGeom prst="rect">
+            <a:avLst/>
+          </a:prstGeom>
+          <a:noFill/>
+          <a:ln/>
+        </p:spPr>
+        <p:txBody>
+          <a:bodyPr wrap="square" lIns="254" tIns="254" rIns="254" bIns="254" rtlCol="0" anchor="t">
             <a:normAutofit/>
           </a:bodyPr>
           <a:lstStyle/>
@@ -5567,7 +5630,7 @@
               <a:buNone/>
             </a:pPr>
             <a:r>
-              <a:rPr lang="en-US" sz="1550" dirty="0">
+              <a:rPr lang="en-US" sz="1320" dirty="0">
                 <a:solidFill>
                   <a:srgbClr val="17364A"/>
                 </a:solidFill>
@@ -5577,7 +5640,7 @@
               </a:rPr>
               <a:t>Model drift.</a:t>
             </a:r>
-            <a:endParaRPr lang="en-US" sz="1550" dirty="0"/>
+            <a:endParaRPr lang="en-US" sz="1320" dirty="0"/>
           </a:p>
         </p:txBody>
       </p:sp>
@@ -5665,13 +5728,16 @@
           <a:ln/>
         </p:spPr>
         <p:txBody>
-          <a:bodyPr wrap="square" lIns="254" tIns="254" rIns="254" bIns="254" rtlCol="0" anchor="t">
+          <a:bodyPr wrap="square" lIns="508" tIns="508" rIns="508" bIns="508" rtlCol="0" anchor="t">
             <a:normAutofit/>
           </a:bodyPr>
           <a:lstStyle/>
           <a:p>
-            <a:r>
-              <a:rPr lang="en-US" sz="1380" dirty="0">
+            <a:pPr indent="0" marL="0">
+              <a:buNone/>
+            </a:pPr>
+            <a:r>
+              <a:rPr lang="en-US" sz="1220" dirty="0">
                 <a:solidFill>
                   <a:srgbClr val="17364A"/>
                 </a:solidFill>
@@ -5681,11 +5747,14 @@
               </a:rPr>
               <a:t>Model drift.</a:t>
             </a:r>
-            <a:endParaRPr lang="en-US" sz="1380" dirty="0"/>
-          </a:p>
-          <a:p>
-            <a:r>
-              <a:rPr lang="en-US" sz="1380" dirty="0">
+            <a:endParaRPr lang="en-US" sz="1220" dirty="0"/>
+          </a:p>
+          <a:p>
+            <a:pPr indent="0" marL="0">
+              <a:buNone/>
+            </a:pPr>
+            <a:r>
+              <a:rPr lang="en-US" sz="1220" dirty="0">
                 <a:solidFill>
                   <a:srgbClr val="17364A"/>
                 </a:solidFill>
@@ -5695,11 +5764,14 @@
               </a:rPr>
               <a:t>Performance may change over time.</a:t>
             </a:r>
-            <a:endParaRPr lang="en-US" sz="1380" dirty="0"/>
-          </a:p>
-          <a:p>
-            <a:r>
-              <a:rPr lang="en-US" sz="1380" dirty="0">
+            <a:endParaRPr lang="en-US" sz="1220" dirty="0"/>
+          </a:p>
+          <a:p>
+            <a:pPr indent="0" marL="0">
+              <a:buNone/>
+            </a:pPr>
+            <a:r>
+              <a:rPr lang="en-US" sz="1220" dirty="0">
                 <a:solidFill>
                   <a:srgbClr val="17364A"/>
                 </a:solidFill>
@@ -5707,9 +5779,9 @@
                 <a:ea typeface="Aptos" pitchFamily="34" charset="-122"/>
                 <a:cs typeface="Aptos" pitchFamily="34" charset="-120"/>
               </a:rPr>
-              <a:t>Guardrails include periodic recalibration, drift monitoring, and authority to pause or.</a:t>
-            </a:r>
-            <a:endParaRPr lang="en-US" sz="1380" dirty="0"/>
+              <a:t>Guardrails include periodic recalibration, drift monitoring, and.</a:t>
+            </a:r>
+            <a:endParaRPr lang="en-US" sz="1220" dirty="0"/>
           </a:p>
         </p:txBody>
       </p:sp>
@@ -5787,17 +5859,17 @@
         </p:nvSpPr>
         <p:spPr>
           <a:xfrm>
-            <a:off x="7799832" y="5001768"/>
-            <a:ext cx="3145536" cy="502920"/>
-          </a:xfrm>
-          <a:prstGeom prst="rect">
-            <a:avLst/>
-          </a:prstGeom>
-          <a:noFill/>
-          <a:ln/>
-        </p:spPr>
-        <p:txBody>
-          <a:bodyPr wrap="square" lIns="0" tIns="0" rIns="0" bIns="0" rtlCol="0" anchor="t">
+            <a:off x="7799832" y="4974336"/>
+            <a:ext cx="3145536" cy="576072"/>
+          </a:xfrm>
+          <a:prstGeom prst="rect">
+            <a:avLst/>
+          </a:prstGeom>
+          <a:noFill/>
+          <a:ln/>
+        </p:spPr>
+        <p:txBody>
+          <a:bodyPr wrap="square" lIns="254" tIns="254" rIns="254" bIns="254" rtlCol="0" anchor="t">
             <a:normAutofit/>
           </a:bodyPr>
           <a:lstStyle/>
@@ -5806,7 +5878,7 @@
               <a:buNone/>
             </a:pPr>
             <a:r>
-              <a:rPr lang="en-US" sz="1550" dirty="0">
+              <a:rPr lang="en-US" sz="1320" dirty="0">
                 <a:solidFill>
                   <a:srgbClr val="17364A"/>
                 </a:solidFill>
@@ -5814,9 +5886,9 @@
                 <a:ea typeface="Aptos" pitchFamily="34" charset="-122"/>
                 <a:cs typeface="Aptos" pitchFamily="34" charset="-120"/>
               </a:rPr>
-              <a:t>Identify what could go wrong, who could be affected, what safeguards are needed, and what evidence should be reviewed before use expands.</a:t>
-            </a:r>
-            <a:endParaRPr lang="en-US" sz="1550" dirty="0"/>
+              <a:t>Identify what could go wrong, who could be affected, what safeguards are needed, and what evidence should be reviewed.</a:t>
+            </a:r>
+            <a:endParaRPr lang="en-US" sz="1320" dirty="0"/>
           </a:p>
         </p:txBody>
       </p:sp>
@@ -6117,49 +6189,58 @@
           <a:ln/>
         </p:spPr>
         <p:txBody>
-          <a:bodyPr wrap="square" lIns="635" tIns="635" rIns="635" bIns="635" rtlCol="0" anchor="t">
+          <a:bodyPr wrap="square" lIns="1016" tIns="1016" rIns="1016" bIns="1016" rtlCol="0" anchor="t">
             <a:normAutofit/>
           </a:bodyPr>
           <a:lstStyle/>
           <a:p>
+            <a:pPr indent="0" marL="0">
+              <a:buNone/>
+            </a:pPr>
             <a:r>
               <a:rPr lang="en-US" sz="2100" dirty="0">
                 <a:solidFill>
-                  <a:srgbClr val="17364A"/>
-                </a:solidFill>
-                <a:latin typeface="Aptos" pitchFamily="34" charset="0"/>
-                <a:ea typeface="Aptos" pitchFamily="34" charset="-122"/>
-                <a:cs typeface="Aptos" pitchFamily="34" charset="-120"/>
-              </a:rPr>
-              <a:t>Predictive analytics may be embedded in dashboards, case management systems, early warning tools,.</a:t>
+                  <a:srgbClr val="003A63"/>
+                </a:solidFill>
+                <a:latin typeface="Aptos" pitchFamily="34" charset="0"/>
+                <a:ea typeface="Aptos" pitchFamily="34" charset="-122"/>
+                <a:cs typeface="Aptos" pitchFamily="34" charset="-120"/>
+              </a:rPr>
+              <a:t>• Predictive analytics may be embedded in dashboards, case management systems, early warning.</a:t>
             </a:r>
             <a:endParaRPr lang="en-US" sz="2100" dirty="0"/>
           </a:p>
           <a:p>
+            <a:pPr indent="0" marL="0">
+              <a:buNone/>
+            </a:pPr>
             <a:r>
               <a:rPr lang="en-US" sz="2100" dirty="0">
                 <a:solidFill>
-                  <a:srgbClr val="17364A"/>
-                </a:solidFill>
-                <a:latin typeface="Aptos" pitchFamily="34" charset="0"/>
-                <a:ea typeface="Aptos" pitchFamily="34" charset="-122"/>
-                <a:cs typeface="Aptos" pitchFamily="34" charset="-120"/>
-              </a:rPr>
-              <a:t>Generative AI may explain or summarize predictive outputs, but those explanations must not imply.</a:t>
+                  <a:srgbClr val="003A63"/>
+                </a:solidFill>
+                <a:latin typeface="Aptos" pitchFamily="34" charset="0"/>
+                <a:ea typeface="Aptos" pitchFamily="34" charset="-122"/>
+                <a:cs typeface="Aptos" pitchFamily="34" charset="-120"/>
+              </a:rPr>
+              <a:t>• Generative AI may explain or summarize predictive outputs, but those explanations must not.</a:t>
             </a:r>
             <a:endParaRPr lang="en-US" sz="2100" dirty="0"/>
           </a:p>
           <a:p>
+            <a:pPr indent="0" marL="0">
+              <a:buNone/>
+            </a:pPr>
             <a:r>
               <a:rPr lang="en-US" sz="2100" dirty="0">
                 <a:solidFill>
-                  <a:srgbClr val="17364A"/>
-                </a:solidFill>
-                <a:latin typeface="Aptos" pitchFamily="34" charset="0"/>
-                <a:ea typeface="Aptos" pitchFamily="34" charset="-122"/>
-                <a:cs typeface="Aptos" pitchFamily="34" charset="-120"/>
-              </a:rPr>
-              <a:t>RAG systems may combine risk results with policy guidance, while agentic workflows may trigger tasks or.</a:t>
+                  <a:srgbClr val="003A63"/>
+                </a:solidFill>
+                <a:latin typeface="Aptos" pitchFamily="34" charset="0"/>
+                <a:ea typeface="Aptos" pitchFamily="34" charset="-122"/>
+                <a:cs typeface="Aptos" pitchFamily="34" charset="-120"/>
+              </a:rPr>
+              <a:t>• RAG systems may combine risk results with policy guidance, while agentic workflows may trigger.</a:t>
             </a:r>
             <a:endParaRPr lang="en-US" sz="2100" dirty="0"/>
           </a:p>
@@ -6239,17 +6320,17 @@
         </p:nvSpPr>
         <p:spPr>
           <a:xfrm>
-            <a:off x="7799832" y="1828800"/>
-            <a:ext cx="3145536" cy="685800"/>
-          </a:xfrm>
-          <a:prstGeom prst="rect">
-            <a:avLst/>
-          </a:prstGeom>
-          <a:noFill/>
-          <a:ln/>
-        </p:spPr>
-        <p:txBody>
-          <a:bodyPr wrap="square" lIns="0" tIns="0" rIns="0" bIns="0" rtlCol="0" anchor="t">
+            <a:off x="7799832" y="1801368"/>
+            <a:ext cx="3145536" cy="758952"/>
+          </a:xfrm>
+          <a:prstGeom prst="rect">
+            <a:avLst/>
+          </a:prstGeom>
+          <a:noFill/>
+          <a:ln/>
+        </p:spPr>
+        <p:txBody>
+          <a:bodyPr wrap="square" lIns="254" tIns="254" rIns="254" bIns="254" rtlCol="0" anchor="t">
             <a:normAutofit/>
           </a:bodyPr>
           <a:lstStyle/>
@@ -6258,7 +6339,7 @@
               <a:buNone/>
             </a:pPr>
             <a:r>
-              <a:rPr lang="en-US" sz="1550" dirty="0">
+              <a:rPr lang="en-US" sz="1320" dirty="0">
                 <a:solidFill>
                   <a:srgbClr val="17364A"/>
                 </a:solidFill>
@@ -6268,7 +6349,7 @@
               </a:rPr>
               <a:t>Predictive analytics may be embedded in dashboards, case management systems, early warning tools,.</a:t>
             </a:r>
-            <a:endParaRPr lang="en-US" sz="1550" dirty="0"/>
+            <a:endParaRPr lang="en-US" sz="1320" dirty="0"/>
           </a:p>
         </p:txBody>
       </p:sp>
@@ -6356,13 +6437,16 @@
           <a:ln/>
         </p:spPr>
         <p:txBody>
-          <a:bodyPr wrap="square" lIns="254" tIns="254" rIns="254" bIns="254" rtlCol="0" anchor="t">
+          <a:bodyPr wrap="square" lIns="508" tIns="508" rIns="508" bIns="508" rtlCol="0" anchor="t">
             <a:normAutofit/>
           </a:bodyPr>
           <a:lstStyle/>
           <a:p>
-            <a:r>
-              <a:rPr lang="en-US" sz="1380" dirty="0">
+            <a:pPr indent="0" marL="0">
+              <a:buNone/>
+            </a:pPr>
+            <a:r>
+              <a:rPr lang="en-US" sz="1220" dirty="0">
                 <a:solidFill>
                   <a:srgbClr val="17364A"/>
                 </a:solidFill>
@@ -6370,13 +6454,16 @@
                 <a:ea typeface="Aptos" pitchFamily="34" charset="-122"/>
                 <a:cs typeface="Aptos" pitchFamily="34" charset="-120"/>
               </a:rPr>
-              <a:t>Predictive analytics may be embedded in dashboards, case management systems, early warning.</a:t>
-            </a:r>
-            <a:endParaRPr lang="en-US" sz="1380" dirty="0"/>
-          </a:p>
-          <a:p>
-            <a:r>
-              <a:rPr lang="en-US" sz="1380" dirty="0">
+              <a:t>Predictive analytics may be embedded in dashboards, case.</a:t>
+            </a:r>
+            <a:endParaRPr lang="en-US" sz="1220" dirty="0"/>
+          </a:p>
+          <a:p>
+            <a:pPr indent="0" marL="0">
+              <a:buNone/>
+            </a:pPr>
+            <a:r>
+              <a:rPr lang="en-US" sz="1220" dirty="0">
                 <a:solidFill>
                   <a:srgbClr val="17364A"/>
                 </a:solidFill>
@@ -6384,13 +6471,16 @@
                 <a:ea typeface="Aptos" pitchFamily="34" charset="-122"/>
                 <a:cs typeface="Aptos" pitchFamily="34" charset="-120"/>
               </a:rPr>
-              <a:t>Generative AI may explain or summarize predictive outputs, but those explanations must not.</a:t>
-            </a:r>
-            <a:endParaRPr lang="en-US" sz="1380" dirty="0"/>
-          </a:p>
-          <a:p>
-            <a:r>
-              <a:rPr lang="en-US" sz="1380" dirty="0">
+              <a:t>Generative AI may explain or summarize predictive outputs, but.</a:t>
+            </a:r>
+            <a:endParaRPr lang="en-US" sz="1220" dirty="0"/>
+          </a:p>
+          <a:p>
+            <a:pPr indent="0" marL="0">
+              <a:buNone/>
+            </a:pPr>
+            <a:r>
+              <a:rPr lang="en-US" sz="1220" dirty="0">
                 <a:solidFill>
                   <a:srgbClr val="17364A"/>
                 </a:solidFill>
@@ -6398,9 +6488,9 @@
                 <a:ea typeface="Aptos" pitchFamily="34" charset="-122"/>
                 <a:cs typeface="Aptos" pitchFamily="34" charset="-120"/>
               </a:rPr>
-              <a:t>RAG systems may combine risk results with policy guidance, while agentic workflows may.</a:t>
-            </a:r>
-            <a:endParaRPr lang="en-US" sz="1380" dirty="0"/>
+              <a:t>RAG systems may combine risk results with policy guidance, while.</a:t>
+            </a:r>
+            <a:endParaRPr lang="en-US" sz="1220" dirty="0"/>
           </a:p>
         </p:txBody>
       </p:sp>
@@ -6478,17 +6568,17 @@
         </p:nvSpPr>
         <p:spPr>
           <a:xfrm>
-            <a:off x="7799832" y="5001768"/>
-            <a:ext cx="3145536" cy="502920"/>
-          </a:xfrm>
-          <a:prstGeom prst="rect">
-            <a:avLst/>
-          </a:prstGeom>
-          <a:noFill/>
-          <a:ln/>
-        </p:spPr>
-        <p:txBody>
-          <a:bodyPr wrap="square" lIns="0" tIns="0" rIns="0" bIns="0" rtlCol="0" anchor="t">
+            <a:off x="7799832" y="4974336"/>
+            <a:ext cx="3145536" cy="576072"/>
+          </a:xfrm>
+          <a:prstGeom prst="rect">
+            <a:avLst/>
+          </a:prstGeom>
+          <a:noFill/>
+          <a:ln/>
+        </p:spPr>
+        <p:txBody>
+          <a:bodyPr wrap="square" lIns="254" tIns="254" rIns="254" bIns="254" rtlCol="0" anchor="t">
             <a:normAutofit/>
           </a:bodyPr>
           <a:lstStyle/>
@@ -6497,7 +6587,7 @@
               <a:buNone/>
             </a:pPr>
             <a:r>
-              <a:rPr lang="en-US" sz="1550" dirty="0">
+              <a:rPr lang="en-US" sz="1320" dirty="0">
                 <a:solidFill>
                   <a:srgbClr val="17364A"/>
                 </a:solidFill>
@@ -6505,9 +6595,9 @@
                 <a:ea typeface="Aptos" pitchFamily="34" charset="-122"/>
                 <a:cs typeface="Aptos" pitchFamily="34" charset="-120"/>
               </a:rPr>
-              <a:t>Identify what could go wrong, who could be affected, what safeguards are needed, and what evidence should be reviewed before use expands.</a:t>
-            </a:r>
-            <a:endParaRPr lang="en-US" sz="1550" dirty="0"/>
+              <a:t>Identify what could go wrong, who could be affected, what safeguards are needed, and what evidence should be reviewed.</a:t>
+            </a:r>
+            <a:endParaRPr lang="en-US" sz="1320" dirty="0"/>
           </a:p>
         </p:txBody>
       </p:sp>
@@ -6808,49 +6898,58 @@
           <a:ln/>
         </p:spPr>
         <p:txBody>
-          <a:bodyPr wrap="square" lIns="635" tIns="635" rIns="635" bIns="635" rtlCol="0" anchor="t">
+          <a:bodyPr wrap="square" lIns="1016" tIns="1016" rIns="1016" bIns="1016" rtlCol="0" anchor="t">
             <a:normAutofit/>
           </a:bodyPr>
           <a:lstStyle/>
           <a:p>
+            <a:pPr indent="0" marL="0">
+              <a:buNone/>
+            </a:pPr>
             <a:r>
               <a:rPr lang="en-US" sz="2100" dirty="0">
                 <a:solidFill>
-                  <a:srgbClr val="17364A"/>
-                </a:solidFill>
-                <a:latin typeface="Aptos" pitchFamily="34" charset="0"/>
-                <a:ea typeface="Aptos" pitchFamily="34" charset="-122"/>
-                <a:cs typeface="Aptos" pitchFamily="34" charset="-120"/>
-              </a:rPr>
-              <a:t>What outcome is being predicted, and over what time period?</a:t>
+                  <a:srgbClr val="003A63"/>
+                </a:solidFill>
+                <a:latin typeface="Aptos" pitchFamily="34" charset="0"/>
+                <a:ea typeface="Aptos" pitchFamily="34" charset="-122"/>
+                <a:cs typeface="Aptos" pitchFamily="34" charset="-120"/>
+              </a:rPr>
+              <a:t>• What outcome is being predicted, and over what time period?</a:t>
             </a:r>
             <a:endParaRPr lang="en-US" sz="2100" dirty="0"/>
           </a:p>
           <a:p>
+            <a:pPr indent="0" marL="0">
+              <a:buNone/>
+            </a:pPr>
             <a:r>
               <a:rPr lang="en-US" sz="2100" dirty="0">
                 <a:solidFill>
-                  <a:srgbClr val="17364A"/>
-                </a:solidFill>
-                <a:latin typeface="Aptos" pitchFamily="34" charset="0"/>
-                <a:ea typeface="Aptos" pitchFamily="34" charset="-122"/>
-                <a:cs typeface="Aptos" pitchFamily="34" charset="-120"/>
-              </a:rPr>
-              <a:t>What public health action will follow a high-risk score?</a:t>
+                  <a:srgbClr val="003A63"/>
+                </a:solidFill>
+                <a:latin typeface="Aptos" pitchFamily="34" charset="0"/>
+                <a:ea typeface="Aptos" pitchFamily="34" charset="-122"/>
+                <a:cs typeface="Aptos" pitchFamily="34" charset="-120"/>
+              </a:rPr>
+              <a:t>• What public health action will follow a high-risk score?</a:t>
             </a:r>
             <a:endParaRPr lang="en-US" sz="2100" dirty="0"/>
           </a:p>
           <a:p>
+            <a:pPr indent="0" marL="0">
+              <a:buNone/>
+            </a:pPr>
             <a:r>
               <a:rPr lang="en-US" sz="2100" dirty="0">
                 <a:solidFill>
-                  <a:srgbClr val="17364A"/>
-                </a:solidFill>
-                <a:latin typeface="Aptos" pitchFamily="34" charset="0"/>
-                <a:ea typeface="Aptos" pitchFamily="34" charset="-122"/>
-                <a:cs typeface="Aptos" pitchFamily="34" charset="-120"/>
-              </a:rPr>
-              <a:t>Which data sources may underrepresent some populations?</a:t>
+                  <a:srgbClr val="003A63"/>
+                </a:solidFill>
+                <a:latin typeface="Aptos" pitchFamily="34" charset="0"/>
+                <a:ea typeface="Aptos" pitchFamily="34" charset="-122"/>
+                <a:cs typeface="Aptos" pitchFamily="34" charset="-120"/>
+              </a:rPr>
+              <a:t>• Which data sources may underrepresent some populations?</a:t>
             </a:r>
             <a:endParaRPr lang="en-US" sz="2100" dirty="0"/>
           </a:p>
@@ -6930,17 +7029,17 @@
         </p:nvSpPr>
         <p:spPr>
           <a:xfrm>
-            <a:off x="7799832" y="1828800"/>
-            <a:ext cx="3145536" cy="685800"/>
-          </a:xfrm>
-          <a:prstGeom prst="rect">
-            <a:avLst/>
-          </a:prstGeom>
-          <a:noFill/>
-          <a:ln/>
-        </p:spPr>
-        <p:txBody>
-          <a:bodyPr wrap="square" lIns="0" tIns="0" rIns="0" bIns="0" rtlCol="0" anchor="t">
+            <a:off x="7799832" y="1801368"/>
+            <a:ext cx="3145536" cy="758952"/>
+          </a:xfrm>
+          <a:prstGeom prst="rect">
+            <a:avLst/>
+          </a:prstGeom>
+          <a:noFill/>
+          <a:ln/>
+        </p:spPr>
+        <p:txBody>
+          <a:bodyPr wrap="square" lIns="254" tIns="254" rIns="254" bIns="254" rtlCol="0" anchor="t">
             <a:normAutofit/>
           </a:bodyPr>
           <a:lstStyle/>
@@ -6949,7 +7048,7 @@
               <a:buNone/>
             </a:pPr>
             <a:r>
-              <a:rPr lang="en-US" sz="1550" dirty="0">
+              <a:rPr lang="en-US" sz="1320" dirty="0">
                 <a:solidFill>
                   <a:srgbClr val="17364A"/>
                 </a:solidFill>
@@ -6959,7 +7058,7 @@
               </a:rPr>
               <a:t>What outcome is being predicted, and over what time period?</a:t>
             </a:r>
-            <a:endParaRPr lang="en-US" sz="1550" dirty="0"/>
+            <a:endParaRPr lang="en-US" sz="1320" dirty="0"/>
           </a:p>
         </p:txBody>
       </p:sp>
@@ -7047,13 +7146,16 @@
           <a:ln/>
         </p:spPr>
         <p:txBody>
-          <a:bodyPr wrap="square" lIns="254" tIns="254" rIns="254" bIns="254" rtlCol="0" anchor="t">
+          <a:bodyPr wrap="square" lIns="508" tIns="508" rIns="508" bIns="508" rtlCol="0" anchor="t">
             <a:normAutofit/>
           </a:bodyPr>
           <a:lstStyle/>
           <a:p>
-            <a:r>
-              <a:rPr lang="en-US" sz="1380" dirty="0">
+            <a:pPr indent="0" marL="0">
+              <a:buNone/>
+            </a:pPr>
+            <a:r>
+              <a:rPr lang="en-US" sz="1220" dirty="0">
                 <a:solidFill>
                   <a:srgbClr val="17364A"/>
                 </a:solidFill>
@@ -7063,11 +7165,14 @@
               </a:rPr>
               <a:t>What outcome is being predicted, and over what time period?</a:t>
             </a:r>
-            <a:endParaRPr lang="en-US" sz="1380" dirty="0"/>
-          </a:p>
-          <a:p>
-            <a:r>
-              <a:rPr lang="en-US" sz="1380" dirty="0">
+            <a:endParaRPr lang="en-US" sz="1220" dirty="0"/>
+          </a:p>
+          <a:p>
+            <a:pPr indent="0" marL="0">
+              <a:buNone/>
+            </a:pPr>
+            <a:r>
+              <a:rPr lang="en-US" sz="1220" dirty="0">
                 <a:solidFill>
                   <a:srgbClr val="17364A"/>
                 </a:solidFill>
@@ -7077,11 +7182,14 @@
               </a:rPr>
               <a:t>What public health action will follow a high-risk score?</a:t>
             </a:r>
-            <a:endParaRPr lang="en-US" sz="1380" dirty="0"/>
-          </a:p>
-          <a:p>
-            <a:r>
-              <a:rPr lang="en-US" sz="1380" dirty="0">
+            <a:endParaRPr lang="en-US" sz="1220" dirty="0"/>
+          </a:p>
+          <a:p>
+            <a:pPr indent="0" marL="0">
+              <a:buNone/>
+            </a:pPr>
+            <a:r>
+              <a:rPr lang="en-US" sz="1220" dirty="0">
                 <a:solidFill>
                   <a:srgbClr val="17364A"/>
                 </a:solidFill>
@@ -7091,7 +7199,7 @@
               </a:rPr>
               <a:t>Which data sources may underrepresent some populations?</a:t>
             </a:r>
-            <a:endParaRPr lang="en-US" sz="1380" dirty="0"/>
+            <a:endParaRPr lang="en-US" sz="1220" dirty="0"/>
           </a:p>
         </p:txBody>
       </p:sp>
@@ -7169,17 +7277,17 @@
         </p:nvSpPr>
         <p:spPr>
           <a:xfrm>
-            <a:off x="7799832" y="5001768"/>
-            <a:ext cx="3145536" cy="502920"/>
-          </a:xfrm>
-          <a:prstGeom prst="rect">
-            <a:avLst/>
-          </a:prstGeom>
-          <a:noFill/>
-          <a:ln/>
-        </p:spPr>
-        <p:txBody>
-          <a:bodyPr wrap="square" lIns="0" tIns="0" rIns="0" bIns="0" rtlCol="0" anchor="t">
+            <a:off x="7799832" y="4974336"/>
+            <a:ext cx="3145536" cy="576072"/>
+          </a:xfrm>
+          <a:prstGeom prst="rect">
+            <a:avLst/>
+          </a:prstGeom>
+          <a:noFill/>
+          <a:ln/>
+        </p:spPr>
+        <p:txBody>
+          <a:bodyPr wrap="square" lIns="254" tIns="254" rIns="254" bIns="254" rtlCol="0" anchor="t">
             <a:normAutofit/>
           </a:bodyPr>
           <a:lstStyle/>
@@ -7188,7 +7296,7 @@
               <a:buNone/>
             </a:pPr>
             <a:r>
-              <a:rPr lang="en-US" sz="1550" dirty="0">
+              <a:rPr lang="en-US" sz="1320" dirty="0">
                 <a:solidFill>
                   <a:srgbClr val="17364A"/>
                 </a:solidFill>
@@ -7196,9 +7304,9 @@
                 <a:ea typeface="Aptos" pitchFamily="34" charset="-122"/>
                 <a:cs typeface="Aptos" pitchFamily="34" charset="-120"/>
               </a:rPr>
-              <a:t>Identify what could go wrong, who could be affected, what safeguards are needed, and what evidence should be reviewed before use expands.</a:t>
-            </a:r>
-            <a:endParaRPr lang="en-US" sz="1550" dirty="0"/>
+              <a:t>Identify what could go wrong, who could be affected, what safeguards are needed, and what evidence should be reviewed.</a:t>
+            </a:r>
+            <a:endParaRPr lang="en-US" sz="1320" dirty="0"/>
           </a:p>
         </p:txBody>
       </p:sp>
@@ -7499,35 +7607,41 @@
           <a:ln/>
         </p:spPr>
         <p:txBody>
-          <a:bodyPr wrap="square" lIns="635" tIns="635" rIns="635" bIns="635" rtlCol="0" anchor="t">
+          <a:bodyPr wrap="square" lIns="1016" tIns="1016" rIns="1016" bIns="1016" rtlCol="0" anchor="t">
             <a:normAutofit/>
           </a:bodyPr>
           <a:lstStyle/>
           <a:p>
+            <a:pPr indent="0" marL="0">
+              <a:buNone/>
+            </a:pPr>
             <a:r>
               <a:rPr lang="en-US" sz="2100" dirty="0">
                 <a:solidFill>
-                  <a:srgbClr val="17364A"/>
-                </a:solidFill>
-                <a:latin typeface="Aptos" pitchFamily="34" charset="0"/>
-                <a:ea typeface="Aptos" pitchFamily="34" charset="-122"/>
-                <a:cs typeface="Aptos" pitchFamily="34" charset="-120"/>
-              </a:rPr>
-              <a:t>What are the consequences of false positives and false negatives?</a:t>
+                  <a:srgbClr val="003A63"/>
+                </a:solidFill>
+                <a:latin typeface="Aptos" pitchFamily="34" charset="0"/>
+                <a:ea typeface="Aptos" pitchFamily="34" charset="-122"/>
+                <a:cs typeface="Aptos" pitchFamily="34" charset="-120"/>
+              </a:rPr>
+              <a:t>• What are the consequences of false positives and false negatives?</a:t>
             </a:r>
             <a:endParaRPr lang="en-US" sz="2100" dirty="0"/>
           </a:p>
           <a:p>
+            <a:pPr indent="0" marL="0">
+              <a:buNone/>
+            </a:pPr>
             <a:r>
               <a:rPr lang="en-US" sz="2100" dirty="0">
                 <a:solidFill>
-                  <a:srgbClr val="17364A"/>
-                </a:solidFill>
-                <a:latin typeface="Aptos" pitchFamily="34" charset="0"/>
-                <a:ea typeface="Aptos" pitchFamily="34" charset="-122"/>
-                <a:cs typeface="Aptos" pitchFamily="34" charset="-120"/>
-              </a:rPr>
-              <a:t>How will thresholds, calibration, and subgroup performance be monitored?</a:t>
+                  <a:srgbClr val="003A63"/>
+                </a:solidFill>
+                <a:latin typeface="Aptos" pitchFamily="34" charset="0"/>
+                <a:ea typeface="Aptos" pitchFamily="34" charset="-122"/>
+                <a:cs typeface="Aptos" pitchFamily="34" charset="-120"/>
+              </a:rPr>
+              <a:t>• How will thresholds, calibration, and subgroup performance be monitored?</a:t>
             </a:r>
             <a:endParaRPr lang="en-US" sz="2100" dirty="0"/>
           </a:p>
@@ -7607,17 +7721,17 @@
         </p:nvSpPr>
         <p:spPr>
           <a:xfrm>
-            <a:off x="7799832" y="1828800"/>
-            <a:ext cx="3145536" cy="685800"/>
-          </a:xfrm>
-          <a:prstGeom prst="rect">
-            <a:avLst/>
-          </a:prstGeom>
-          <a:noFill/>
-          <a:ln/>
-        </p:spPr>
-        <p:txBody>
-          <a:bodyPr wrap="square" lIns="0" tIns="0" rIns="0" bIns="0" rtlCol="0" anchor="t">
+            <a:off x="7799832" y="1801368"/>
+            <a:ext cx="3145536" cy="758952"/>
+          </a:xfrm>
+          <a:prstGeom prst="rect">
+            <a:avLst/>
+          </a:prstGeom>
+          <a:noFill/>
+          <a:ln/>
+        </p:spPr>
+        <p:txBody>
+          <a:bodyPr wrap="square" lIns="254" tIns="254" rIns="254" bIns="254" rtlCol="0" anchor="t">
             <a:normAutofit/>
           </a:bodyPr>
           <a:lstStyle/>
@@ -7626,7 +7740,7 @@
               <a:buNone/>
             </a:pPr>
             <a:r>
-              <a:rPr lang="en-US" sz="1550" dirty="0">
+              <a:rPr lang="en-US" sz="1320" dirty="0">
                 <a:solidFill>
                   <a:srgbClr val="17364A"/>
                 </a:solidFill>
@@ -7636,7 +7750,7 @@
               </a:rPr>
               <a:t>What are the consequences of false positives and false negatives?</a:t>
             </a:r>
-            <a:endParaRPr lang="en-US" sz="1550" dirty="0"/>
+            <a:endParaRPr lang="en-US" sz="1320" dirty="0"/>
           </a:p>
         </p:txBody>
       </p:sp>
@@ -7724,13 +7838,16 @@
           <a:ln/>
         </p:spPr>
         <p:txBody>
-          <a:bodyPr wrap="square" lIns="254" tIns="254" rIns="254" bIns="254" rtlCol="0" anchor="t">
+          <a:bodyPr wrap="square" lIns="508" tIns="508" rIns="508" bIns="508" rtlCol="0" anchor="t">
             <a:normAutofit/>
           </a:bodyPr>
           <a:lstStyle/>
           <a:p>
-            <a:r>
-              <a:rPr lang="en-US" sz="1380" dirty="0">
+            <a:pPr indent="0" marL="0">
+              <a:buNone/>
+            </a:pPr>
+            <a:r>
+              <a:rPr lang="en-US" sz="1220" dirty="0">
                 <a:solidFill>
                   <a:srgbClr val="17364A"/>
                 </a:solidFill>
@@ -7740,11 +7857,14 @@
               </a:rPr>
               <a:t>What are the consequences of false positives and false negatives?</a:t>
             </a:r>
-            <a:endParaRPr lang="en-US" sz="1380" dirty="0"/>
-          </a:p>
-          <a:p>
-            <a:r>
-              <a:rPr lang="en-US" sz="1380" dirty="0">
+            <a:endParaRPr lang="en-US" sz="1220" dirty="0"/>
+          </a:p>
+          <a:p>
+            <a:pPr indent="0" marL="0">
+              <a:buNone/>
+            </a:pPr>
+            <a:r>
+              <a:rPr lang="en-US" sz="1220" dirty="0">
                 <a:solidFill>
                   <a:srgbClr val="17364A"/>
                 </a:solidFill>
@@ -7752,9 +7872,9 @@
                 <a:ea typeface="Aptos" pitchFamily="34" charset="-122"/>
                 <a:cs typeface="Aptos" pitchFamily="34" charset="-120"/>
               </a:rPr>
-              <a:t>How will thresholds, calibration, and subgroup performance be monitored?</a:t>
-            </a:r>
-            <a:endParaRPr lang="en-US" sz="1380" dirty="0"/>
+              <a:t>How will thresholds, calibration, and subgroup performance be.</a:t>
+            </a:r>
+            <a:endParaRPr lang="en-US" sz="1220" dirty="0"/>
           </a:p>
         </p:txBody>
       </p:sp>
@@ -7832,17 +7952,17 @@
         </p:nvSpPr>
         <p:spPr>
           <a:xfrm>
-            <a:off x="7799832" y="5001768"/>
-            <a:ext cx="3145536" cy="502920"/>
-          </a:xfrm>
-          <a:prstGeom prst="rect">
-            <a:avLst/>
-          </a:prstGeom>
-          <a:noFill/>
-          <a:ln/>
-        </p:spPr>
-        <p:txBody>
-          <a:bodyPr wrap="square" lIns="0" tIns="0" rIns="0" bIns="0" rtlCol="0" anchor="t">
+            <a:off x="7799832" y="4974336"/>
+            <a:ext cx="3145536" cy="576072"/>
+          </a:xfrm>
+          <a:prstGeom prst="rect">
+            <a:avLst/>
+          </a:prstGeom>
+          <a:noFill/>
+          <a:ln/>
+        </p:spPr>
+        <p:txBody>
+          <a:bodyPr wrap="square" lIns="254" tIns="254" rIns="254" bIns="254" rtlCol="0" anchor="t">
             <a:normAutofit/>
           </a:bodyPr>
           <a:lstStyle/>
@@ -7851,7 +7971,7 @@
               <a:buNone/>
             </a:pPr>
             <a:r>
-              <a:rPr lang="en-US" sz="1550" dirty="0">
+              <a:rPr lang="en-US" sz="1320" dirty="0">
                 <a:solidFill>
                   <a:srgbClr val="17364A"/>
                 </a:solidFill>
@@ -7859,9 +7979,9 @@
                 <a:ea typeface="Aptos" pitchFamily="34" charset="-122"/>
                 <a:cs typeface="Aptos" pitchFamily="34" charset="-120"/>
               </a:rPr>
-              <a:t>Identify what could go wrong, who could be affected, what safeguards are needed, and what evidence should be reviewed before use expands.</a:t>
-            </a:r>
-            <a:endParaRPr lang="en-US" sz="1550" dirty="0"/>
+              <a:t>Identify what could go wrong, who could be affected, what safeguards are needed, and what evidence should be reviewed.</a:t>
+            </a:r>
+            <a:endParaRPr lang="en-US" sz="1320" dirty="0"/>
           </a:p>
         </p:txBody>
       </p:sp>
@@ -8162,49 +8282,58 @@
           <a:ln/>
         </p:spPr>
         <p:txBody>
-          <a:bodyPr wrap="square" lIns="635" tIns="635" rIns="635" bIns="635" rtlCol="0" anchor="t">
+          <a:bodyPr wrap="square" lIns="1016" tIns="1016" rIns="1016" bIns="1016" rtlCol="0" anchor="t">
             <a:normAutofit/>
           </a:bodyPr>
           <a:lstStyle/>
           <a:p>
+            <a:pPr indent="0" marL="0">
+              <a:buNone/>
+            </a:pPr>
             <a:r>
               <a:rPr lang="en-US" sz="2100" dirty="0">
                 <a:solidFill>
-                  <a:srgbClr val="17364A"/>
-                </a:solidFill>
-                <a:latin typeface="Aptos" pitchFamily="34" charset="0"/>
-                <a:ea typeface="Aptos" pitchFamily="34" charset="-122"/>
-                <a:cs typeface="Aptos" pitchFamily="34" charset="-120"/>
-              </a:rPr>
-              <a:t>Create a predictive model review plan for one public health use case.</a:t>
+                  <a:srgbClr val="003A63"/>
+                </a:solidFill>
+                <a:latin typeface="Aptos" pitchFamily="34" charset="0"/>
+                <a:ea typeface="Aptos" pitchFamily="34" charset="-122"/>
+                <a:cs typeface="Aptos" pitchFamily="34" charset="-120"/>
+              </a:rPr>
+              <a:t>• Create a predictive model review plan for one public health use case.</a:t>
             </a:r>
             <a:endParaRPr lang="en-US" sz="2100" dirty="0"/>
           </a:p>
           <a:p>
+            <a:pPr indent="0" marL="0">
+              <a:buNone/>
+            </a:pPr>
             <a:r>
               <a:rPr lang="en-US" sz="2100" dirty="0">
                 <a:solidFill>
-                  <a:srgbClr val="17364A"/>
-                </a:solidFill>
-                <a:latin typeface="Aptos" pitchFamily="34" charset="0"/>
-                <a:ea typeface="Aptos" pitchFamily="34" charset="-122"/>
-                <a:cs typeface="Aptos" pitchFamily="34" charset="-120"/>
-              </a:rPr>
-              <a:t>Include the outcome, population, time horizon, data sources, candidate features, risk categories,.</a:t>
+                  <a:srgbClr val="003A63"/>
+                </a:solidFill>
+                <a:latin typeface="Aptos" pitchFamily="34" charset="0"/>
+                <a:ea typeface="Aptos" pitchFamily="34" charset="-122"/>
+                <a:cs typeface="Aptos" pitchFamily="34" charset="-120"/>
+              </a:rPr>
+              <a:t>• Include the outcome, population, time horizon, data sources, candidate features, risk.</a:t>
             </a:r>
             <a:endParaRPr lang="en-US" sz="2100" dirty="0"/>
           </a:p>
           <a:p>
+            <a:pPr indent="0" marL="0">
+              <a:buNone/>
+            </a:pPr>
             <a:r>
               <a:rPr lang="en-US" sz="2100" dirty="0">
                 <a:solidFill>
-                  <a:srgbClr val="17364A"/>
-                </a:solidFill>
-                <a:latin typeface="Aptos" pitchFamily="34" charset="0"/>
-                <a:ea typeface="Aptos" pitchFamily="34" charset="-122"/>
-                <a:cs typeface="Aptos" pitchFamily="34" charset="-120"/>
-              </a:rPr>
-              <a:t>The plan should also identify whether the use is supportive, restrictive, or consequential.</a:t>
+                  <a:srgbClr val="003A63"/>
+                </a:solidFill>
+                <a:latin typeface="Aptos" pitchFamily="34" charset="0"/>
+                <a:ea typeface="Aptos" pitchFamily="34" charset="-122"/>
+                <a:cs typeface="Aptos" pitchFamily="34" charset="-120"/>
+              </a:rPr>
+              <a:t>• The plan should also identify whether the use is supportive, restrictive, or consequential.</a:t>
             </a:r>
             <a:endParaRPr lang="en-US" sz="2100" dirty="0"/>
           </a:p>
@@ -8284,17 +8413,17 @@
         </p:nvSpPr>
         <p:spPr>
           <a:xfrm>
-            <a:off x="7799832" y="1828800"/>
-            <a:ext cx="3145536" cy="685800"/>
-          </a:xfrm>
-          <a:prstGeom prst="rect">
-            <a:avLst/>
-          </a:prstGeom>
-          <a:noFill/>
-          <a:ln/>
-        </p:spPr>
-        <p:txBody>
-          <a:bodyPr wrap="square" lIns="0" tIns="0" rIns="0" bIns="0" rtlCol="0" anchor="t">
+            <a:off x="7799832" y="1801368"/>
+            <a:ext cx="3145536" cy="758952"/>
+          </a:xfrm>
+          <a:prstGeom prst="rect">
+            <a:avLst/>
+          </a:prstGeom>
+          <a:noFill/>
+          <a:ln/>
+        </p:spPr>
+        <p:txBody>
+          <a:bodyPr wrap="square" lIns="254" tIns="254" rIns="254" bIns="254" rtlCol="0" anchor="t">
             <a:normAutofit/>
           </a:bodyPr>
           <a:lstStyle/>
@@ -8303,7 +8432,7 @@
               <a:buNone/>
             </a:pPr>
             <a:r>
-              <a:rPr lang="en-US" sz="1550" dirty="0">
+              <a:rPr lang="en-US" sz="1320" dirty="0">
                 <a:solidFill>
                   <a:srgbClr val="17364A"/>
                 </a:solidFill>
@@ -8313,7 +8442,7 @@
               </a:rPr>
               <a:t>Create a predictive model review plan for one public health use case.</a:t>
             </a:r>
-            <a:endParaRPr lang="en-US" sz="1550" dirty="0"/>
+            <a:endParaRPr lang="en-US" sz="1320" dirty="0"/>
           </a:p>
         </p:txBody>
       </p:sp>
@@ -8401,13 +8530,16 @@
           <a:ln/>
         </p:spPr>
         <p:txBody>
-          <a:bodyPr wrap="square" lIns="254" tIns="254" rIns="254" bIns="254" rtlCol="0" anchor="t">
+          <a:bodyPr wrap="square" lIns="508" tIns="508" rIns="508" bIns="508" rtlCol="0" anchor="t">
             <a:normAutofit/>
           </a:bodyPr>
           <a:lstStyle/>
           <a:p>
-            <a:r>
-              <a:rPr lang="en-US" sz="1380" dirty="0">
+            <a:pPr indent="0" marL="0">
+              <a:buNone/>
+            </a:pPr>
+            <a:r>
+              <a:rPr lang="en-US" sz="1220" dirty="0">
                 <a:solidFill>
                   <a:srgbClr val="17364A"/>
                 </a:solidFill>
@@ -8415,13 +8547,16 @@
                 <a:ea typeface="Aptos" pitchFamily="34" charset="-122"/>
                 <a:cs typeface="Aptos" pitchFamily="34" charset="-120"/>
               </a:rPr>
-              <a:t>Include the outcome, population, time horizon, data sources, candidate features, risk.</a:t>
-            </a:r>
-            <a:endParaRPr lang="en-US" sz="1380" dirty="0"/>
-          </a:p>
-          <a:p>
-            <a:r>
-              <a:rPr lang="en-US" sz="1380" dirty="0">
+              <a:t>Include the outcome, population, time horizon, data sources,.</a:t>
+            </a:r>
+            <a:endParaRPr lang="en-US" sz="1220" dirty="0"/>
+          </a:p>
+          <a:p>
+            <a:pPr indent="0" marL="0">
+              <a:buNone/>
+            </a:pPr>
+            <a:r>
+              <a:rPr lang="en-US" sz="1220" dirty="0">
                 <a:solidFill>
                   <a:srgbClr val="17364A"/>
                 </a:solidFill>
@@ -8429,9 +8564,9 @@
                 <a:ea typeface="Aptos" pitchFamily="34" charset="-122"/>
                 <a:cs typeface="Aptos" pitchFamily="34" charset="-120"/>
               </a:rPr>
-              <a:t>Predictive tools used to allocate supportive resources have different risk profiles than.</a:t>
-            </a:r>
-            <a:endParaRPr lang="en-US" sz="1380" dirty="0"/>
+              <a:t>Predictive tools used to allocate supportive resources have.</a:t>
+            </a:r>
+            <a:endParaRPr lang="en-US" sz="1220" dirty="0"/>
           </a:p>
         </p:txBody>
       </p:sp>
@@ -8509,17 +8644,17 @@
         </p:nvSpPr>
         <p:spPr>
           <a:xfrm>
-            <a:off x="7799832" y="5001768"/>
-            <a:ext cx="3145536" cy="502920"/>
-          </a:xfrm>
-          <a:prstGeom prst="rect">
-            <a:avLst/>
-          </a:prstGeom>
-          <a:noFill/>
-          <a:ln/>
-        </p:spPr>
-        <p:txBody>
-          <a:bodyPr wrap="square" lIns="0" tIns="0" rIns="0" bIns="0" rtlCol="0" anchor="t">
+            <a:off x="7799832" y="4974336"/>
+            <a:ext cx="3145536" cy="576072"/>
+          </a:xfrm>
+          <a:prstGeom prst="rect">
+            <a:avLst/>
+          </a:prstGeom>
+          <a:noFill/>
+          <a:ln/>
+        </p:spPr>
+        <p:txBody>
+          <a:bodyPr wrap="square" lIns="254" tIns="254" rIns="254" bIns="254" rtlCol="0" anchor="t">
             <a:normAutofit/>
           </a:bodyPr>
           <a:lstStyle/>
@@ -8528,7 +8663,7 @@
               <a:buNone/>
             </a:pPr>
             <a:r>
-              <a:rPr lang="en-US" sz="1550" dirty="0">
+              <a:rPr lang="en-US" sz="1320" dirty="0">
                 <a:solidFill>
                   <a:srgbClr val="17364A"/>
                 </a:solidFill>
@@ -8536,9 +8671,9 @@
                 <a:ea typeface="Aptos" pitchFamily="34" charset="-122"/>
                 <a:cs typeface="Aptos" pitchFamily="34" charset="-120"/>
               </a:rPr>
-              <a:t>Use the assignment to test whether you can explain the concept, apply it to a realistic public health situation, and identify what would need review before the work moves forward.</a:t>
-            </a:r>
-            <a:endParaRPr lang="en-US" sz="1550" dirty="0"/>
+              <a:t>Use the assignment to test whether you can explain the concept, apply it to a realistic public health situation, and.</a:t>
+            </a:r>
+            <a:endParaRPr lang="en-US" sz="1320" dirty="0"/>
           </a:p>
         </p:txBody>
       </p:sp>
@@ -8839,49 +8974,58 @@
           <a:ln/>
         </p:spPr>
         <p:txBody>
-          <a:bodyPr wrap="square" lIns="635" tIns="635" rIns="635" bIns="635" rtlCol="0" anchor="t">
+          <a:bodyPr wrap="square" lIns="1016" tIns="1016" rIns="1016" bIns="1016" rtlCol="0" anchor="t">
             <a:normAutofit/>
           </a:bodyPr>
           <a:lstStyle/>
           <a:p>
+            <a:pPr indent="0" marL="0">
+              <a:buNone/>
+            </a:pPr>
             <a:r>
               <a:rPr lang="en-US" sz="2100" dirty="0">
                 <a:solidFill>
-                  <a:srgbClr val="17364A"/>
-                </a:solidFill>
-                <a:latin typeface="Aptos" pitchFamily="34" charset="0"/>
-                <a:ea typeface="Aptos" pitchFamily="34" charset="-122"/>
-                <a:cs typeface="Aptos" pitchFamily="34" charset="-120"/>
-              </a:rPr>
-              <a:t>Predictive model review plan</a:t>
+                  <a:srgbClr val="003A63"/>
+                </a:solidFill>
+                <a:latin typeface="Aptos" pitchFamily="34" charset="0"/>
+                <a:ea typeface="Aptos" pitchFamily="34" charset="-122"/>
+                <a:cs typeface="Aptos" pitchFamily="34" charset="-120"/>
+              </a:rPr>
+              <a:t>• Predictive model review plan</a:t>
             </a:r>
             <a:endParaRPr lang="en-US" sz="2100" dirty="0"/>
           </a:p>
           <a:p>
+            <a:pPr indent="0" marL="0">
+              <a:buNone/>
+            </a:pPr>
             <a:r>
               <a:rPr lang="en-US" sz="2100" dirty="0">
                 <a:solidFill>
-                  <a:srgbClr val="17364A"/>
-                </a:solidFill>
-                <a:latin typeface="Aptos" pitchFamily="34" charset="0"/>
-                <a:ea typeface="Aptos" pitchFamily="34" charset="-122"/>
-                <a:cs typeface="Aptos" pitchFamily="34" charset="-120"/>
-              </a:rPr>
-              <a:t>Risk score interpretation guide</a:t>
+                  <a:srgbClr val="003A63"/>
+                </a:solidFill>
+                <a:latin typeface="Aptos" pitchFamily="34" charset="0"/>
+                <a:ea typeface="Aptos" pitchFamily="34" charset="-122"/>
+                <a:cs typeface="Aptos" pitchFamily="34" charset="-120"/>
+              </a:rPr>
+              <a:t>• Risk score interpretation guide</a:t>
             </a:r>
             <a:endParaRPr lang="en-US" sz="2100" dirty="0"/>
           </a:p>
           <a:p>
+            <a:pPr indent="0" marL="0">
+              <a:buNone/>
+            </a:pPr>
             <a:r>
               <a:rPr lang="en-US" sz="2100" dirty="0">
                 <a:solidFill>
-                  <a:srgbClr val="17364A"/>
-                </a:solidFill>
-                <a:latin typeface="Aptos" pitchFamily="34" charset="0"/>
-                <a:ea typeface="Aptos" pitchFamily="34" charset="-122"/>
-                <a:cs typeface="Aptos" pitchFamily="34" charset="-120"/>
-              </a:rPr>
-              <a:t>Threshold and error tradeoff memo</a:t>
+                  <a:srgbClr val="003A63"/>
+                </a:solidFill>
+                <a:latin typeface="Aptos" pitchFamily="34" charset="0"/>
+                <a:ea typeface="Aptos" pitchFamily="34" charset="-122"/>
+                <a:cs typeface="Aptos" pitchFamily="34" charset="-120"/>
+              </a:rPr>
+              <a:t>• Threshold and error tradeoff memo</a:t>
             </a:r>
             <a:endParaRPr lang="en-US" sz="2100" dirty="0"/>
           </a:p>
@@ -8961,17 +9105,17 @@
         </p:nvSpPr>
         <p:spPr>
           <a:xfrm>
-            <a:off x="7799832" y="1828800"/>
-            <a:ext cx="3145536" cy="685800"/>
-          </a:xfrm>
-          <a:prstGeom prst="rect">
-            <a:avLst/>
-          </a:prstGeom>
-          <a:noFill/>
-          <a:ln/>
-        </p:spPr>
-        <p:txBody>
-          <a:bodyPr wrap="square" lIns="0" tIns="0" rIns="0" bIns="0" rtlCol="0" anchor="t">
+            <a:off x="7799832" y="1801368"/>
+            <a:ext cx="3145536" cy="758952"/>
+          </a:xfrm>
+          <a:prstGeom prst="rect">
+            <a:avLst/>
+          </a:prstGeom>
+          <a:noFill/>
+          <a:ln/>
+        </p:spPr>
+        <p:txBody>
+          <a:bodyPr wrap="square" lIns="254" tIns="254" rIns="254" bIns="254" rtlCol="0" anchor="t">
             <a:normAutofit/>
           </a:bodyPr>
           <a:lstStyle/>
@@ -8980,7 +9124,7 @@
               <a:buNone/>
             </a:pPr>
             <a:r>
-              <a:rPr lang="en-US" sz="1550" dirty="0">
+              <a:rPr lang="en-US" sz="1320" dirty="0">
                 <a:solidFill>
                   <a:srgbClr val="17364A"/>
                 </a:solidFill>
@@ -8990,7 +9134,7 @@
               </a:rPr>
               <a:t>Predictive model review plan</a:t>
             </a:r>
-            <a:endParaRPr lang="en-US" sz="1550" dirty="0"/>
+            <a:endParaRPr lang="en-US" sz="1320" dirty="0"/>
           </a:p>
         </p:txBody>
       </p:sp>
@@ -9078,13 +9222,16 @@
           <a:ln/>
         </p:spPr>
         <p:txBody>
-          <a:bodyPr wrap="square" lIns="254" tIns="254" rIns="254" bIns="254" rtlCol="0" anchor="t">
+          <a:bodyPr wrap="square" lIns="508" tIns="508" rIns="508" bIns="508" rtlCol="0" anchor="t">
             <a:normAutofit/>
           </a:bodyPr>
           <a:lstStyle/>
           <a:p>
-            <a:r>
-              <a:rPr lang="en-US" sz="1380" dirty="0">
+            <a:pPr indent="0" marL="0">
+              <a:buNone/>
+            </a:pPr>
+            <a:r>
+              <a:rPr lang="en-US" sz="1220" dirty="0">
                 <a:solidFill>
                   <a:srgbClr val="17364A"/>
                 </a:solidFill>
@@ -9094,11 +9241,14 @@
               </a:rPr>
               <a:t>Predictive model review plan</a:t>
             </a:r>
-            <a:endParaRPr lang="en-US" sz="1380" dirty="0"/>
-          </a:p>
-          <a:p>
-            <a:r>
-              <a:rPr lang="en-US" sz="1380" dirty="0">
+            <a:endParaRPr lang="en-US" sz="1220" dirty="0"/>
+          </a:p>
+          <a:p>
+            <a:pPr indent="0" marL="0">
+              <a:buNone/>
+            </a:pPr>
+            <a:r>
+              <a:rPr lang="en-US" sz="1220" dirty="0">
                 <a:solidFill>
                   <a:srgbClr val="17364A"/>
                 </a:solidFill>
@@ -9108,11 +9258,14 @@
               </a:rPr>
               <a:t>Risk score interpretation guide</a:t>
             </a:r>
-            <a:endParaRPr lang="en-US" sz="1380" dirty="0"/>
-          </a:p>
-          <a:p>
-            <a:r>
-              <a:rPr lang="en-US" sz="1380" dirty="0">
+            <a:endParaRPr lang="en-US" sz="1220" dirty="0"/>
+          </a:p>
+          <a:p>
+            <a:pPr indent="0" marL="0">
+              <a:buNone/>
+            </a:pPr>
+            <a:r>
+              <a:rPr lang="en-US" sz="1220" dirty="0">
                 <a:solidFill>
                   <a:srgbClr val="17364A"/>
                 </a:solidFill>
@@ -9122,7 +9275,7 @@
               </a:rPr>
               <a:t>Threshold and error tradeoff memo</a:t>
             </a:r>
-            <a:endParaRPr lang="en-US" sz="1380" dirty="0"/>
+            <a:endParaRPr lang="en-US" sz="1220" dirty="0"/>
           </a:p>
         </p:txBody>
       </p:sp>
@@ -9200,17 +9353,17 @@
         </p:nvSpPr>
         <p:spPr>
           <a:xfrm>
-            <a:off x="7799832" y="5001768"/>
-            <a:ext cx="3145536" cy="502920"/>
-          </a:xfrm>
-          <a:prstGeom prst="rect">
-            <a:avLst/>
-          </a:prstGeom>
-          <a:noFill/>
-          <a:ln/>
-        </p:spPr>
-        <p:txBody>
-          <a:bodyPr wrap="square" lIns="0" tIns="0" rIns="0" bIns="0" rtlCol="0" anchor="t">
+            <a:off x="7799832" y="4974336"/>
+            <a:ext cx="3145536" cy="576072"/>
+          </a:xfrm>
+          <a:prstGeom prst="rect">
+            <a:avLst/>
+          </a:prstGeom>
+          <a:noFill/>
+          <a:ln/>
+        </p:spPr>
+        <p:txBody>
+          <a:bodyPr wrap="square" lIns="254" tIns="254" rIns="254" bIns="254" rtlCol="0" anchor="t">
             <a:normAutofit/>
           </a:bodyPr>
           <a:lstStyle/>
@@ -9219,7 +9372,7 @@
               <a:buNone/>
             </a:pPr>
             <a:r>
-              <a:rPr lang="en-US" sz="1550" dirty="0">
+              <a:rPr lang="en-US" sz="1320" dirty="0">
                 <a:solidFill>
                   <a:srgbClr val="17364A"/>
                 </a:solidFill>
@@ -9227,9 +9380,9 @@
                 <a:ea typeface="Aptos" pitchFamily="34" charset="-122"/>
                 <a:cs typeface="Aptos" pitchFamily="34" charset="-120"/>
               </a:rPr>
-              <a:t>Identify what could go wrong, who could be affected, what safeguards are needed, and what evidence should be reviewed before use expands.</a:t>
-            </a:r>
-            <a:endParaRPr lang="en-US" sz="1550" dirty="0"/>
+              <a:t>Identify what could go wrong, who could be affected, what safeguards are needed, and what evidence should be reviewed.</a:t>
+            </a:r>
+            <a:endParaRPr lang="en-US" sz="1320" dirty="0"/>
           </a:p>
         </p:txBody>
       </p:sp>
@@ -9530,21 +9683,24 @@
           <a:ln/>
         </p:spPr>
         <p:txBody>
-          <a:bodyPr wrap="square" lIns="635" tIns="635" rIns="635" bIns="635" rtlCol="0" anchor="t">
+          <a:bodyPr wrap="square" lIns="1016" tIns="1016" rIns="1016" bIns="1016" rtlCol="0" anchor="t">
             <a:normAutofit/>
           </a:bodyPr>
           <a:lstStyle/>
           <a:p>
+            <a:pPr indent="0" marL="0">
+              <a:buNone/>
+            </a:pPr>
             <a:r>
               <a:rPr lang="en-US" sz="2100" dirty="0">
                 <a:solidFill>
-                  <a:srgbClr val="17364A"/>
-                </a:solidFill>
-                <a:latin typeface="Aptos" pitchFamily="34" charset="0"/>
-                <a:ea typeface="Aptos" pitchFamily="34" charset="-122"/>
-                <a:cs typeface="Aptos" pitchFamily="34" charset="-120"/>
-              </a:rPr>
-              <a:t>Subgroup monitoring plan</a:t>
+                  <a:srgbClr val="003A63"/>
+                </a:solidFill>
+                <a:latin typeface="Aptos" pitchFamily="34" charset="0"/>
+                <a:ea typeface="Aptos" pitchFamily="34" charset="-122"/>
+                <a:cs typeface="Aptos" pitchFamily="34" charset="-120"/>
+              </a:rPr>
+              <a:t>• Subgroup monitoring plan</a:t>
             </a:r>
             <a:endParaRPr lang="en-US" sz="2100" dirty="0"/>
           </a:p>
@@ -9624,17 +9780,17 @@
         </p:nvSpPr>
         <p:spPr>
           <a:xfrm>
-            <a:off x="7799832" y="1828800"/>
-            <a:ext cx="3145536" cy="685800"/>
-          </a:xfrm>
-          <a:prstGeom prst="rect">
-            <a:avLst/>
-          </a:prstGeom>
-          <a:noFill/>
-          <a:ln/>
-        </p:spPr>
-        <p:txBody>
-          <a:bodyPr wrap="square" lIns="0" tIns="0" rIns="0" bIns="0" rtlCol="0" anchor="t">
+            <a:off x="7799832" y="1801368"/>
+            <a:ext cx="3145536" cy="758952"/>
+          </a:xfrm>
+          <a:prstGeom prst="rect">
+            <a:avLst/>
+          </a:prstGeom>
+          <a:noFill/>
+          <a:ln/>
+        </p:spPr>
+        <p:txBody>
+          <a:bodyPr wrap="square" lIns="254" tIns="254" rIns="254" bIns="254" rtlCol="0" anchor="t">
             <a:normAutofit/>
           </a:bodyPr>
           <a:lstStyle/>
@@ -9643,7 +9799,7 @@
               <a:buNone/>
             </a:pPr>
             <a:r>
-              <a:rPr lang="en-US" sz="1550" dirty="0">
+              <a:rPr lang="en-US" sz="1320" dirty="0">
                 <a:solidFill>
                   <a:srgbClr val="17364A"/>
                 </a:solidFill>
@@ -9653,7 +9809,7 @@
               </a:rPr>
               <a:t>Subgroup monitoring plan</a:t>
             </a:r>
-            <a:endParaRPr lang="en-US" sz="1550" dirty="0"/>
+            <a:endParaRPr lang="en-US" sz="1320" dirty="0"/>
           </a:p>
         </p:txBody>
       </p:sp>
@@ -9741,13 +9897,16 @@
           <a:ln/>
         </p:spPr>
         <p:txBody>
-          <a:bodyPr wrap="square" lIns="254" tIns="254" rIns="254" bIns="254" rtlCol="0" anchor="t">
+          <a:bodyPr wrap="square" lIns="508" tIns="508" rIns="508" bIns="508" rtlCol="0" anchor="t">
             <a:normAutofit/>
           </a:bodyPr>
           <a:lstStyle/>
           <a:p>
-            <a:r>
-              <a:rPr lang="en-US" sz="1380" dirty="0">
+            <a:pPr indent="0" marL="0">
+              <a:buNone/>
+            </a:pPr>
+            <a:r>
+              <a:rPr lang="en-US" sz="1220" dirty="0">
                 <a:solidFill>
                   <a:srgbClr val="17364A"/>
                 </a:solidFill>
@@ -9757,7 +9916,7 @@
               </a:rPr>
               <a:t>Subgroup monitoring plan</a:t>
             </a:r>
-            <a:endParaRPr lang="en-US" sz="1380" dirty="0"/>
+            <a:endParaRPr lang="en-US" sz="1220" dirty="0"/>
           </a:p>
         </p:txBody>
       </p:sp>
@@ -9835,17 +9994,17 @@
         </p:nvSpPr>
         <p:spPr>
           <a:xfrm>
-            <a:off x="7799832" y="5001768"/>
-            <a:ext cx="3145536" cy="502920"/>
-          </a:xfrm>
-          <a:prstGeom prst="rect">
-            <a:avLst/>
-          </a:prstGeom>
-          <a:noFill/>
-          <a:ln/>
-        </p:spPr>
-        <p:txBody>
-          <a:bodyPr wrap="square" lIns="0" tIns="0" rIns="0" bIns="0" rtlCol="0" anchor="t">
+            <a:off x="7799832" y="4974336"/>
+            <a:ext cx="3145536" cy="576072"/>
+          </a:xfrm>
+          <a:prstGeom prst="rect">
+            <a:avLst/>
+          </a:prstGeom>
+          <a:noFill/>
+          <a:ln/>
+        </p:spPr>
+        <p:txBody>
+          <a:bodyPr wrap="square" lIns="254" tIns="254" rIns="254" bIns="254" rtlCol="0" anchor="t">
             <a:normAutofit/>
           </a:bodyPr>
           <a:lstStyle/>
@@ -9854,7 +10013,7 @@
               <a:buNone/>
             </a:pPr>
             <a:r>
-              <a:rPr lang="en-US" sz="1550" dirty="0">
+              <a:rPr lang="en-US" sz="1320" dirty="0">
                 <a:solidFill>
                   <a:srgbClr val="17364A"/>
                 </a:solidFill>
@@ -9862,9 +10021,9 @@
                 <a:ea typeface="Aptos" pitchFamily="34" charset="-122"/>
                 <a:cs typeface="Aptos" pitchFamily="34" charset="-120"/>
               </a:rPr>
-              <a:t>Identify what could go wrong, who could be affected, what safeguards are needed, and what evidence should be reviewed before use expands.</a:t>
-            </a:r>
-            <a:endParaRPr lang="en-US" sz="1550" dirty="0"/>
+              <a:t>Identify what could go wrong, who could be affected, what safeguards are needed, and what evidence should be reviewed.</a:t>
+            </a:r>
+            <a:endParaRPr lang="en-US" sz="1320" dirty="0"/>
           </a:p>
         </p:txBody>
       </p:sp>
@@ -10165,49 +10324,58 @@
           <a:ln/>
         </p:spPr>
         <p:txBody>
-          <a:bodyPr wrap="square" lIns="635" tIns="635" rIns="635" bIns="635" rtlCol="0" anchor="t">
+          <a:bodyPr wrap="square" lIns="1016" tIns="1016" rIns="1016" bIns="1016" rtlCol="0" anchor="t">
             <a:normAutofit/>
           </a:bodyPr>
           <a:lstStyle/>
           <a:p>
+            <a:pPr indent="0" marL="0">
+              <a:buNone/>
+            </a:pPr>
             <a:r>
               <a:rPr lang="en-US" sz="2100" dirty="0">
                 <a:solidFill>
-                  <a:srgbClr val="17364A"/>
-                </a:solidFill>
-                <a:latin typeface="Aptos" pitchFamily="34" charset="0"/>
-                <a:ea typeface="Aptos" pitchFamily="34" charset="-122"/>
-                <a:cs typeface="Aptos" pitchFamily="34" charset="-120"/>
-              </a:rPr>
-              <a:t>Predictive analytics uses data to estimate the likelihood of future events or outcomes.</a:t>
+                  <a:srgbClr val="003A63"/>
+                </a:solidFill>
+                <a:latin typeface="Aptos" pitchFamily="34" charset="0"/>
+                <a:ea typeface="Aptos" pitchFamily="34" charset="-122"/>
+                <a:cs typeface="Aptos" pitchFamily="34" charset="-120"/>
+              </a:rPr>
+              <a:t>• Predictive analytics uses data to estimate the likelihood of future events or outcomes.</a:t>
             </a:r>
             <a:endParaRPr lang="en-US" sz="2100" dirty="0"/>
           </a:p>
           <a:p>
+            <a:pPr indent="0" marL="0">
+              <a:buNone/>
+            </a:pPr>
             <a:r>
               <a:rPr lang="en-US" sz="2100" dirty="0">
                 <a:solidFill>
-                  <a:srgbClr val="17364A"/>
-                </a:solidFill>
-                <a:latin typeface="Aptos" pitchFamily="34" charset="0"/>
-                <a:ea typeface="Aptos" pitchFamily="34" charset="-122"/>
-                <a:cs typeface="Aptos" pitchFamily="34" charset="-120"/>
-              </a:rPr>
-              <a:t>In public health, predictive models may be used to anticipate disease burden, identify populations at higher.</a:t>
+                  <a:srgbClr val="003A63"/>
+                </a:solidFill>
+                <a:latin typeface="Aptos" pitchFamily="34" charset="0"/>
+                <a:ea typeface="Aptos" pitchFamily="34" charset="-122"/>
+                <a:cs typeface="Aptos" pitchFamily="34" charset="-120"/>
+              </a:rPr>
+              <a:t>• In public health, predictive models may be used to anticipate disease burden, identify.</a:t>
             </a:r>
             <a:endParaRPr lang="en-US" sz="2100" dirty="0"/>
           </a:p>
           <a:p>
+            <a:pPr indent="0" marL="0">
+              <a:buNone/>
+            </a:pPr>
             <a:r>
               <a:rPr lang="en-US" sz="2100" dirty="0">
                 <a:solidFill>
-                  <a:srgbClr val="17364A"/>
-                </a:solidFill>
-                <a:latin typeface="Aptos" pitchFamily="34" charset="0"/>
-                <a:ea typeface="Aptos" pitchFamily="34" charset="-122"/>
-                <a:cs typeface="Aptos" pitchFamily="34" charset="-120"/>
-              </a:rPr>
-              <a:t>Risk stratification is the practice of grouping individuals, facilities, areas, events, or populations into.</a:t>
+                  <a:srgbClr val="003A63"/>
+                </a:solidFill>
+                <a:latin typeface="Aptos" pitchFamily="34" charset="0"/>
+                <a:ea typeface="Aptos" pitchFamily="34" charset="-122"/>
+                <a:cs typeface="Aptos" pitchFamily="34" charset="-120"/>
+              </a:rPr>
+              <a:t>• Risk stratification is the practice of grouping individuals, facilities, areas, events, or.</a:t>
             </a:r>
             <a:endParaRPr lang="en-US" sz="2100" dirty="0"/>
           </a:p>
@@ -10287,17 +10455,17 @@
         </p:nvSpPr>
         <p:spPr>
           <a:xfrm>
-            <a:off x="8074152" y="1920240"/>
-            <a:ext cx="2825496" cy="1280160"/>
-          </a:xfrm>
-          <a:prstGeom prst="rect">
-            <a:avLst/>
-          </a:prstGeom>
-          <a:noFill/>
-          <a:ln/>
-        </p:spPr>
-        <p:txBody>
-          <a:bodyPr wrap="square" lIns="0" tIns="0" rIns="0" bIns="0" rtlCol="0" anchor="t">
+            <a:off x="8074152" y="1892808"/>
+            <a:ext cx="2825496" cy="1353312"/>
+          </a:xfrm>
+          <a:prstGeom prst="rect">
+            <a:avLst/>
+          </a:prstGeom>
+          <a:noFill/>
+          <a:ln/>
+        </p:spPr>
+        <p:txBody>
+          <a:bodyPr wrap="square" lIns="254" tIns="254" rIns="254" bIns="254" rtlCol="0" anchor="t">
             <a:normAutofit/>
           </a:bodyPr>
           <a:lstStyle/>
@@ -10306,7 +10474,7 @@
               <a:buNone/>
             </a:pPr>
             <a:r>
-              <a:rPr lang="en-US" sz="1550" dirty="0">
+              <a:rPr lang="en-US" sz="1320" dirty="0">
                 <a:solidFill>
                   <a:srgbClr val="17364A"/>
                 </a:solidFill>
@@ -10314,43 +10482,9 @@
                 <a:ea typeface="Aptos" pitchFamily="34" charset="-122"/>
                 <a:cs typeface="Aptos" pitchFamily="34" charset="-120"/>
               </a:rPr>
-              <a:t>Level: applied/foundational</a:t>
-            </a:r>
-            <a:endParaRPr lang="en-US" sz="1550" dirty="0"/>
-          </a:p>
-          <a:p>
-            <a:pPr indent="0" marL="0">
-              <a:buNone/>
-            </a:pPr>
-            <a:r>
-              <a:rPr lang="en-US" sz="1550" dirty="0">
-                <a:solidFill>
-                  <a:srgbClr val="17364A"/>
-                </a:solidFill>
-                <a:latin typeface="Aptos" pitchFamily="34" charset="0"/>
-                <a:ea typeface="Aptos" pitchFamily="34" charset="-122"/>
-                <a:cs typeface="Aptos" pitchFamily="34" charset="-120"/>
-              </a:rPr>
-              <a:t>Primary track: Analytics and Modeling Track</a:t>
-            </a:r>
-            <a:endParaRPr lang="en-US" sz="1550" dirty="0"/>
-          </a:p>
-          <a:p>
-            <a:pPr indent="0" marL="0">
-              <a:buNone/>
-            </a:pPr>
-            <a:r>
-              <a:rPr lang="en-US" sz="1550" dirty="0">
-                <a:solidFill>
-                  <a:srgbClr val="17364A"/>
-                </a:solidFill>
-                <a:latin typeface="Aptos" pitchFamily="34" charset="0"/>
-                <a:ea typeface="Aptos" pitchFamily="34" charset="-122"/>
-                <a:cs typeface="Aptos" pitchFamily="34" charset="-120"/>
-              </a:rPr>
-              <a:t>Appears in tracks: analytics-modeling</a:t>
-            </a:r>
-            <a:endParaRPr lang="en-US" sz="1550" dirty="0"/>
+              <a:t>Level: applied/foundational Primary track: Analytics and Modeling Track Appears in tracks: analytics-modeling</a:t>
+            </a:r>
+            <a:endParaRPr lang="en-US" sz="1320" dirty="0"/>
           </a:p>
         </p:txBody>
       </p:sp>
@@ -10438,13 +10572,16 @@
           <a:ln/>
         </p:spPr>
         <p:txBody>
-          <a:bodyPr wrap="square" lIns="254" tIns="254" rIns="254" bIns="254" rtlCol="0" anchor="t">
+          <a:bodyPr wrap="square" lIns="508" tIns="508" rIns="508" bIns="508" rtlCol="0" anchor="t">
             <a:normAutofit/>
           </a:bodyPr>
           <a:lstStyle/>
           <a:p>
-            <a:r>
-              <a:rPr lang="en-US" sz="1380" dirty="0">
+            <a:pPr indent="0" marL="0">
+              <a:buNone/>
+            </a:pPr>
+            <a:r>
+              <a:rPr lang="en-US" sz="1220" dirty="0">
                 <a:solidFill>
                   <a:srgbClr val="17364A"/>
                 </a:solidFill>
@@ -10454,11 +10591,14 @@
               </a:rPr>
               <a:t>Read the module for shared vocabulary and context.</a:t>
             </a:r>
-            <a:endParaRPr lang="en-US" sz="1380" dirty="0"/>
-          </a:p>
-          <a:p>
-            <a:r>
-              <a:rPr lang="en-US" sz="1380" dirty="0">
+            <a:endParaRPr lang="en-US" sz="1220" dirty="0"/>
+          </a:p>
+          <a:p>
+            <a:pPr indent="0" marL="0">
+              <a:buNone/>
+            </a:pPr>
+            <a:r>
+              <a:rPr lang="en-US" sz="1220" dirty="0">
                 <a:solidFill>
                   <a:srgbClr val="17364A"/>
                 </a:solidFill>
@@ -10468,11 +10608,14 @@
               </a:rPr>
               <a:t>Complete the practical exercise to apply the concept.</a:t>
             </a:r>
-            <a:endParaRPr lang="en-US" sz="1380" dirty="0"/>
-          </a:p>
-          <a:p>
-            <a:r>
-              <a:rPr lang="en-US" sz="1380" dirty="0">
+            <a:endParaRPr lang="en-US" sz="1220" dirty="0"/>
+          </a:p>
+          <a:p>
+            <a:pPr indent="0" marL="0">
+              <a:buNone/>
+            </a:pPr>
+            <a:r>
+              <a:rPr lang="en-US" sz="1220" dirty="0">
                 <a:solidFill>
                   <a:srgbClr val="17364A"/>
                 </a:solidFill>
@@ -10482,7 +10625,7 @@
               </a:rPr>
               <a:t>Use the notes and references for deeper review.</a:t>
             </a:r>
-            <a:endParaRPr lang="en-US" sz="1380" dirty="0"/>
+            <a:endParaRPr lang="en-US" sz="1220" dirty="0"/>
           </a:p>
         </p:txBody>
       </p:sp>
@@ -10783,49 +10926,58 @@
           <a:ln/>
         </p:spPr>
         <p:txBody>
-          <a:bodyPr wrap="square" lIns="635" tIns="635" rIns="635" bIns="635" rtlCol="0" anchor="t">
+          <a:bodyPr wrap="square" lIns="1016" tIns="1016" rIns="1016" bIns="1016" rtlCol="0" anchor="t">
             <a:normAutofit/>
           </a:bodyPr>
           <a:lstStyle/>
           <a:p>
+            <a:pPr indent="0" marL="0">
+              <a:buNone/>
+            </a:pPr>
             <a:r>
               <a:rPr lang="en-US" sz="2100" dirty="0">
                 <a:solidFill>
-                  <a:srgbClr val="17364A"/>
-                </a:solidFill>
-                <a:latin typeface="Aptos" pitchFamily="34" charset="0"/>
-                <a:ea typeface="Aptos" pitchFamily="34" charset="-122"/>
-                <a:cs typeface="Aptos" pitchFamily="34" charset="-120"/>
-              </a:rPr>
-              <a:t>Predictive model review plan</a:t>
+                  <a:srgbClr val="003A63"/>
+                </a:solidFill>
+                <a:latin typeface="Aptos" pitchFamily="34" charset="0"/>
+                <a:ea typeface="Aptos" pitchFamily="34" charset="-122"/>
+                <a:cs typeface="Aptos" pitchFamily="34" charset="-120"/>
+              </a:rPr>
+              <a:t>• Predictive model review plan</a:t>
             </a:r>
             <a:endParaRPr lang="en-US" sz="2100" dirty="0"/>
           </a:p>
           <a:p>
+            <a:pPr indent="0" marL="0">
+              <a:buNone/>
+            </a:pPr>
             <a:r>
               <a:rPr lang="en-US" sz="2100" dirty="0">
                 <a:solidFill>
-                  <a:srgbClr val="17364A"/>
-                </a:solidFill>
-                <a:latin typeface="Aptos" pitchFamily="34" charset="0"/>
-                <a:ea typeface="Aptos" pitchFamily="34" charset="-122"/>
-                <a:cs typeface="Aptos" pitchFamily="34" charset="-120"/>
-              </a:rPr>
-              <a:t>Risk score interpretation guide</a:t>
+                  <a:srgbClr val="003A63"/>
+                </a:solidFill>
+                <a:latin typeface="Aptos" pitchFamily="34" charset="0"/>
+                <a:ea typeface="Aptos" pitchFamily="34" charset="-122"/>
+                <a:cs typeface="Aptos" pitchFamily="34" charset="-120"/>
+              </a:rPr>
+              <a:t>• Risk score interpretation guide</a:t>
             </a:r>
             <a:endParaRPr lang="en-US" sz="2100" dirty="0"/>
           </a:p>
           <a:p>
+            <a:pPr indent="0" marL="0">
+              <a:buNone/>
+            </a:pPr>
             <a:r>
               <a:rPr lang="en-US" sz="2100" dirty="0">
                 <a:solidFill>
-                  <a:srgbClr val="17364A"/>
-                </a:solidFill>
-                <a:latin typeface="Aptos" pitchFamily="34" charset="0"/>
-                <a:ea typeface="Aptos" pitchFamily="34" charset="-122"/>
-                <a:cs typeface="Aptos" pitchFamily="34" charset="-120"/>
-              </a:rPr>
-              <a:t>Threshold and error tradeoff memo</a:t>
+                  <a:srgbClr val="003A63"/>
+                </a:solidFill>
+                <a:latin typeface="Aptos" pitchFamily="34" charset="0"/>
+                <a:ea typeface="Aptos" pitchFamily="34" charset="-122"/>
+                <a:cs typeface="Aptos" pitchFamily="34" charset="-120"/>
+              </a:rPr>
+              <a:t>• Threshold and error tradeoff memo</a:t>
             </a:r>
             <a:endParaRPr lang="en-US" sz="2100" dirty="0"/>
           </a:p>
@@ -10905,17 +11057,17 @@
         </p:nvSpPr>
         <p:spPr>
           <a:xfrm>
-            <a:off x="7799832" y="1828800"/>
-            <a:ext cx="3145536" cy="685800"/>
-          </a:xfrm>
-          <a:prstGeom prst="rect">
-            <a:avLst/>
-          </a:prstGeom>
-          <a:noFill/>
-          <a:ln/>
-        </p:spPr>
-        <p:txBody>
-          <a:bodyPr wrap="square" lIns="0" tIns="0" rIns="0" bIns="0" rtlCol="0" anchor="t">
+            <a:off x="7799832" y="1801368"/>
+            <a:ext cx="3145536" cy="758952"/>
+          </a:xfrm>
+          <a:prstGeom prst="rect">
+            <a:avLst/>
+          </a:prstGeom>
+          <a:noFill/>
+          <a:ln/>
+        </p:spPr>
+        <p:txBody>
+          <a:bodyPr wrap="square" lIns="254" tIns="254" rIns="254" bIns="254" rtlCol="0" anchor="t">
             <a:normAutofit/>
           </a:bodyPr>
           <a:lstStyle/>
@@ -10924,7 +11076,7 @@
               <a:buNone/>
             </a:pPr>
             <a:r>
-              <a:rPr lang="en-US" sz="1550" dirty="0">
+              <a:rPr lang="en-US" sz="1320" dirty="0">
                 <a:solidFill>
                   <a:srgbClr val="17364A"/>
                 </a:solidFill>
@@ -10934,7 +11086,7 @@
               </a:rPr>
               <a:t>Predictive model review plan</a:t>
             </a:r>
-            <a:endParaRPr lang="en-US" sz="1550" dirty="0"/>
+            <a:endParaRPr lang="en-US" sz="1320" dirty="0"/>
           </a:p>
         </p:txBody>
       </p:sp>
@@ -11022,13 +11174,16 @@
           <a:ln/>
         </p:spPr>
         <p:txBody>
-          <a:bodyPr wrap="square" lIns="254" tIns="254" rIns="254" bIns="254" rtlCol="0" anchor="t">
+          <a:bodyPr wrap="square" lIns="508" tIns="508" rIns="508" bIns="508" rtlCol="0" anchor="t">
             <a:normAutofit/>
           </a:bodyPr>
           <a:lstStyle/>
           <a:p>
-            <a:r>
-              <a:rPr lang="en-US" sz="1380" dirty="0">
+            <a:pPr indent="0" marL="0">
+              <a:buNone/>
+            </a:pPr>
+            <a:r>
+              <a:rPr lang="en-US" sz="1220" dirty="0">
                 <a:solidFill>
                   <a:srgbClr val="17364A"/>
                 </a:solidFill>
@@ -11038,11 +11193,14 @@
               </a:rPr>
               <a:t>Predictive model review plan</a:t>
             </a:r>
-            <a:endParaRPr lang="en-US" sz="1380" dirty="0"/>
-          </a:p>
-          <a:p>
-            <a:r>
-              <a:rPr lang="en-US" sz="1380" dirty="0">
+            <a:endParaRPr lang="en-US" sz="1220" dirty="0"/>
+          </a:p>
+          <a:p>
+            <a:pPr indent="0" marL="0">
+              <a:buNone/>
+            </a:pPr>
+            <a:r>
+              <a:rPr lang="en-US" sz="1220" dirty="0">
                 <a:solidFill>
                   <a:srgbClr val="17364A"/>
                 </a:solidFill>
@@ -11052,11 +11210,14 @@
               </a:rPr>
               <a:t>Risk score interpretation guide</a:t>
             </a:r>
-            <a:endParaRPr lang="en-US" sz="1380" dirty="0"/>
-          </a:p>
-          <a:p>
-            <a:r>
-              <a:rPr lang="en-US" sz="1380" dirty="0">
+            <a:endParaRPr lang="en-US" sz="1220" dirty="0"/>
+          </a:p>
+          <a:p>
+            <a:pPr indent="0" marL="0">
+              <a:buNone/>
+            </a:pPr>
+            <a:r>
+              <a:rPr lang="en-US" sz="1220" dirty="0">
                 <a:solidFill>
                   <a:srgbClr val="17364A"/>
                 </a:solidFill>
@@ -11066,7 +11227,7 @@
               </a:rPr>
               <a:t>Threshold and error tradeoff memo</a:t>
             </a:r>
-            <a:endParaRPr lang="en-US" sz="1380" dirty="0"/>
+            <a:endParaRPr lang="en-US" sz="1220" dirty="0"/>
           </a:p>
         </p:txBody>
       </p:sp>
@@ -11144,17 +11305,17 @@
         </p:nvSpPr>
         <p:spPr>
           <a:xfrm>
-            <a:off x="7799832" y="5001768"/>
-            <a:ext cx="3145536" cy="502920"/>
-          </a:xfrm>
-          <a:prstGeom prst="rect">
-            <a:avLst/>
-          </a:prstGeom>
-          <a:noFill/>
-          <a:ln/>
-        </p:spPr>
-        <p:txBody>
-          <a:bodyPr wrap="square" lIns="0" tIns="0" rIns="0" bIns="0" rtlCol="0" anchor="t">
+            <a:off x="7799832" y="4974336"/>
+            <a:ext cx="3145536" cy="576072"/>
+          </a:xfrm>
+          <a:prstGeom prst="rect">
+            <a:avLst/>
+          </a:prstGeom>
+          <a:noFill/>
+          <a:ln/>
+        </p:spPr>
+        <p:txBody>
+          <a:bodyPr wrap="square" lIns="254" tIns="254" rIns="254" bIns="254" rtlCol="0" anchor="t">
             <a:normAutofit/>
           </a:bodyPr>
           <a:lstStyle/>
@@ -11163,7 +11324,7 @@
               <a:buNone/>
             </a:pPr>
             <a:r>
-              <a:rPr lang="en-US" sz="1550" dirty="0">
+              <a:rPr lang="en-US" sz="1320" dirty="0">
                 <a:solidFill>
                   <a:srgbClr val="17364A"/>
                 </a:solidFill>
@@ -11171,9 +11332,9 @@
                 <a:ea typeface="Aptos" pitchFamily="34" charset="-122"/>
                 <a:cs typeface="Aptos" pitchFamily="34" charset="-120"/>
               </a:rPr>
-              <a:t>Use the assignment to test whether you can explain the concept, apply it to a realistic public health situation, and identify what would need review before the work moves forward.</a:t>
-            </a:r>
-            <a:endParaRPr lang="en-US" sz="1550" dirty="0"/>
+              <a:t>Use the assignment to test whether you can explain the concept, apply it to a realistic public health situation, and.</a:t>
+            </a:r>
+            <a:endParaRPr lang="en-US" sz="1320" dirty="0"/>
           </a:p>
         </p:txBody>
       </p:sp>
@@ -11474,49 +11635,58 @@
           <a:ln/>
         </p:spPr>
         <p:txBody>
-          <a:bodyPr wrap="square" lIns="635" tIns="635" rIns="635" bIns="635" rtlCol="0" anchor="t">
+          <a:bodyPr wrap="square" lIns="1016" tIns="1016" rIns="1016" bIns="1016" rtlCol="0" anchor="t">
             <a:normAutofit/>
           </a:bodyPr>
           <a:lstStyle/>
           <a:p>
+            <a:pPr indent="0" marL="0">
+              <a:buNone/>
+            </a:pPr>
             <a:r>
               <a:rPr lang="en-US" sz="2100" dirty="0">
                 <a:solidFill>
-                  <a:srgbClr val="17364A"/>
-                </a:solidFill>
-                <a:latin typeface="Aptos" pitchFamily="34" charset="0"/>
-                <a:ea typeface="Aptos" pitchFamily="34" charset="-122"/>
-                <a:cs typeface="Aptos" pitchFamily="34" charset="-120"/>
-              </a:rPr>
-              <a:t>1. What is calibration?</a:t>
+                  <a:srgbClr val="003A63"/>
+                </a:solidFill>
+                <a:latin typeface="Aptos" pitchFamily="34" charset="0"/>
+                <a:ea typeface="Aptos" pitchFamily="34" charset="-122"/>
+                <a:cs typeface="Aptos" pitchFamily="34" charset="-120"/>
+              </a:rPr>
+              <a:t>• 1. What is calibration?</a:t>
             </a:r>
             <a:endParaRPr lang="en-US" sz="2100" dirty="0"/>
           </a:p>
           <a:p>
+            <a:pPr indent="0" marL="0">
+              <a:buNone/>
+            </a:pPr>
             <a:r>
               <a:rPr lang="en-US" sz="2100" dirty="0">
                 <a:solidFill>
-                  <a:srgbClr val="17364A"/>
-                </a:solidFill>
-                <a:latin typeface="Aptos" pitchFamily="34" charset="0"/>
-                <a:ea typeface="Aptos" pitchFamily="34" charset="-122"/>
-                <a:cs typeface="Aptos" pitchFamily="34" charset="-120"/>
-              </a:rPr>
-              <a:t>2. Why should thresholds be reviewed by public health staff?</a:t>
+                  <a:srgbClr val="003A63"/>
+                </a:solidFill>
+                <a:latin typeface="Aptos" pitchFamily="34" charset="0"/>
+                <a:ea typeface="Aptos" pitchFamily="34" charset="-122"/>
+                <a:cs typeface="Aptos" pitchFamily="34" charset="-120"/>
+              </a:rPr>
+              <a:t>• 2. Why should thresholds be reviewed by public health staff?</a:t>
             </a:r>
             <a:endParaRPr lang="en-US" sz="2100" dirty="0"/>
           </a:p>
           <a:p>
+            <a:pPr indent="0" marL="0">
+              <a:buNone/>
+            </a:pPr>
             <a:r>
               <a:rPr lang="en-US" sz="2100" dirty="0">
                 <a:solidFill>
-                  <a:srgbClr val="17364A"/>
-                </a:solidFill>
-                <a:latin typeface="Aptos" pitchFamily="34" charset="0"/>
-                <a:ea typeface="Aptos" pitchFamily="34" charset="-122"/>
-                <a:cs typeface="Aptos" pitchFamily="34" charset="-120"/>
-              </a:rPr>
-              <a:t>3. Which use of a risk score is most concerning without additional safeguards?</a:t>
+                  <a:srgbClr val="003A63"/>
+                </a:solidFill>
+                <a:latin typeface="Aptos" pitchFamily="34" charset="0"/>
+                <a:ea typeface="Aptos" pitchFamily="34" charset="-122"/>
+                <a:cs typeface="Aptos" pitchFamily="34" charset="-120"/>
+              </a:rPr>
+              <a:t>• 3. Which use of a risk score is most concerning without additional safeguards?</a:t>
             </a:r>
             <a:endParaRPr lang="en-US" sz="2100" dirty="0"/>
           </a:p>
@@ -11596,17 +11766,17 @@
         </p:nvSpPr>
         <p:spPr>
           <a:xfrm>
-            <a:off x="7799832" y="1828800"/>
-            <a:ext cx="3145536" cy="685800"/>
-          </a:xfrm>
-          <a:prstGeom prst="rect">
-            <a:avLst/>
-          </a:prstGeom>
-          <a:noFill/>
-          <a:ln/>
-        </p:spPr>
-        <p:txBody>
-          <a:bodyPr wrap="square" lIns="0" tIns="0" rIns="0" bIns="0" rtlCol="0" anchor="t">
+            <a:off x="7799832" y="1801368"/>
+            <a:ext cx="3145536" cy="758952"/>
+          </a:xfrm>
+          <a:prstGeom prst="rect">
+            <a:avLst/>
+          </a:prstGeom>
+          <a:noFill/>
+          <a:ln/>
+        </p:spPr>
+        <p:txBody>
+          <a:bodyPr wrap="square" lIns="254" tIns="254" rIns="254" bIns="254" rtlCol="0" anchor="t">
             <a:normAutofit/>
           </a:bodyPr>
           <a:lstStyle/>
@@ -11615,7 +11785,7 @@
               <a:buNone/>
             </a:pPr>
             <a:r>
-              <a:rPr lang="en-US" sz="1550" dirty="0">
+              <a:rPr lang="en-US" sz="1320" dirty="0">
                 <a:solidFill>
                   <a:srgbClr val="17364A"/>
                 </a:solidFill>
@@ -11625,7 +11795,7 @@
               </a:rPr>
               <a:t>1. What is calibration?</a:t>
             </a:r>
-            <a:endParaRPr lang="en-US" sz="1550" dirty="0"/>
+            <a:endParaRPr lang="en-US" sz="1320" dirty="0"/>
           </a:p>
         </p:txBody>
       </p:sp>
@@ -11713,13 +11883,16 @@
           <a:ln/>
         </p:spPr>
         <p:txBody>
-          <a:bodyPr wrap="square" lIns="254" tIns="254" rIns="254" bIns="254" rtlCol="0" anchor="t">
+          <a:bodyPr wrap="square" lIns="508" tIns="508" rIns="508" bIns="508" rtlCol="0" anchor="t">
             <a:normAutofit/>
           </a:bodyPr>
           <a:lstStyle/>
           <a:p>
-            <a:r>
-              <a:rPr lang="en-US" sz="1380" dirty="0">
+            <a:pPr indent="0" marL="0">
+              <a:buNone/>
+            </a:pPr>
+            <a:r>
+              <a:rPr lang="en-US" sz="1220" dirty="0">
                 <a:solidFill>
                   <a:srgbClr val="17364A"/>
                 </a:solidFill>
@@ -11729,11 +11902,14 @@
               </a:rPr>
               <a:t>1.</a:t>
             </a:r>
-            <a:endParaRPr lang="en-US" sz="1380" dirty="0"/>
-          </a:p>
-          <a:p>
-            <a:r>
-              <a:rPr lang="en-US" sz="1380" dirty="0">
+            <a:endParaRPr lang="en-US" sz="1220" dirty="0"/>
+          </a:p>
+          <a:p>
+            <a:pPr indent="0" marL="0">
+              <a:buNone/>
+            </a:pPr>
+            <a:r>
+              <a:rPr lang="en-US" sz="1220" dirty="0">
                 <a:solidFill>
                   <a:srgbClr val="17364A"/>
                 </a:solidFill>
@@ -11743,11 +11919,14 @@
               </a:rPr>
               <a:t>What is calibration?</a:t>
             </a:r>
-            <a:endParaRPr lang="en-US" sz="1380" dirty="0"/>
-          </a:p>
-          <a:p>
-            <a:r>
-              <a:rPr lang="en-US" sz="1380" dirty="0">
+            <a:endParaRPr lang="en-US" sz="1220" dirty="0"/>
+          </a:p>
+          <a:p>
+            <a:pPr indent="0" marL="0">
+              <a:buNone/>
+            </a:pPr>
+            <a:r>
+              <a:rPr lang="en-US" sz="1220" dirty="0">
                 <a:solidFill>
                   <a:srgbClr val="17364A"/>
                 </a:solidFill>
@@ -11757,7 +11936,7 @@
               </a:rPr>
               <a:t>2.</a:t>
             </a:r>
-            <a:endParaRPr lang="en-US" sz="1380" dirty="0"/>
+            <a:endParaRPr lang="en-US" sz="1220" dirty="0"/>
           </a:p>
         </p:txBody>
       </p:sp>
@@ -11835,17 +12014,17 @@
         </p:nvSpPr>
         <p:spPr>
           <a:xfrm>
-            <a:off x="7799832" y="5001768"/>
-            <a:ext cx="3145536" cy="502920"/>
-          </a:xfrm>
-          <a:prstGeom prst="rect">
-            <a:avLst/>
-          </a:prstGeom>
-          <a:noFill/>
-          <a:ln/>
-        </p:spPr>
-        <p:txBody>
-          <a:bodyPr wrap="square" lIns="0" tIns="0" rIns="0" bIns="0" rtlCol="0" anchor="t">
+            <a:off x="7799832" y="4974336"/>
+            <a:ext cx="3145536" cy="576072"/>
+          </a:xfrm>
+          <a:prstGeom prst="rect">
+            <a:avLst/>
+          </a:prstGeom>
+          <a:noFill/>
+          <a:ln/>
+        </p:spPr>
+        <p:txBody>
+          <a:bodyPr wrap="square" lIns="254" tIns="254" rIns="254" bIns="254" rtlCol="0" anchor="t">
             <a:normAutofit/>
           </a:bodyPr>
           <a:lstStyle/>
@@ -11854,7 +12033,7 @@
               <a:buNone/>
             </a:pPr>
             <a:r>
-              <a:rPr lang="en-US" sz="1550" dirty="0">
+              <a:rPr lang="en-US" sz="1320" dirty="0">
                 <a:solidFill>
                   <a:srgbClr val="17364A"/>
                 </a:solidFill>
@@ -11862,9 +12041,9 @@
                 <a:ea typeface="Aptos" pitchFamily="34" charset="-122"/>
                 <a:cs typeface="Aptos" pitchFamily="34" charset="-120"/>
               </a:rPr>
-              <a:t>Use the assignment to test whether you can explain the concept, apply it to a realistic public health situation, and identify what would need review before the work moves forward.</a:t>
-            </a:r>
-            <a:endParaRPr lang="en-US" sz="1550" dirty="0"/>
+              <a:t>Use the assignment to test whether you can explain the concept, apply it to a realistic public health situation, and.</a:t>
+            </a:r>
+            <a:endParaRPr lang="en-US" sz="1320" dirty="0"/>
           </a:p>
         </p:txBody>
       </p:sp>
@@ -12165,49 +12344,58 @@
           <a:ln/>
         </p:spPr>
         <p:txBody>
-          <a:bodyPr wrap="square" lIns="635" tIns="635" rIns="635" bIns="635" rtlCol="0" anchor="t">
+          <a:bodyPr wrap="square" lIns="1016" tIns="1016" rIns="1016" bIns="1016" rtlCol="0" anchor="t">
             <a:normAutofit/>
           </a:bodyPr>
           <a:lstStyle/>
           <a:p>
+            <a:pPr indent="0" marL="0">
+              <a:buNone/>
+            </a:pPr>
             <a:r>
               <a:rPr lang="en-US" sz="2100" dirty="0">
                 <a:solidFill>
-                  <a:srgbClr val="17364A"/>
-                </a:solidFill>
-                <a:latin typeface="Aptos" pitchFamily="34" charset="0"/>
-                <a:ea typeface="Aptos" pitchFamily="34" charset="-122"/>
-                <a:cs typeface="Aptos" pitchFamily="34" charset="-120"/>
-              </a:rPr>
-              <a:t>NIST Artificial Intelligence Risk Management Framework:.</a:t>
+                  <a:srgbClr val="003A63"/>
+                </a:solidFill>
+                <a:latin typeface="Aptos" pitchFamily="34" charset="0"/>
+                <a:ea typeface="Aptos" pitchFamily="34" charset="-122"/>
+                <a:cs typeface="Aptos" pitchFamily="34" charset="-120"/>
+              </a:rPr>
+              <a:t>• NIST Artificial Intelligence Risk Management Framework:.</a:t>
             </a:r>
             <a:endParaRPr lang="en-US" sz="2100" dirty="0"/>
           </a:p>
           <a:p>
+            <a:pPr indent="0" marL="0">
+              <a:buNone/>
+            </a:pPr>
             <a:r>
               <a:rPr lang="en-US" sz="2100" dirty="0">
                 <a:solidFill>
-                  <a:srgbClr val="17364A"/>
-                </a:solidFill>
-                <a:latin typeface="Aptos" pitchFamily="34" charset="0"/>
-                <a:ea typeface="Aptos" pitchFamily="34" charset="-122"/>
-                <a:cs typeface="Aptos" pitchFamily="34" charset="-120"/>
-              </a:rPr>
-              <a:t>NIST AI RMF Generative AI Profile:.</a:t>
+                  <a:srgbClr val="003A63"/>
+                </a:solidFill>
+                <a:latin typeface="Aptos" pitchFamily="34" charset="0"/>
+                <a:ea typeface="Aptos" pitchFamily="34" charset="-122"/>
+                <a:cs typeface="Aptos" pitchFamily="34" charset="-120"/>
+              </a:rPr>
+              <a:t>• NIST AI RMF Generative AI Profile:.</a:t>
             </a:r>
             <a:endParaRPr lang="en-US" sz="2100" dirty="0"/>
           </a:p>
           <a:p>
+            <a:pPr indent="0" marL="0">
+              <a:buNone/>
+            </a:pPr>
             <a:r>
               <a:rPr lang="en-US" sz="2100" dirty="0">
                 <a:solidFill>
-                  <a:srgbClr val="17364A"/>
-                </a:solidFill>
-                <a:latin typeface="Aptos" pitchFamily="34" charset="0"/>
-                <a:ea typeface="Aptos" pitchFamily="34" charset="-122"/>
-                <a:cs typeface="Aptos" pitchFamily="34" charset="-120"/>
-              </a:rPr>
-              <a:t>CDC Evaluation Framework: https://www.cdc.gov/evaluation/</a:t>
+                  <a:srgbClr val="003A63"/>
+                </a:solidFill>
+                <a:latin typeface="Aptos" pitchFamily="34" charset="0"/>
+                <a:ea typeface="Aptos" pitchFamily="34" charset="-122"/>
+                <a:cs typeface="Aptos" pitchFamily="34" charset="-120"/>
+              </a:rPr>
+              <a:t>• CDC Evaluation Framework: https://www.cdc.gov/evaluation/</a:t>
             </a:r>
             <a:endParaRPr lang="en-US" sz="2100" dirty="0"/>
           </a:p>
@@ -12287,17 +12475,17 @@
         </p:nvSpPr>
         <p:spPr>
           <a:xfrm>
-            <a:off x="7799832" y="1828800"/>
-            <a:ext cx="3145536" cy="685800"/>
-          </a:xfrm>
-          <a:prstGeom prst="rect">
-            <a:avLst/>
-          </a:prstGeom>
-          <a:noFill/>
-          <a:ln/>
-        </p:spPr>
-        <p:txBody>
-          <a:bodyPr wrap="square" lIns="0" tIns="0" rIns="0" bIns="0" rtlCol="0" anchor="t">
+            <a:off x="7799832" y="1801368"/>
+            <a:ext cx="3145536" cy="758952"/>
+          </a:xfrm>
+          <a:prstGeom prst="rect">
+            <a:avLst/>
+          </a:prstGeom>
+          <a:noFill/>
+          <a:ln/>
+        </p:spPr>
+        <p:txBody>
+          <a:bodyPr wrap="square" lIns="254" tIns="254" rIns="254" bIns="254" rtlCol="0" anchor="t">
             <a:normAutofit/>
           </a:bodyPr>
           <a:lstStyle/>
@@ -12306,7 +12494,7 @@
               <a:buNone/>
             </a:pPr>
             <a:r>
-              <a:rPr lang="en-US" sz="1550" dirty="0">
+              <a:rPr lang="en-US" sz="1320" dirty="0">
                 <a:solidFill>
                   <a:srgbClr val="17364A"/>
                 </a:solidFill>
@@ -12316,7 +12504,7 @@
               </a:rPr>
               <a:t>NIST Artificial Intelligence Risk Management Framework:.</a:t>
             </a:r>
-            <a:endParaRPr lang="en-US" sz="1550" dirty="0"/>
+            <a:endParaRPr lang="en-US" sz="1320" dirty="0"/>
           </a:p>
         </p:txBody>
       </p:sp>
@@ -12404,13 +12592,16 @@
           <a:ln/>
         </p:spPr>
         <p:txBody>
-          <a:bodyPr wrap="square" lIns="254" tIns="254" rIns="254" bIns="254" rtlCol="0" anchor="t">
+          <a:bodyPr wrap="square" lIns="508" tIns="508" rIns="508" bIns="508" rtlCol="0" anchor="t">
             <a:normAutofit/>
           </a:bodyPr>
           <a:lstStyle/>
           <a:p>
-            <a:r>
-              <a:rPr lang="en-US" sz="1380" dirty="0">
+            <a:pPr indent="0" marL="0">
+              <a:buNone/>
+            </a:pPr>
+            <a:r>
+              <a:rPr lang="en-US" sz="1220" dirty="0">
                 <a:solidFill>
                   <a:srgbClr val="17364A"/>
                 </a:solidFill>
@@ -12420,11 +12611,14 @@
               </a:rPr>
               <a:t>NIST Artificial Intelligence Risk Management Framework:.</a:t>
             </a:r>
-            <a:endParaRPr lang="en-US" sz="1380" dirty="0"/>
-          </a:p>
-          <a:p>
-            <a:r>
-              <a:rPr lang="en-US" sz="1380" dirty="0">
+            <a:endParaRPr lang="en-US" sz="1220" dirty="0"/>
+          </a:p>
+          <a:p>
+            <a:pPr indent="0" marL="0">
+              <a:buNone/>
+            </a:pPr>
+            <a:r>
+              <a:rPr lang="en-US" sz="1220" dirty="0">
                 <a:solidFill>
                   <a:srgbClr val="17364A"/>
                 </a:solidFill>
@@ -12434,7 +12628,7 @@
               </a:rPr>
               <a:t>CDC Public Health Data Strategy:.</a:t>
             </a:r>
-            <a:endParaRPr lang="en-US" sz="1380" dirty="0"/>
+            <a:endParaRPr lang="en-US" sz="1220" dirty="0"/>
           </a:p>
         </p:txBody>
       </p:sp>
@@ -12512,17 +12706,17 @@
         </p:nvSpPr>
         <p:spPr>
           <a:xfrm>
-            <a:off x="7799832" y="5001768"/>
-            <a:ext cx="3145536" cy="502920"/>
-          </a:xfrm>
-          <a:prstGeom prst="rect">
-            <a:avLst/>
-          </a:prstGeom>
-          <a:noFill/>
-          <a:ln/>
-        </p:spPr>
-        <p:txBody>
-          <a:bodyPr wrap="square" lIns="0" tIns="0" rIns="0" bIns="0" rtlCol="0" anchor="t">
+            <a:off x="7799832" y="4974336"/>
+            <a:ext cx="3145536" cy="576072"/>
+          </a:xfrm>
+          <a:prstGeom prst="rect">
+            <a:avLst/>
+          </a:prstGeom>
+          <a:noFill/>
+          <a:ln/>
+        </p:spPr>
+        <p:txBody>
+          <a:bodyPr wrap="square" lIns="254" tIns="254" rIns="254" bIns="254" rtlCol="0" anchor="t">
             <a:normAutofit/>
           </a:bodyPr>
           <a:lstStyle/>
@@ -12531,7 +12725,7 @@
               <a:buNone/>
             </a:pPr>
             <a:r>
-              <a:rPr lang="en-US" sz="1550" dirty="0">
+              <a:rPr lang="en-US" sz="1320" dirty="0">
                 <a:solidFill>
                   <a:srgbClr val="17364A"/>
                 </a:solidFill>
@@ -12539,9 +12733,9 @@
                 <a:ea typeface="Aptos" pitchFamily="34" charset="-122"/>
                 <a:cs typeface="Aptos" pitchFamily="34" charset="-120"/>
               </a:rPr>
-              <a:t>Identify what could go wrong, who could be affected, what safeguards are needed, and what evidence should be reviewed before use expands.</a:t>
-            </a:r>
-            <a:endParaRPr lang="en-US" sz="1550" dirty="0"/>
+              <a:t>Identify what could go wrong, who could be affected, what safeguards are needed, and what evidence should be reviewed.</a:t>
+            </a:r>
+            <a:endParaRPr lang="en-US" sz="1320" dirty="0"/>
           </a:p>
         </p:txBody>
       </p:sp>
@@ -12842,63 +13036,75 @@
           <a:ln/>
         </p:spPr>
         <p:txBody>
-          <a:bodyPr wrap="square" lIns="635" tIns="635" rIns="635" bIns="635" rtlCol="0" anchor="t">
+          <a:bodyPr wrap="square" lIns="1016" tIns="1016" rIns="1016" bIns="1016" rtlCol="0" anchor="t">
             <a:normAutofit/>
           </a:bodyPr>
           <a:lstStyle/>
           <a:p>
+            <a:pPr indent="0" marL="0">
+              <a:buNone/>
+            </a:pPr>
             <a:r>
               <a:rPr lang="en-US" sz="1900" dirty="0">
                 <a:solidFill>
-                  <a:srgbClr val="17364A"/>
-                </a:solidFill>
-                <a:latin typeface="Aptos" pitchFamily="34" charset="0"/>
-                <a:ea typeface="Aptos" pitchFamily="34" charset="-122"/>
-                <a:cs typeface="Aptos" pitchFamily="34" charset="-120"/>
-              </a:rPr>
-              <a:t>Play 13: Monitor and Evaluate AI Systems - This lesson informs Play 13 by helping learners connect the.</a:t>
+                  <a:srgbClr val="003A63"/>
+                </a:solidFill>
+                <a:latin typeface="Aptos" pitchFamily="34" charset="0"/>
+                <a:ea typeface="Aptos" pitchFamily="34" charset="-122"/>
+                <a:cs typeface="Aptos" pitchFamily="34" charset="-120"/>
+              </a:rPr>
+              <a:t>• Play 13: Monitor and Evaluate AI Systems - This lesson informs Play 13 by helping learners.</a:t>
             </a:r>
             <a:endParaRPr lang="en-US" sz="1900" dirty="0"/>
           </a:p>
           <a:p>
+            <a:pPr indent="0" marL="0">
+              <a:buNone/>
+            </a:pPr>
             <a:r>
               <a:rPr lang="en-US" sz="1900" dirty="0">
                 <a:solidFill>
-                  <a:srgbClr val="17364A"/>
-                </a:solidFill>
-                <a:latin typeface="Aptos" pitchFamily="34" charset="0"/>
-                <a:ea typeface="Aptos" pitchFamily="34" charset="-122"/>
-                <a:cs typeface="Aptos" pitchFamily="34" charset="-120"/>
-              </a:rPr>
-              <a:t>Play 1: Vision &amp; Guardrails - This lesson informs Play 1 by helping learners connect the lesson topic to.</a:t>
+                  <a:srgbClr val="003A63"/>
+                </a:solidFill>
+                <a:latin typeface="Aptos" pitchFamily="34" charset="0"/>
+                <a:ea typeface="Aptos" pitchFamily="34" charset="-122"/>
+                <a:cs typeface="Aptos" pitchFamily="34" charset="-120"/>
+              </a:rPr>
+              <a:t>• Play 1: Vision &amp; Guardrails - This lesson informs Play 1 by helping learners connect the.</a:t>
             </a:r>
             <a:endParaRPr lang="en-US" sz="1900" dirty="0"/>
           </a:p>
           <a:p>
+            <a:pPr indent="0" marL="0">
+              <a:buNone/>
+            </a:pPr>
             <a:r>
               <a:rPr lang="en-US" sz="1900" dirty="0">
                 <a:solidFill>
-                  <a:srgbClr val="17364A"/>
-                </a:solidFill>
-                <a:latin typeface="Aptos" pitchFamily="34" charset="0"/>
-                <a:ea typeface="Aptos" pitchFamily="34" charset="-122"/>
-                <a:cs typeface="Aptos" pitchFamily="34" charset="-120"/>
-              </a:rPr>
-              <a:t>Play 11: Build and Deploy AI Solutions - This lesson informs Play 11 by helping learners connect the lesson.</a:t>
+                  <a:srgbClr val="003A63"/>
+                </a:solidFill>
+                <a:latin typeface="Aptos" pitchFamily="34" charset="0"/>
+                <a:ea typeface="Aptos" pitchFamily="34" charset="-122"/>
+                <a:cs typeface="Aptos" pitchFamily="34" charset="-120"/>
+              </a:rPr>
+              <a:t>• Play 11: Build and Deploy AI Solutions - This lesson informs Play 11 by helping learners.</a:t>
             </a:r>
             <a:endParaRPr lang="en-US" sz="1900" dirty="0"/>
           </a:p>
           <a:p>
+            <a:pPr indent="0" marL="0">
+              <a:buNone/>
+            </a:pPr>
             <a:r>
               <a:rPr lang="en-US" sz="1900" dirty="0">
                 <a:solidFill>
-                  <a:srgbClr val="17364A"/>
-                </a:solidFill>
-                <a:latin typeface="Aptos" pitchFamily="34" charset="0"/>
-                <a:ea typeface="Aptos" pitchFamily="34" charset="-122"/>
-                <a:cs typeface="Aptos" pitchFamily="34" charset="-120"/>
-              </a:rPr>
-              <a:t>Play 3: Establish AI Governance - This lesson informs Play 3 by helping learners connect the lesson topic to.</a:t>
+                  <a:srgbClr val="003A63"/>
+                </a:solidFill>
+                <a:latin typeface="Aptos" pitchFamily="34" charset="0"/>
+                <a:ea typeface="Aptos" pitchFamily="34" charset="-122"/>
+                <a:cs typeface="Aptos" pitchFamily="34" charset="-120"/>
+              </a:rPr>
+              <a:t>• Play 3: Establish AI Governance - This lesson informs Play 3 by helping learners connect the.</a:t>
             </a:r>
             <a:endParaRPr lang="en-US" sz="1900" dirty="0"/>
           </a:p>
@@ -12978,17 +13184,17 @@
         </p:nvSpPr>
         <p:spPr>
           <a:xfrm>
-            <a:off x="8211312" y="1920240"/>
-            <a:ext cx="2734056" cy="1463040"/>
-          </a:xfrm>
-          <a:prstGeom prst="rect">
-            <a:avLst/>
-          </a:prstGeom>
-          <a:noFill/>
-          <a:ln/>
-        </p:spPr>
-        <p:txBody>
-          <a:bodyPr wrap="square" lIns="0" tIns="0" rIns="0" bIns="0" rtlCol="0" anchor="t">
+            <a:off x="8211312" y="1892808"/>
+            <a:ext cx="2734056" cy="1536192"/>
+          </a:xfrm>
+          <a:prstGeom prst="rect">
+            <a:avLst/>
+          </a:prstGeom>
+          <a:noFill/>
+          <a:ln/>
+        </p:spPr>
+        <p:txBody>
+          <a:bodyPr wrap="square" lIns="254" tIns="254" rIns="254" bIns="254" rtlCol="0" anchor="t">
             <a:normAutofit/>
           </a:bodyPr>
           <a:lstStyle/>
@@ -12997,7 +13203,7 @@
               <a:buNone/>
             </a:pPr>
             <a:r>
-              <a:rPr lang="en-US" sz="1550" dirty="0">
+              <a:rPr lang="en-US" sz="1320" dirty="0">
                 <a:solidFill>
                   <a:srgbClr val="17364A"/>
                 </a:solidFill>
@@ -13005,9 +13211,9 @@
                 <a:ea typeface="Aptos" pitchFamily="34" charset="-122"/>
                 <a:cs typeface="Aptos" pitchFamily="34" charset="-120"/>
               </a:rPr>
-              <a:t>Use the related plays to identify decisions, participants, timing, approvals, and documentation needed for responsible implementation.</a:t>
-            </a:r>
-            <a:endParaRPr lang="en-US" sz="1550" dirty="0"/>
+              <a:t>Use the related plays to identify decisions, participants, timing, approvals, and documentation needed for responsible.</a:t>
+            </a:r>
+            <a:endParaRPr lang="en-US" sz="1320" dirty="0"/>
           </a:p>
         </p:txBody>
       </p:sp>
@@ -13095,13 +13301,16 @@
           <a:ln/>
         </p:spPr>
         <p:txBody>
-          <a:bodyPr wrap="square" lIns="254" tIns="254" rIns="254" bIns="254" rtlCol="0" anchor="t">
+          <a:bodyPr wrap="square" lIns="508" tIns="508" rIns="508" bIns="508" rtlCol="0" anchor="t">
             <a:normAutofit/>
           </a:bodyPr>
           <a:lstStyle/>
           <a:p>
-            <a:r>
-              <a:rPr lang="en-US" sz="1380" dirty="0">
+            <a:pPr indent="0" marL="0">
+              <a:buNone/>
+            </a:pPr>
+            <a:r>
+              <a:rPr lang="en-US" sz="1220" dirty="0">
                 <a:solidFill>
                   <a:srgbClr val="17364A"/>
                 </a:solidFill>
@@ -13111,11 +13320,14 @@
               </a:rPr>
               <a:t>Locate the decision point in the playbook sequence.</a:t>
             </a:r>
-            <a:endParaRPr lang="en-US" sz="1380" dirty="0"/>
-          </a:p>
-          <a:p>
-            <a:r>
-              <a:rPr lang="en-US" sz="1380" dirty="0">
+            <a:endParaRPr lang="en-US" sz="1220" dirty="0"/>
+          </a:p>
+          <a:p>
+            <a:pPr indent="0" marL="0">
+              <a:buNone/>
+            </a:pPr>
+            <a:r>
+              <a:rPr lang="en-US" sz="1220" dirty="0">
                 <a:solidFill>
                   <a:srgbClr val="17364A"/>
                 </a:solidFill>
@@ -13125,11 +13337,14 @@
               </a:rPr>
               <a:t>Identify who should participate in the work.</a:t>
             </a:r>
-            <a:endParaRPr lang="en-US" sz="1380" dirty="0"/>
-          </a:p>
-          <a:p>
-            <a:r>
-              <a:rPr lang="en-US" sz="1380" dirty="0">
+            <a:endParaRPr lang="en-US" sz="1220" dirty="0"/>
+          </a:p>
+          <a:p>
+            <a:pPr indent="0" marL="0">
+              <a:buNone/>
+            </a:pPr>
+            <a:r>
+              <a:rPr lang="en-US" sz="1220" dirty="0">
                 <a:solidFill>
                   <a:srgbClr val="17364A"/>
                 </a:solidFill>
@@ -13139,7 +13354,7 @@
               </a:rPr>
               <a:t>Document the review, approval, or implementation step.</a:t>
             </a:r>
-            <a:endParaRPr lang="en-US" sz="1380" dirty="0"/>
+            <a:endParaRPr lang="en-US" sz="1220" dirty="0"/>
           </a:p>
         </p:txBody>
       </p:sp>
@@ -13440,63 +13655,75 @@
           <a:ln/>
         </p:spPr>
         <p:txBody>
-          <a:bodyPr wrap="square" lIns="635" tIns="635" rIns="635" bIns="635" rtlCol="0" anchor="t">
+          <a:bodyPr wrap="square" lIns="1016" tIns="1016" rIns="1016" bIns="1016" rtlCol="0" anchor="t">
             <a:normAutofit/>
           </a:bodyPr>
           <a:lstStyle/>
           <a:p>
+            <a:pPr indent="0" marL="0">
+              <a:buNone/>
+            </a:pPr>
             <a:r>
               <a:rPr lang="en-US" sz="1850" dirty="0">
                 <a:solidFill>
-                  <a:srgbClr val="17364A"/>
-                </a:solidFill>
-                <a:latin typeface="Aptos" pitchFamily="34" charset="0"/>
-                <a:ea typeface="Aptos" pitchFamily="34" charset="-122"/>
-                <a:cs typeface="Aptos" pitchFamily="34" charset="-120"/>
-              </a:rPr>
-              <a:t>Tool 44: Performance Monitoring Dashboard (Dashboard) - Use this tool to complete or strengthen the.</a:t>
+                  <a:srgbClr val="003A63"/>
+                </a:solidFill>
+                <a:latin typeface="Aptos" pitchFamily="34" charset="0"/>
+                <a:ea typeface="Aptos" pitchFamily="34" charset="-122"/>
+                <a:cs typeface="Aptos" pitchFamily="34" charset="-120"/>
+              </a:rPr>
+              <a:t>• Tool 44: Performance Monitoring Dashboard (Dashboard) - Use this tool to complete or.</a:t>
             </a:r>
             <a:endParaRPr lang="en-US" sz="1850" dirty="0"/>
           </a:p>
           <a:p>
+            <a:pPr indent="0" marL="0">
+              <a:buNone/>
+            </a:pPr>
             <a:r>
               <a:rPr lang="en-US" sz="1850" dirty="0">
                 <a:solidFill>
-                  <a:srgbClr val="17364A"/>
-                </a:solidFill>
-                <a:latin typeface="Aptos" pitchFamily="34" charset="0"/>
-                <a:ea typeface="Aptos" pitchFamily="34" charset="-122"/>
-                <a:cs typeface="Aptos" pitchFamily="34" charset="-120"/>
-              </a:rPr>
-              <a:t>Tool 45: Continuous Improvement Log (Log) - Use Continuous Improvement Log to translate this lesson into a.</a:t>
+                  <a:srgbClr val="003A63"/>
+                </a:solidFill>
+                <a:latin typeface="Aptos" pitchFamily="34" charset="0"/>
+                <a:ea typeface="Aptos" pitchFamily="34" charset="-122"/>
+                <a:cs typeface="Aptos" pitchFamily="34" charset="-120"/>
+              </a:rPr>
+              <a:t>• Tool 45: Continuous Improvement Log (Log) - Use Continuous Improvement Log to translate this.</a:t>
             </a:r>
             <a:endParaRPr lang="en-US" sz="1850" dirty="0"/>
           </a:p>
           <a:p>
+            <a:pPr indent="0" marL="0">
+              <a:buNone/>
+            </a:pPr>
             <a:r>
               <a:rPr lang="en-US" sz="1850" dirty="0">
                 <a:solidFill>
-                  <a:srgbClr val="17364A"/>
-                </a:solidFill>
-                <a:latin typeface="Aptos" pitchFamily="34" charset="0"/>
-                <a:ea typeface="Aptos" pitchFamily="34" charset="-122"/>
-                <a:cs typeface="Aptos" pitchFamily="34" charset="-120"/>
-              </a:rPr>
-              <a:t>Tool 48: AI Evaluation &amp; Outcomes Reporting (Template) - Use this tool to complete or strengthen the.</a:t>
+                  <a:srgbClr val="003A63"/>
+                </a:solidFill>
+                <a:latin typeface="Aptos" pitchFamily="34" charset="0"/>
+                <a:ea typeface="Aptos" pitchFamily="34" charset="-122"/>
+                <a:cs typeface="Aptos" pitchFamily="34" charset="-120"/>
+              </a:rPr>
+              <a:t>• Tool 48: AI Evaluation &amp; Outcomes Reporting (Template) - Use this tool to complete or.</a:t>
             </a:r>
             <a:endParaRPr lang="en-US" sz="1850" dirty="0"/>
           </a:p>
           <a:p>
+            <a:pPr indent="0" marL="0">
+              <a:buNone/>
+            </a:pPr>
             <a:r>
               <a:rPr lang="en-US" sz="1850" dirty="0">
                 <a:solidFill>
-                  <a:srgbClr val="17364A"/>
-                </a:solidFill>
-                <a:latin typeface="Aptos" pitchFamily="34" charset="0"/>
-                <a:ea typeface="Aptos" pitchFamily="34" charset="-122"/>
-                <a:cs typeface="Aptos" pitchFamily="34" charset="-120"/>
-              </a:rPr>
-              <a:t>Tool 1: AI Vision &amp; Principles Workshop (Workshop) - Use AI Vision &amp; Principles Workshop to translate this.</a:t>
+                  <a:srgbClr val="003A63"/>
+                </a:solidFill>
+                <a:latin typeface="Aptos" pitchFamily="34" charset="0"/>
+                <a:ea typeface="Aptos" pitchFamily="34" charset="-122"/>
+                <a:cs typeface="Aptos" pitchFamily="34" charset="-120"/>
+              </a:rPr>
+              <a:t>• Tool 1: AI Vision &amp; Principles Workshop (Workshop) - Use AI Vision &amp; Principles Workshop to.</a:t>
             </a:r>
             <a:endParaRPr lang="en-US" sz="1850" dirty="0"/>
           </a:p>
@@ -13576,17 +13803,17 @@
         </p:nvSpPr>
         <p:spPr>
           <a:xfrm>
-            <a:off x="8211312" y="1920240"/>
-            <a:ext cx="2734056" cy="1463040"/>
-          </a:xfrm>
-          <a:prstGeom prst="rect">
-            <a:avLst/>
-          </a:prstGeom>
-          <a:noFill/>
-          <a:ln/>
-        </p:spPr>
-        <p:txBody>
-          <a:bodyPr wrap="square" lIns="0" tIns="0" rIns="0" bIns="0" rtlCol="0" anchor="t">
+            <a:off x="8211312" y="1892808"/>
+            <a:ext cx="2734056" cy="1536192"/>
+          </a:xfrm>
+          <a:prstGeom prst="rect">
+            <a:avLst/>
+          </a:prstGeom>
+          <a:noFill/>
+          <a:ln/>
+        </p:spPr>
+        <p:txBody>
+          <a:bodyPr wrap="square" lIns="254" tIns="254" rIns="254" bIns="254" rtlCol="0" anchor="t">
             <a:normAutofit/>
           </a:bodyPr>
           <a:lstStyle/>
@@ -13595,7 +13822,7 @@
               <a:buNone/>
             </a:pPr>
             <a:r>
-              <a:rPr lang="en-US" sz="1550" dirty="0">
+              <a:rPr lang="en-US" sz="1320" dirty="0">
                 <a:solidFill>
                   <a:srgbClr val="17364A"/>
                 </a:solidFill>
@@ -13603,9 +13830,9 @@
                 <a:ea typeface="Aptos" pitchFamily="34" charset="-122"/>
                 <a:cs typeface="Aptos" pitchFamily="34" charset="-120"/>
               </a:rPr>
-              <a:t>Use linked tools when your department needs a structured worksheet, template, checklist, review process, or documentation artifact.</a:t>
-            </a:r>
-            <a:endParaRPr lang="en-US" sz="1550" dirty="0"/>
+              <a:t>Use linked tools when your department needs a structured worksheet, template, checklist, review process, or.</a:t>
+            </a:r>
+            <a:endParaRPr lang="en-US" sz="1320" dirty="0"/>
           </a:p>
         </p:txBody>
       </p:sp>
@@ -13693,13 +13920,16 @@
           <a:ln/>
         </p:spPr>
         <p:txBody>
-          <a:bodyPr wrap="square" lIns="254" tIns="254" rIns="254" bIns="254" rtlCol="0" anchor="t">
+          <a:bodyPr wrap="square" lIns="508" tIns="508" rIns="508" bIns="508" rtlCol="0" anchor="t">
             <a:normAutofit/>
           </a:bodyPr>
           <a:lstStyle/>
           <a:p>
-            <a:r>
-              <a:rPr lang="en-US" sz="1380" dirty="0">
+            <a:pPr indent="0" marL="0">
+              <a:buNone/>
+            </a:pPr>
+            <a:r>
+              <a:rPr lang="en-US" sz="1220" dirty="0">
                 <a:solidFill>
                   <a:srgbClr val="17364A"/>
                 </a:solidFill>
@@ -13709,11 +13939,14 @@
               </a:rPr>
               <a:t>Use a tool when no comparable local process exists.</a:t>
             </a:r>
-            <a:endParaRPr lang="en-US" sz="1380" dirty="0"/>
-          </a:p>
-          <a:p>
-            <a:r>
-              <a:rPr lang="en-US" sz="1380" dirty="0">
+            <a:endParaRPr lang="en-US" sz="1220" dirty="0"/>
+          </a:p>
+          <a:p>
+            <a:pPr indent="0" marL="0">
+              <a:buNone/>
+            </a:pPr>
+            <a:r>
+              <a:rPr lang="en-US" sz="1220" dirty="0">
                 <a:solidFill>
                   <a:srgbClr val="17364A"/>
                 </a:solidFill>
@@ -13721,13 +13954,16 @@
                 <a:ea typeface="Aptos" pitchFamily="34" charset="-122"/>
                 <a:cs typeface="Aptos" pitchFamily="34" charset="-120"/>
               </a:rPr>
-              <a:t>Adapt existing department templates when they already fit the purpose.</a:t>
-            </a:r>
-            <a:endParaRPr lang="en-US" sz="1380" dirty="0"/>
-          </a:p>
-          <a:p>
-            <a:r>
-              <a:rPr lang="en-US" sz="1380" dirty="0">
+              <a:t>Adapt existing department templates when they already fit the.</a:t>
+            </a:r>
+            <a:endParaRPr lang="en-US" sz="1220" dirty="0"/>
+          </a:p>
+          <a:p>
+            <a:pPr indent="0" marL="0">
+              <a:buNone/>
+            </a:pPr>
+            <a:r>
+              <a:rPr lang="en-US" sz="1220" dirty="0">
                 <a:solidFill>
                   <a:srgbClr val="17364A"/>
                 </a:solidFill>
@@ -13737,7 +13973,7 @@
               </a:rPr>
               <a:t>Save the completed artifact as evidence of the decision.</a:t>
             </a:r>
-            <a:endParaRPr lang="en-US" sz="1380" dirty="0"/>
+            <a:endParaRPr lang="en-US" sz="1220" dirty="0"/>
           </a:p>
         </p:txBody>
       </p:sp>
@@ -14038,49 +14274,58 @@
           <a:ln/>
         </p:spPr>
         <p:txBody>
-          <a:bodyPr wrap="square" lIns="635" tIns="635" rIns="635" bIns="635" rtlCol="0" anchor="t">
+          <a:bodyPr wrap="square" lIns="1016" tIns="1016" rIns="1016" bIns="1016" rtlCol="0" anchor="t">
             <a:normAutofit/>
           </a:bodyPr>
           <a:lstStyle/>
           <a:p>
+            <a:pPr indent="0" marL="0">
+              <a:buNone/>
+            </a:pPr>
             <a:r>
               <a:rPr lang="en-US" sz="2100" dirty="0">
                 <a:solidFill>
-                  <a:srgbClr val="17364A"/>
-                </a:solidFill>
-                <a:latin typeface="Aptos" pitchFamily="34" charset="0"/>
-                <a:ea typeface="Aptos" pitchFamily="34" charset="-122"/>
-                <a:cs typeface="Aptos" pitchFamily="34" charset="-120"/>
-              </a:rPr>
-              <a:t>Define predictive analytics and risk stratification in public health terms.</a:t>
+                  <a:srgbClr val="003A63"/>
+                </a:solidFill>
+                <a:latin typeface="Aptos" pitchFamily="34" charset="0"/>
+                <a:ea typeface="Aptos" pitchFamily="34" charset="-122"/>
+                <a:cs typeface="Aptos" pitchFamily="34" charset="-120"/>
+              </a:rPr>
+              <a:t>• Define predictive analytics and risk stratification in public health terms.</a:t>
             </a:r>
             <a:endParaRPr lang="en-US" sz="2100" dirty="0"/>
           </a:p>
           <a:p>
+            <a:pPr indent="0" marL="0">
+              <a:buNone/>
+            </a:pPr>
             <a:r>
               <a:rPr lang="en-US" sz="2100" dirty="0">
                 <a:solidFill>
-                  <a:srgbClr val="17364A"/>
-                </a:solidFill>
-                <a:latin typeface="Aptos" pitchFamily="34" charset="0"/>
-                <a:ea typeface="Aptos" pitchFamily="34" charset="-122"/>
-                <a:cs typeface="Aptos" pitchFamily="34" charset="-120"/>
-              </a:rPr>
-              <a:t>Distinguish prediction from causation, diagnosis, and eligibility determination.</a:t>
+                  <a:srgbClr val="003A63"/>
+                </a:solidFill>
+                <a:latin typeface="Aptos" pitchFamily="34" charset="0"/>
+                <a:ea typeface="Aptos" pitchFamily="34" charset="-122"/>
+                <a:cs typeface="Aptos" pitchFamily="34" charset="-120"/>
+              </a:rPr>
+              <a:t>• Distinguish prediction from causation, diagnosis, and eligibility determination.</a:t>
             </a:r>
             <a:endParaRPr lang="en-US" sz="2100" dirty="0"/>
           </a:p>
           <a:p>
+            <a:pPr indent="0" marL="0">
+              <a:buNone/>
+            </a:pPr>
             <a:r>
               <a:rPr lang="en-US" sz="2100" dirty="0">
                 <a:solidFill>
-                  <a:srgbClr val="17364A"/>
-                </a:solidFill>
-                <a:latin typeface="Aptos" pitchFamily="34" charset="0"/>
-                <a:ea typeface="Aptos" pitchFamily="34" charset="-122"/>
-                <a:cs typeface="Aptos" pitchFamily="34" charset="-120"/>
-              </a:rPr>
-              <a:t>Interpret basic risk categories, thresholds, calibration, and error tradeoffs.</a:t>
+                  <a:srgbClr val="003A63"/>
+                </a:solidFill>
+                <a:latin typeface="Aptos" pitchFamily="34" charset="0"/>
+                <a:ea typeface="Aptos" pitchFamily="34" charset="-122"/>
+                <a:cs typeface="Aptos" pitchFamily="34" charset="-120"/>
+              </a:rPr>
+              <a:t>• Interpret basic risk categories, thresholds, calibration, and error tradeoffs.</a:t>
             </a:r>
             <a:endParaRPr lang="en-US" sz="2100" dirty="0"/>
           </a:p>
@@ -14160,17 +14405,17 @@
         </p:nvSpPr>
         <p:spPr>
           <a:xfrm>
-            <a:off x="7799832" y="1828800"/>
-            <a:ext cx="3145536" cy="685800"/>
-          </a:xfrm>
-          <a:prstGeom prst="rect">
-            <a:avLst/>
-          </a:prstGeom>
-          <a:noFill/>
-          <a:ln/>
-        </p:spPr>
-        <p:txBody>
-          <a:bodyPr wrap="square" lIns="0" tIns="0" rIns="0" bIns="0" rtlCol="0" anchor="t">
+            <a:off x="7799832" y="1801368"/>
+            <a:ext cx="3145536" cy="758952"/>
+          </a:xfrm>
+          <a:prstGeom prst="rect">
+            <a:avLst/>
+          </a:prstGeom>
+          <a:noFill/>
+          <a:ln/>
+        </p:spPr>
+        <p:txBody>
+          <a:bodyPr wrap="square" lIns="254" tIns="254" rIns="254" bIns="254" rtlCol="0" anchor="t">
             <a:normAutofit/>
           </a:bodyPr>
           <a:lstStyle/>
@@ -14179,7 +14424,7 @@
               <a:buNone/>
             </a:pPr>
             <a:r>
-              <a:rPr lang="en-US" sz="1550" dirty="0">
+              <a:rPr lang="en-US" sz="1320" dirty="0">
                 <a:solidFill>
                   <a:srgbClr val="17364A"/>
                 </a:solidFill>
@@ -14189,7 +14434,7 @@
               </a:rPr>
               <a:t>Define predictive analytics and risk stratification in public health terms.</a:t>
             </a:r>
-            <a:endParaRPr lang="en-US" sz="1550" dirty="0"/>
+            <a:endParaRPr lang="en-US" sz="1320" dirty="0"/>
           </a:p>
         </p:txBody>
       </p:sp>
@@ -14277,13 +14522,16 @@
           <a:ln/>
         </p:spPr>
         <p:txBody>
-          <a:bodyPr wrap="square" lIns="254" tIns="254" rIns="254" bIns="254" rtlCol="0" anchor="t">
+          <a:bodyPr wrap="square" lIns="508" tIns="508" rIns="508" bIns="508" rtlCol="0" anchor="t">
             <a:normAutofit/>
           </a:bodyPr>
           <a:lstStyle/>
           <a:p>
-            <a:r>
-              <a:rPr lang="en-US" sz="1380" dirty="0">
+            <a:pPr indent="0" marL="0">
+              <a:buNone/>
+            </a:pPr>
+            <a:r>
+              <a:rPr lang="en-US" sz="1220" dirty="0">
                 <a:solidFill>
                   <a:srgbClr val="17364A"/>
                 </a:solidFill>
@@ -14293,11 +14541,14 @@
               </a:rPr>
               <a:t>Identify equity and operational risks associated with risk scores.</a:t>
             </a:r>
-            <a:endParaRPr lang="en-US" sz="1380" dirty="0"/>
-          </a:p>
-          <a:p>
-            <a:r>
-              <a:rPr lang="en-US" sz="1380" dirty="0">
+            <a:endParaRPr lang="en-US" sz="1220" dirty="0"/>
+          </a:p>
+          <a:p>
+            <a:pPr indent="0" marL="0">
+              <a:buNone/>
+            </a:pPr>
+            <a:r>
+              <a:rPr lang="en-US" sz="1220" dirty="0">
                 <a:solidFill>
                   <a:srgbClr val="17364A"/>
                 </a:solidFill>
@@ -14305,9 +14556,9 @@
                 <a:ea typeface="Aptos" pitchFamily="34" charset="-122"/>
                 <a:cs typeface="Aptos" pitchFamily="34" charset="-120"/>
               </a:rPr>
-              <a:t>Design safeguards for use of predictive outputs in resource allocation, outreach,.</a:t>
-            </a:r>
-            <a:endParaRPr lang="en-US" sz="1380" dirty="0"/>
+              <a:t>Design safeguards for use of predictive outputs in resource.</a:t>
+            </a:r>
+            <a:endParaRPr lang="en-US" sz="1220" dirty="0"/>
           </a:p>
         </p:txBody>
       </p:sp>
@@ -14385,17 +14636,17 @@
         </p:nvSpPr>
         <p:spPr>
           <a:xfrm>
-            <a:off x="7799832" y="5001768"/>
-            <a:ext cx="3145536" cy="502920"/>
-          </a:xfrm>
-          <a:prstGeom prst="rect">
-            <a:avLst/>
-          </a:prstGeom>
-          <a:noFill/>
-          <a:ln/>
-        </p:spPr>
-        <p:txBody>
-          <a:bodyPr wrap="square" lIns="0" tIns="0" rIns="0" bIns="0" rtlCol="0" anchor="t">
+            <a:off x="7799832" y="4974336"/>
+            <a:ext cx="3145536" cy="576072"/>
+          </a:xfrm>
+          <a:prstGeom prst="rect">
+            <a:avLst/>
+          </a:prstGeom>
+          <a:noFill/>
+          <a:ln/>
+        </p:spPr>
+        <p:txBody>
+          <a:bodyPr wrap="square" lIns="254" tIns="254" rIns="254" bIns="254" rtlCol="0" anchor="t">
             <a:normAutofit/>
           </a:bodyPr>
           <a:lstStyle/>
@@ -14404,7 +14655,7 @@
               <a:buNone/>
             </a:pPr>
             <a:r>
-              <a:rPr lang="en-US" sz="1550" dirty="0">
+              <a:rPr lang="en-US" sz="1320" dirty="0">
                 <a:solidFill>
                   <a:srgbClr val="17364A"/>
                 </a:solidFill>
@@ -14412,9 +14663,9 @@
                 <a:ea typeface="Aptos" pitchFamily="34" charset="-122"/>
                 <a:cs typeface="Aptos" pitchFamily="34" charset="-120"/>
               </a:rPr>
-              <a:t>Use the assignment to test whether you can explain the concept, apply it to a realistic public health situation, and identify what would need review before the work moves forward.</a:t>
-            </a:r>
-            <a:endParaRPr lang="en-US" sz="1550" dirty="0"/>
+              <a:t>Use the assignment to test whether you can explain the concept, apply it to a realistic public health situation, and.</a:t>
+            </a:r>
+            <a:endParaRPr lang="en-US" sz="1320" dirty="0"/>
           </a:p>
         </p:txBody>
       </p:sp>
@@ -14715,21 +14966,24 @@
           <a:ln/>
         </p:spPr>
         <p:txBody>
-          <a:bodyPr wrap="square" lIns="635" tIns="635" rIns="635" bIns="635" rtlCol="0" anchor="t">
+          <a:bodyPr wrap="square" lIns="1016" tIns="1016" rIns="1016" bIns="1016" rtlCol="0" anchor="t">
             <a:normAutofit/>
           </a:bodyPr>
           <a:lstStyle/>
           <a:p>
+            <a:pPr indent="0" marL="0">
+              <a:buNone/>
+            </a:pPr>
             <a:r>
               <a:rPr lang="en-US" sz="2100" dirty="0">
                 <a:solidFill>
-                  <a:srgbClr val="17364A"/>
-                </a:solidFill>
-                <a:latin typeface="Aptos" pitchFamily="34" charset="0"/>
-                <a:ea typeface="Aptos" pitchFamily="34" charset="-122"/>
-                <a:cs typeface="Aptos" pitchFamily="34" charset="-120"/>
-              </a:rPr>
-              <a:t>Produce a predictive model review plan for a public health workflow.</a:t>
+                  <a:srgbClr val="003A63"/>
+                </a:solidFill>
+                <a:latin typeface="Aptos" pitchFamily="34" charset="0"/>
+                <a:ea typeface="Aptos" pitchFamily="34" charset="-122"/>
+                <a:cs typeface="Aptos" pitchFamily="34" charset="-120"/>
+              </a:rPr>
+              <a:t>• Produce a predictive model review plan for a public health workflow.</a:t>
             </a:r>
             <a:endParaRPr lang="en-US" sz="2100" dirty="0"/>
           </a:p>
@@ -14809,17 +15063,17 @@
         </p:nvSpPr>
         <p:spPr>
           <a:xfrm>
-            <a:off x="7799832" y="1828800"/>
-            <a:ext cx="3145536" cy="685800"/>
-          </a:xfrm>
-          <a:prstGeom prst="rect">
-            <a:avLst/>
-          </a:prstGeom>
-          <a:noFill/>
-          <a:ln/>
-        </p:spPr>
-        <p:txBody>
-          <a:bodyPr wrap="square" lIns="0" tIns="0" rIns="0" bIns="0" rtlCol="0" anchor="t">
+            <a:off x="7799832" y="1801368"/>
+            <a:ext cx="3145536" cy="758952"/>
+          </a:xfrm>
+          <a:prstGeom prst="rect">
+            <a:avLst/>
+          </a:prstGeom>
+          <a:noFill/>
+          <a:ln/>
+        </p:spPr>
+        <p:txBody>
+          <a:bodyPr wrap="square" lIns="254" tIns="254" rIns="254" bIns="254" rtlCol="0" anchor="t">
             <a:normAutofit/>
           </a:bodyPr>
           <a:lstStyle/>
@@ -14828,7 +15082,7 @@
               <a:buNone/>
             </a:pPr>
             <a:r>
-              <a:rPr lang="en-US" sz="1550" dirty="0">
+              <a:rPr lang="en-US" sz="1320" dirty="0">
                 <a:solidFill>
                   <a:srgbClr val="17364A"/>
                 </a:solidFill>
@@ -14838,7 +15092,7 @@
               </a:rPr>
               <a:t>Produce a predictive model review plan for a public health workflow.</a:t>
             </a:r>
-            <a:endParaRPr lang="en-US" sz="1550" dirty="0"/>
+            <a:endParaRPr lang="en-US" sz="1320" dirty="0"/>
           </a:p>
         </p:txBody>
       </p:sp>
@@ -14926,13 +15180,16 @@
           <a:ln/>
         </p:spPr>
         <p:txBody>
-          <a:bodyPr wrap="square" lIns="254" tIns="254" rIns="254" bIns="254" rtlCol="0" anchor="t">
+          <a:bodyPr wrap="square" lIns="508" tIns="508" rIns="508" bIns="508" rtlCol="0" anchor="t">
             <a:normAutofit/>
           </a:bodyPr>
           <a:lstStyle/>
           <a:p>
-            <a:r>
-              <a:rPr lang="en-US" sz="1380" dirty="0">
+            <a:pPr indent="0" marL="0">
+              <a:buNone/>
+            </a:pPr>
+            <a:r>
+              <a:rPr lang="en-US" sz="1220" dirty="0">
                 <a:solidFill>
                   <a:srgbClr val="17364A"/>
                 </a:solidFill>
@@ -14942,7 +15199,7 @@
               </a:rPr>
               <a:t>Produce a predictive model review plan for a public health workflow.</a:t>
             </a:r>
-            <a:endParaRPr lang="en-US" sz="1380" dirty="0"/>
+            <a:endParaRPr lang="en-US" sz="1220" dirty="0"/>
           </a:p>
         </p:txBody>
       </p:sp>
@@ -15020,17 +15277,17 @@
         </p:nvSpPr>
         <p:spPr>
           <a:xfrm>
-            <a:off x="7799832" y="5001768"/>
-            <a:ext cx="3145536" cy="502920"/>
-          </a:xfrm>
-          <a:prstGeom prst="rect">
-            <a:avLst/>
-          </a:prstGeom>
-          <a:noFill/>
-          <a:ln/>
-        </p:spPr>
-        <p:txBody>
-          <a:bodyPr wrap="square" lIns="0" tIns="0" rIns="0" bIns="0" rtlCol="0" anchor="t">
+            <a:off x="7799832" y="4974336"/>
+            <a:ext cx="3145536" cy="576072"/>
+          </a:xfrm>
+          <a:prstGeom prst="rect">
+            <a:avLst/>
+          </a:prstGeom>
+          <a:noFill/>
+          <a:ln/>
+        </p:spPr>
+        <p:txBody>
+          <a:bodyPr wrap="square" lIns="254" tIns="254" rIns="254" bIns="254" rtlCol="0" anchor="t">
             <a:normAutofit/>
           </a:bodyPr>
           <a:lstStyle/>
@@ -15039,7 +15296,7 @@
               <a:buNone/>
             </a:pPr>
             <a:r>
-              <a:rPr lang="en-US" sz="1550" dirty="0">
+              <a:rPr lang="en-US" sz="1320" dirty="0">
                 <a:solidFill>
                   <a:srgbClr val="17364A"/>
                 </a:solidFill>
@@ -15047,9 +15304,9 @@
                 <a:ea typeface="Aptos" pitchFamily="34" charset="-122"/>
                 <a:cs typeface="Aptos" pitchFamily="34" charset="-120"/>
               </a:rPr>
-              <a:t>Use the assignment to test whether you can explain the concept, apply it to a realistic public health situation, and identify what would need review before the work moves forward.</a:t>
-            </a:r>
-            <a:endParaRPr lang="en-US" sz="1550" dirty="0"/>
+              <a:t>Use the assignment to test whether you can explain the concept, apply it to a realistic public health situation, and.</a:t>
+            </a:r>
+            <a:endParaRPr lang="en-US" sz="1320" dirty="0"/>
           </a:p>
         </p:txBody>
       </p:sp>
@@ -15350,49 +15607,58 @@
           <a:ln/>
         </p:spPr>
         <p:txBody>
-          <a:bodyPr wrap="square" lIns="635" tIns="635" rIns="635" bIns="635" rtlCol="0" anchor="t">
+          <a:bodyPr wrap="square" lIns="1016" tIns="1016" rIns="1016" bIns="1016" rtlCol="0" anchor="t">
             <a:normAutofit/>
           </a:bodyPr>
           <a:lstStyle/>
           <a:p>
+            <a:pPr indent="0" marL="0">
+              <a:buNone/>
+            </a:pPr>
             <a:r>
               <a:rPr lang="en-US" sz="2100" dirty="0">
                 <a:solidFill>
-                  <a:srgbClr val="17364A"/>
-                </a:solidFill>
-                <a:latin typeface="Aptos" pitchFamily="34" charset="0"/>
-                <a:ea typeface="Aptos" pitchFamily="34" charset="-122"/>
-                <a:cs typeface="Aptos" pitchFamily="34" charset="-120"/>
-              </a:rPr>
-              <a:t>Predictive analytics uses data to estimate the likelihood of future events or outcomes.</a:t>
+                  <a:srgbClr val="003A63"/>
+                </a:solidFill>
+                <a:latin typeface="Aptos" pitchFamily="34" charset="0"/>
+                <a:ea typeface="Aptos" pitchFamily="34" charset="-122"/>
+                <a:cs typeface="Aptos" pitchFamily="34" charset="-120"/>
+              </a:rPr>
+              <a:t>• Predictive analytics uses data to estimate the likelihood of future events or outcomes.</a:t>
             </a:r>
             <a:endParaRPr lang="en-US" sz="2100" dirty="0"/>
           </a:p>
           <a:p>
+            <a:pPr indent="0" marL="0">
+              <a:buNone/>
+            </a:pPr>
             <a:r>
               <a:rPr lang="en-US" sz="2100" dirty="0">
                 <a:solidFill>
-                  <a:srgbClr val="17364A"/>
-                </a:solidFill>
-                <a:latin typeface="Aptos" pitchFamily="34" charset="0"/>
-                <a:ea typeface="Aptos" pitchFamily="34" charset="-122"/>
-                <a:cs typeface="Aptos" pitchFamily="34" charset="-120"/>
-              </a:rPr>
-              <a:t>In public health, predictive models may be used to anticipate disease burden, identify populations at.</a:t>
+                  <a:srgbClr val="003A63"/>
+                </a:solidFill>
+                <a:latin typeface="Aptos" pitchFamily="34" charset="0"/>
+                <a:ea typeface="Aptos" pitchFamily="34" charset="-122"/>
+                <a:cs typeface="Aptos" pitchFamily="34" charset="-120"/>
+              </a:rPr>
+              <a:t>• In public health, predictive models may be used to anticipate disease burden, identify.</a:t>
             </a:r>
             <a:endParaRPr lang="en-US" sz="2100" dirty="0"/>
           </a:p>
           <a:p>
+            <a:pPr indent="0" marL="0">
+              <a:buNone/>
+            </a:pPr>
             <a:r>
               <a:rPr lang="en-US" sz="2100" dirty="0">
                 <a:solidFill>
-                  <a:srgbClr val="17364A"/>
-                </a:solidFill>
-                <a:latin typeface="Aptos" pitchFamily="34" charset="0"/>
-                <a:ea typeface="Aptos" pitchFamily="34" charset="-122"/>
-                <a:cs typeface="Aptos" pitchFamily="34" charset="-120"/>
-              </a:rPr>
-              <a:t>Risk stratification is the practice of grouping individuals, facilities, areas, events, or populations.</a:t>
+                  <a:srgbClr val="003A63"/>
+                </a:solidFill>
+                <a:latin typeface="Aptos" pitchFamily="34" charset="0"/>
+                <a:ea typeface="Aptos" pitchFamily="34" charset="-122"/>
+                <a:cs typeface="Aptos" pitchFamily="34" charset="-120"/>
+              </a:rPr>
+              <a:t>• Risk stratification is the practice of grouping individuals, facilities, areas, events, or.</a:t>
             </a:r>
             <a:endParaRPr lang="en-US" sz="2100" dirty="0"/>
           </a:p>
@@ -15472,17 +15738,17 @@
         </p:nvSpPr>
         <p:spPr>
           <a:xfrm>
-            <a:off x="7799832" y="1828800"/>
-            <a:ext cx="3145536" cy="685800"/>
-          </a:xfrm>
-          <a:prstGeom prst="rect">
-            <a:avLst/>
-          </a:prstGeom>
-          <a:noFill/>
-          <a:ln/>
-        </p:spPr>
-        <p:txBody>
-          <a:bodyPr wrap="square" lIns="0" tIns="0" rIns="0" bIns="0" rtlCol="0" anchor="t">
+            <a:off x="7799832" y="1801368"/>
+            <a:ext cx="3145536" cy="758952"/>
+          </a:xfrm>
+          <a:prstGeom prst="rect">
+            <a:avLst/>
+          </a:prstGeom>
+          <a:noFill/>
+          <a:ln/>
+        </p:spPr>
+        <p:txBody>
+          <a:bodyPr wrap="square" lIns="254" tIns="254" rIns="254" bIns="254" rtlCol="0" anchor="t">
             <a:normAutofit/>
           </a:bodyPr>
           <a:lstStyle/>
@@ -15491,7 +15757,7 @@
               <a:buNone/>
             </a:pPr>
             <a:r>
-              <a:rPr lang="en-US" sz="1550" dirty="0">
+              <a:rPr lang="en-US" sz="1320" dirty="0">
                 <a:solidFill>
                   <a:srgbClr val="17364A"/>
                 </a:solidFill>
@@ -15501,7 +15767,7 @@
               </a:rPr>
               <a:t>Predictive analytics uses data to estimate the likelihood of future events or outcomes.</a:t>
             </a:r>
-            <a:endParaRPr lang="en-US" sz="1550" dirty="0"/>
+            <a:endParaRPr lang="en-US" sz="1320" dirty="0"/>
           </a:p>
         </p:txBody>
       </p:sp>
@@ -15589,13 +15855,16 @@
           <a:ln/>
         </p:spPr>
         <p:txBody>
-          <a:bodyPr wrap="square" lIns="254" tIns="254" rIns="254" bIns="254" rtlCol="0" anchor="t">
+          <a:bodyPr wrap="square" lIns="508" tIns="508" rIns="508" bIns="508" rtlCol="0" anchor="t">
             <a:normAutofit/>
           </a:bodyPr>
           <a:lstStyle/>
           <a:p>
-            <a:r>
-              <a:rPr lang="en-US" sz="1380" dirty="0">
+            <a:pPr indent="0" marL="0">
+              <a:buNone/>
+            </a:pPr>
+            <a:r>
+              <a:rPr lang="en-US" sz="1220" dirty="0">
                 <a:solidFill>
                   <a:srgbClr val="17364A"/>
                 </a:solidFill>
@@ -15603,13 +15872,16 @@
                 <a:ea typeface="Aptos" pitchFamily="34" charset="-122"/>
                 <a:cs typeface="Aptos" pitchFamily="34" charset="-120"/>
               </a:rPr>
-              <a:t>In public health, predictive models may be used to anticipate disease burden, identify.</a:t>
-            </a:r>
-            <a:endParaRPr lang="en-US" sz="1380" dirty="0"/>
-          </a:p>
-          <a:p>
-            <a:r>
-              <a:rPr lang="en-US" sz="1380" dirty="0">
+              <a:t>In public health, predictive models may be used to anticipate.</a:t>
+            </a:r>
+            <a:endParaRPr lang="en-US" sz="1220" dirty="0"/>
+          </a:p>
+          <a:p>
+            <a:pPr indent="0" marL="0">
+              <a:buNone/>
+            </a:pPr>
+            <a:r>
+              <a:rPr lang="en-US" sz="1220" dirty="0">
                 <a:solidFill>
                   <a:srgbClr val="17364A"/>
                 </a:solidFill>
@@ -15617,13 +15889,16 @@
                 <a:ea typeface="Aptos" pitchFamily="34" charset="-122"/>
                 <a:cs typeface="Aptos" pitchFamily="34" charset="-120"/>
               </a:rPr>
-              <a:t>Risk stratification is the practice of grouping individuals, facilities, areas, events, or.</a:t>
-            </a:r>
-            <a:endParaRPr lang="en-US" sz="1380" dirty="0"/>
-          </a:p>
-          <a:p>
-            <a:r>
-              <a:rPr lang="en-US" sz="1380" dirty="0">
+              <a:t>Risk stratification is the practice of grouping individuals,.</a:t>
+            </a:r>
+            <a:endParaRPr lang="en-US" sz="1220" dirty="0"/>
+          </a:p>
+          <a:p>
+            <a:pPr indent="0" marL="0">
+              <a:buNone/>
+            </a:pPr>
+            <a:r>
+              <a:rPr lang="en-US" sz="1220" dirty="0">
                 <a:solidFill>
                   <a:srgbClr val="17364A"/>
                 </a:solidFill>
@@ -15631,9 +15906,9 @@
                 <a:ea typeface="Aptos" pitchFamily="34" charset="-122"/>
                 <a:cs typeface="Aptos" pitchFamily="34" charset="-120"/>
               </a:rPr>
-              <a:t>This module helps learners distinguish prediction from diagnosis, causation, eligibility.</a:t>
-            </a:r>
-            <a:endParaRPr lang="en-US" sz="1380" dirty="0"/>
+              <a:t>This module helps learners distinguish prediction from diagnosis,.</a:t>
+            </a:r>
+            <a:endParaRPr lang="en-US" sz="1220" dirty="0"/>
           </a:p>
         </p:txBody>
       </p:sp>
@@ -15711,17 +15986,17 @@
         </p:nvSpPr>
         <p:spPr>
           <a:xfrm>
-            <a:off x="7799832" y="5001768"/>
-            <a:ext cx="3145536" cy="502920"/>
-          </a:xfrm>
-          <a:prstGeom prst="rect">
-            <a:avLst/>
-          </a:prstGeom>
-          <a:noFill/>
-          <a:ln/>
-        </p:spPr>
-        <p:txBody>
-          <a:bodyPr wrap="square" lIns="0" tIns="0" rIns="0" bIns="0" rtlCol="0" anchor="t">
+            <a:off x="7799832" y="4974336"/>
+            <a:ext cx="3145536" cy="576072"/>
+          </a:xfrm>
+          <a:prstGeom prst="rect">
+            <a:avLst/>
+          </a:prstGeom>
+          <a:noFill/>
+          <a:ln/>
+        </p:spPr>
+        <p:txBody>
+          <a:bodyPr wrap="square" lIns="254" tIns="254" rIns="254" bIns="254" rtlCol="0" anchor="t">
             <a:normAutofit/>
           </a:bodyPr>
           <a:lstStyle/>
@@ -15730,7 +16005,7 @@
               <a:buNone/>
             </a:pPr>
             <a:r>
-              <a:rPr lang="en-US" sz="1550" dirty="0">
+              <a:rPr lang="en-US" sz="1320" dirty="0">
                 <a:solidFill>
                   <a:srgbClr val="17364A"/>
                 </a:solidFill>
@@ -15738,9 +16013,9 @@
                 <a:ea typeface="Aptos" pitchFamily="34" charset="-122"/>
                 <a:cs typeface="Aptos" pitchFamily="34" charset="-120"/>
               </a:rPr>
-              <a:t>Identify what could go wrong, who could be affected, what safeguards are needed, and what evidence should be reviewed before use expands.</a:t>
-            </a:r>
-            <a:endParaRPr lang="en-US" sz="1550" dirty="0"/>
+              <a:t>Identify what could go wrong, who could be affected, what safeguards are needed, and what evidence should be reviewed.</a:t>
+            </a:r>
+            <a:endParaRPr lang="en-US" sz="1320" dirty="0"/>
           </a:p>
         </p:txBody>
       </p:sp>
@@ -16041,49 +16316,58 @@
           <a:ln/>
         </p:spPr>
         <p:txBody>
-          <a:bodyPr wrap="square" lIns="635" tIns="635" rIns="635" bIns="635" rtlCol="0" anchor="t">
+          <a:bodyPr wrap="square" lIns="1016" tIns="1016" rIns="1016" bIns="1016" rtlCol="0" anchor="t">
             <a:normAutofit/>
           </a:bodyPr>
           <a:lstStyle/>
           <a:p>
+            <a:pPr indent="0" marL="0">
+              <a:buNone/>
+            </a:pPr>
             <a:r>
               <a:rPr lang="en-US" sz="2100" dirty="0">
                 <a:solidFill>
-                  <a:srgbClr val="17364A"/>
-                </a:solidFill>
-                <a:latin typeface="Aptos" pitchFamily="34" charset="0"/>
-                <a:ea typeface="Aptos" pitchFamily="34" charset="-122"/>
-                <a:cs typeface="Aptos" pitchFamily="34" charset="-120"/>
-              </a:rPr>
-              <a:t>Predictive analytics matters because public health agencies often must act before all information is.</a:t>
+                  <a:srgbClr val="003A63"/>
+                </a:solidFill>
+                <a:latin typeface="Aptos" pitchFamily="34" charset="0"/>
+                <a:ea typeface="Aptos" pitchFamily="34" charset="-122"/>
+                <a:cs typeface="Aptos" pitchFamily="34" charset="-120"/>
+              </a:rPr>
+              <a:t>• Predictive analytics matters because public health agencies often must act before all.</a:t>
             </a:r>
             <a:endParaRPr lang="en-US" sz="2100" dirty="0"/>
           </a:p>
           <a:p>
+            <a:pPr indent="0" marL="0">
+              <a:buNone/>
+            </a:pPr>
             <a:r>
               <a:rPr lang="en-US" sz="2100" dirty="0">
                 <a:solidFill>
-                  <a:srgbClr val="17364A"/>
-                </a:solidFill>
-                <a:latin typeface="Aptos" pitchFamily="34" charset="0"/>
-                <a:ea typeface="Aptos" pitchFamily="34" charset="-122"/>
-                <a:cs typeface="Aptos" pitchFamily="34" charset="-120"/>
-              </a:rPr>
-              <a:t>During outbreaks, emergencies, or resource-constrained programs, agencies may need to decide where to.</a:t>
+                  <a:srgbClr val="003A63"/>
+                </a:solidFill>
+                <a:latin typeface="Aptos" pitchFamily="34" charset="0"/>
+                <a:ea typeface="Aptos" pitchFamily="34" charset="-122"/>
+                <a:cs typeface="Aptos" pitchFamily="34" charset="-120"/>
+              </a:rPr>
+              <a:t>• During outbreaks, emergencies, or resource-constrained programs, agencies may need to decide.</a:t>
             </a:r>
             <a:endParaRPr lang="en-US" sz="2100" dirty="0"/>
           </a:p>
           <a:p>
+            <a:pPr indent="0" marL="0">
+              <a:buNone/>
+            </a:pPr>
             <a:r>
               <a:rPr lang="en-US" sz="2100" dirty="0">
                 <a:solidFill>
-                  <a:srgbClr val="17364A"/>
-                </a:solidFill>
-                <a:latin typeface="Aptos" pitchFamily="34" charset="0"/>
-                <a:ea typeface="Aptos" pitchFamily="34" charset="-122"/>
-                <a:cs typeface="Aptos" pitchFamily="34" charset="-120"/>
-              </a:rPr>
-              <a:t>Prediction can help organize uncertainty, but it cannot remove uncertainty.</a:t>
+                  <a:srgbClr val="003A63"/>
+                </a:solidFill>
+                <a:latin typeface="Aptos" pitchFamily="34" charset="0"/>
+                <a:ea typeface="Aptos" pitchFamily="34" charset="-122"/>
+                <a:cs typeface="Aptos" pitchFamily="34" charset="-120"/>
+              </a:rPr>
+              <a:t>• Prediction can help organize uncertainty, but it cannot remove uncertainty.</a:t>
             </a:r>
             <a:endParaRPr lang="en-US" sz="2100" dirty="0"/>
           </a:p>
@@ -16163,17 +16447,17 @@
         </p:nvSpPr>
         <p:spPr>
           <a:xfrm>
-            <a:off x="7799832" y="1828800"/>
-            <a:ext cx="3145536" cy="685800"/>
-          </a:xfrm>
-          <a:prstGeom prst="rect">
-            <a:avLst/>
-          </a:prstGeom>
-          <a:noFill/>
-          <a:ln/>
-        </p:spPr>
-        <p:txBody>
-          <a:bodyPr wrap="square" lIns="0" tIns="0" rIns="0" bIns="0" rtlCol="0" anchor="t">
+            <a:off x="7799832" y="1801368"/>
+            <a:ext cx="3145536" cy="758952"/>
+          </a:xfrm>
+          <a:prstGeom prst="rect">
+            <a:avLst/>
+          </a:prstGeom>
+          <a:noFill/>
+          <a:ln/>
+        </p:spPr>
+        <p:txBody>
+          <a:bodyPr wrap="square" lIns="254" tIns="254" rIns="254" bIns="254" rtlCol="0" anchor="t">
             <a:normAutofit/>
           </a:bodyPr>
           <a:lstStyle/>
@@ -16182,7 +16466,7 @@
               <a:buNone/>
             </a:pPr>
             <a:r>
-              <a:rPr lang="en-US" sz="1550" dirty="0">
+              <a:rPr lang="en-US" sz="1320" dirty="0">
                 <a:solidFill>
                   <a:srgbClr val="17364A"/>
                 </a:solidFill>
@@ -16192,7 +16476,7 @@
               </a:rPr>
               <a:t>Predictive analytics matters because public health agencies often must act before all information is.</a:t>
             </a:r>
-            <a:endParaRPr lang="en-US" sz="1550" dirty="0"/>
+            <a:endParaRPr lang="en-US" sz="1320" dirty="0"/>
           </a:p>
         </p:txBody>
       </p:sp>
@@ -16280,13 +16564,16 @@
           <a:ln/>
         </p:spPr>
         <p:txBody>
-          <a:bodyPr wrap="square" lIns="254" tIns="254" rIns="254" bIns="254" rtlCol="0" anchor="t">
+          <a:bodyPr wrap="square" lIns="508" tIns="508" rIns="508" bIns="508" rtlCol="0" anchor="t">
             <a:normAutofit/>
           </a:bodyPr>
           <a:lstStyle/>
           <a:p>
-            <a:r>
-              <a:rPr lang="en-US" sz="1380" dirty="0">
+            <a:pPr indent="0" marL="0">
+              <a:buNone/>
+            </a:pPr>
+            <a:r>
+              <a:rPr lang="en-US" sz="1220" dirty="0">
                 <a:solidFill>
                   <a:srgbClr val="17364A"/>
                 </a:solidFill>
@@ -16294,13 +16581,16 @@
                 <a:ea typeface="Aptos" pitchFamily="34" charset="-122"/>
                 <a:cs typeface="Aptos" pitchFamily="34" charset="-120"/>
               </a:rPr>
-              <a:t>Predictive analytics matters because public health agencies often must act before all.</a:t>
-            </a:r>
-            <a:endParaRPr lang="en-US" sz="1380" dirty="0"/>
-          </a:p>
-          <a:p>
-            <a:r>
-              <a:rPr lang="en-US" sz="1380" dirty="0">
+              <a:t>Predictive analytics matters because public health agencies often.</a:t>
+            </a:r>
+            <a:endParaRPr lang="en-US" sz="1220" dirty="0"/>
+          </a:p>
+          <a:p>
+            <a:pPr indent="0" marL="0">
+              <a:buNone/>
+            </a:pPr>
+            <a:r>
+              <a:rPr lang="en-US" sz="1220" dirty="0">
                 <a:solidFill>
                   <a:srgbClr val="17364A"/>
                 </a:solidFill>
@@ -16308,13 +16598,16 @@
                 <a:ea typeface="Aptos" pitchFamily="34" charset="-122"/>
                 <a:cs typeface="Aptos" pitchFamily="34" charset="-120"/>
               </a:rPr>
-              <a:t>During outbreaks, emergencies, or resource-constrained programs, agencies may need to.</a:t>
-            </a:r>
-            <a:endParaRPr lang="en-US" sz="1380" dirty="0"/>
-          </a:p>
-          <a:p>
-            <a:r>
-              <a:rPr lang="en-US" sz="1380" dirty="0">
+              <a:t>During outbreaks, emergencies, or resource-constrained programs,.</a:t>
+            </a:r>
+            <a:endParaRPr lang="en-US" sz="1220" dirty="0"/>
+          </a:p>
+          <a:p>
+            <a:pPr indent="0" marL="0">
+              <a:buNone/>
+            </a:pPr>
+            <a:r>
+              <a:rPr lang="en-US" sz="1220" dirty="0">
                 <a:solidFill>
                   <a:srgbClr val="17364A"/>
                 </a:solidFill>
@@ -16324,7 +16617,7 @@
               </a:rPr>
               <a:t>Risk stratification can also create harm if used carelessly.</a:t>
             </a:r>
-            <a:endParaRPr lang="en-US" sz="1380" dirty="0"/>
+            <a:endParaRPr lang="en-US" sz="1220" dirty="0"/>
           </a:p>
         </p:txBody>
       </p:sp>
@@ -16402,17 +16695,17 @@
         </p:nvSpPr>
         <p:spPr>
           <a:xfrm>
-            <a:off x="7799832" y="5001768"/>
-            <a:ext cx="3145536" cy="502920"/>
-          </a:xfrm>
-          <a:prstGeom prst="rect">
-            <a:avLst/>
-          </a:prstGeom>
-          <a:noFill/>
-          <a:ln/>
-        </p:spPr>
-        <p:txBody>
-          <a:bodyPr wrap="square" lIns="0" tIns="0" rIns="0" bIns="0" rtlCol="0" anchor="t">
+            <a:off x="7799832" y="4974336"/>
+            <a:ext cx="3145536" cy="576072"/>
+          </a:xfrm>
+          <a:prstGeom prst="rect">
+            <a:avLst/>
+          </a:prstGeom>
+          <a:noFill/>
+          <a:ln/>
+        </p:spPr>
+        <p:txBody>
+          <a:bodyPr wrap="square" lIns="254" tIns="254" rIns="254" bIns="254" rtlCol="0" anchor="t">
             <a:normAutofit/>
           </a:bodyPr>
           <a:lstStyle/>
@@ -16421,7 +16714,7 @@
               <a:buNone/>
             </a:pPr>
             <a:r>
-              <a:rPr lang="en-US" sz="1550" dirty="0">
+              <a:rPr lang="en-US" sz="1320" dirty="0">
                 <a:solidFill>
                   <a:srgbClr val="17364A"/>
                 </a:solidFill>
@@ -16429,9 +16722,9 @@
                 <a:ea typeface="Aptos" pitchFamily="34" charset="-122"/>
                 <a:cs typeface="Aptos" pitchFamily="34" charset="-120"/>
               </a:rPr>
-              <a:t>Identify what could go wrong, who could be affected, what safeguards are needed, and what evidence should be reviewed before use expands.</a:t>
-            </a:r>
-            <a:endParaRPr lang="en-US" sz="1550" dirty="0"/>
+              <a:t>Identify what could go wrong, who could be affected, what safeguards are needed, and what evidence should be reviewed.</a:t>
+            </a:r>
+            <a:endParaRPr lang="en-US" sz="1320" dirty="0"/>
           </a:p>
         </p:txBody>
       </p:sp>
@@ -16732,49 +17025,58 @@
           <a:ln/>
         </p:spPr>
         <p:txBody>
-          <a:bodyPr wrap="square" lIns="635" tIns="635" rIns="635" bIns="635" rtlCol="0" anchor="t">
+          <a:bodyPr wrap="square" lIns="1016" tIns="1016" rIns="1016" bIns="1016" rtlCol="0" anchor="t">
             <a:normAutofit/>
           </a:bodyPr>
           <a:lstStyle/>
           <a:p>
+            <a:pPr indent="0" marL="0">
+              <a:buNone/>
+            </a:pPr>
             <a:r>
               <a:rPr lang="en-US" sz="2100" dirty="0">
                 <a:solidFill>
-                  <a:srgbClr val="17364A"/>
-                </a:solidFill>
-                <a:latin typeface="Aptos" pitchFamily="34" charset="0"/>
-                <a:ea typeface="Aptos" pitchFamily="34" charset="-122"/>
-                <a:cs typeface="Aptos" pitchFamily="34" charset="-120"/>
-              </a:rPr>
-              <a:t>A local health department may want to predict which neighborhoods are at increased risk of low.</a:t>
+                  <a:srgbClr val="003A63"/>
+                </a:solidFill>
+                <a:latin typeface="Aptos" pitchFamily="34" charset="0"/>
+                <a:ea typeface="Aptos" pitchFamily="34" charset="-122"/>
+                <a:cs typeface="Aptos" pitchFamily="34" charset="-120"/>
+              </a:rPr>
+              <a:t>• A local health department may want to predict which neighborhoods are at increased risk of low.</a:t>
             </a:r>
             <a:endParaRPr lang="en-US" sz="2100" dirty="0"/>
           </a:p>
           <a:p>
+            <a:pPr indent="0" marL="0">
+              <a:buNone/>
+            </a:pPr>
             <a:r>
               <a:rPr lang="en-US" sz="2100" dirty="0">
                 <a:solidFill>
-                  <a:srgbClr val="17364A"/>
-                </a:solidFill>
-                <a:latin typeface="Aptos" pitchFamily="34" charset="0"/>
-                <a:ea typeface="Aptos" pitchFamily="34" charset="-122"/>
-                <a:cs typeface="Aptos" pitchFamily="34" charset="-120"/>
-              </a:rPr>
-              <a:t>The model could use prior immunization data, school enrollment patterns, appointment availability,.</a:t>
+                  <a:srgbClr val="003A63"/>
+                </a:solidFill>
+                <a:latin typeface="Aptos" pitchFamily="34" charset="0"/>
+                <a:ea typeface="Aptos" pitchFamily="34" charset="-122"/>
+                <a:cs typeface="Aptos" pitchFamily="34" charset="-120"/>
+              </a:rPr>
+              <a:t>• The model could use prior immunization data, school enrollment patterns, appointment.</a:t>
             </a:r>
             <a:endParaRPr lang="en-US" sz="2100" dirty="0"/>
           </a:p>
           <a:p>
+            <a:pPr indent="0" marL="0">
+              <a:buNone/>
+            </a:pPr>
             <a:r>
               <a:rPr lang="en-US" sz="2100" dirty="0">
                 <a:solidFill>
-                  <a:srgbClr val="17364A"/>
-                </a:solidFill>
-                <a:latin typeface="Aptos" pitchFamily="34" charset="0"/>
-                <a:ea typeface="Aptos" pitchFamily="34" charset="-122"/>
-                <a:cs typeface="Aptos" pitchFamily="34" charset="-120"/>
-              </a:rPr>
-              <a:t>The output might help prioritize community outreach and mobile clinics.</a:t>
+                  <a:srgbClr val="003A63"/>
+                </a:solidFill>
+                <a:latin typeface="Aptos" pitchFamily="34" charset="0"/>
+                <a:ea typeface="Aptos" pitchFamily="34" charset="-122"/>
+                <a:cs typeface="Aptos" pitchFamily="34" charset="-120"/>
+              </a:rPr>
+              <a:t>• The output might help prioritize community outreach and mobile clinics.</a:t>
             </a:r>
             <a:endParaRPr lang="en-US" sz="2100" dirty="0"/>
           </a:p>
@@ -16854,17 +17156,17 @@
         </p:nvSpPr>
         <p:spPr>
           <a:xfrm>
-            <a:off x="7799832" y="1828800"/>
-            <a:ext cx="3145536" cy="685800"/>
-          </a:xfrm>
-          <a:prstGeom prst="rect">
-            <a:avLst/>
-          </a:prstGeom>
-          <a:noFill/>
-          <a:ln/>
-        </p:spPr>
-        <p:txBody>
-          <a:bodyPr wrap="square" lIns="0" tIns="0" rIns="0" bIns="0" rtlCol="0" anchor="t">
+            <a:off x="7799832" y="1801368"/>
+            <a:ext cx="3145536" cy="758952"/>
+          </a:xfrm>
+          <a:prstGeom prst="rect">
+            <a:avLst/>
+          </a:prstGeom>
+          <a:noFill/>
+          <a:ln/>
+        </p:spPr>
+        <p:txBody>
+          <a:bodyPr wrap="square" lIns="254" tIns="254" rIns="254" bIns="254" rtlCol="0" anchor="t">
             <a:normAutofit/>
           </a:bodyPr>
           <a:lstStyle/>
@@ -16873,7 +17175,7 @@
               <a:buNone/>
             </a:pPr>
             <a:r>
-              <a:rPr lang="en-US" sz="1550" dirty="0">
+              <a:rPr lang="en-US" sz="1320" dirty="0">
                 <a:solidFill>
                   <a:srgbClr val="17364A"/>
                 </a:solidFill>
@@ -16883,7 +17185,7 @@
               </a:rPr>
               <a:t>A local health department may want to predict which neighborhoods are at increased risk of low.</a:t>
             </a:r>
-            <a:endParaRPr lang="en-US" sz="1550" dirty="0"/>
+            <a:endParaRPr lang="en-US" sz="1320" dirty="0"/>
           </a:p>
         </p:txBody>
       </p:sp>
@@ -16971,13 +17273,16 @@
           <a:ln/>
         </p:spPr>
         <p:txBody>
-          <a:bodyPr wrap="square" lIns="254" tIns="254" rIns="254" bIns="254" rtlCol="0" anchor="t">
+          <a:bodyPr wrap="square" lIns="508" tIns="508" rIns="508" bIns="508" rtlCol="0" anchor="t">
             <a:normAutofit/>
           </a:bodyPr>
           <a:lstStyle/>
           <a:p>
-            <a:r>
-              <a:rPr lang="en-US" sz="1380" dirty="0">
+            <a:pPr indent="0" marL="0">
+              <a:buNone/>
+            </a:pPr>
+            <a:r>
+              <a:rPr lang="en-US" sz="1220" dirty="0">
                 <a:solidFill>
                   <a:srgbClr val="17364A"/>
                 </a:solidFill>
@@ -16985,13 +17290,16 @@
                 <a:ea typeface="Aptos" pitchFamily="34" charset="-122"/>
                 <a:cs typeface="Aptos" pitchFamily="34" charset="-120"/>
               </a:rPr>
-              <a:t>A local health department may want to predict which neighborhoods are at increased risk of.</a:t>
-            </a:r>
-            <a:endParaRPr lang="en-US" sz="1380" dirty="0"/>
-          </a:p>
-          <a:p>
-            <a:r>
-              <a:rPr lang="en-US" sz="1380" dirty="0">
+              <a:t>A local health department may want to predict which neighborhoods.</a:t>
+            </a:r>
+            <a:endParaRPr lang="en-US" sz="1220" dirty="0"/>
+          </a:p>
+          <a:p>
+            <a:pPr indent="0" marL="0">
+              <a:buNone/>
+            </a:pPr>
+            <a:r>
+              <a:rPr lang="en-US" sz="1220" dirty="0">
                 <a:solidFill>
                   <a:srgbClr val="17364A"/>
                 </a:solidFill>
@@ -16999,13 +17307,16 @@
                 <a:ea typeface="Aptos" pitchFamily="34" charset="-122"/>
                 <a:cs typeface="Aptos" pitchFamily="34" charset="-120"/>
               </a:rPr>
-              <a:t>The model could use prior immunization data, school enrollment patterns, appointment.</a:t>
-            </a:r>
-            <a:endParaRPr lang="en-US" sz="1380" dirty="0"/>
-          </a:p>
-          <a:p>
-            <a:r>
-              <a:rPr lang="en-US" sz="1380" dirty="0">
+              <a:t>The model could use prior immunization data, school enrollment.</a:t>
+            </a:r>
+            <a:endParaRPr lang="en-US" sz="1220" dirty="0"/>
+          </a:p>
+          <a:p>
+            <a:pPr indent="0" marL="0">
+              <a:buNone/>
+            </a:pPr>
+            <a:r>
+              <a:rPr lang="en-US" sz="1220" dirty="0">
                 <a:solidFill>
                   <a:srgbClr val="17364A"/>
                 </a:solidFill>
@@ -17013,9 +17324,9 @@
                 <a:ea typeface="Aptos" pitchFamily="34" charset="-122"/>
                 <a:cs typeface="Aptos" pitchFamily="34" charset="-120"/>
               </a:rPr>
-              <a:t>This use can support equity if it directs resources toward communities facing access.</a:t>
-            </a:r>
-            <a:endParaRPr lang="en-US" sz="1380" dirty="0"/>
+              <a:t>This use can support equity if it directs resources toward.</a:t>
+            </a:r>
+            <a:endParaRPr lang="en-US" sz="1220" dirty="0"/>
           </a:p>
         </p:txBody>
       </p:sp>
@@ -17093,17 +17404,17 @@
         </p:nvSpPr>
         <p:spPr>
           <a:xfrm>
-            <a:off x="7799832" y="5001768"/>
-            <a:ext cx="3145536" cy="502920"/>
-          </a:xfrm>
-          <a:prstGeom prst="rect">
-            <a:avLst/>
-          </a:prstGeom>
-          <a:noFill/>
-          <a:ln/>
-        </p:spPr>
-        <p:txBody>
-          <a:bodyPr wrap="square" lIns="0" tIns="0" rIns="0" bIns="0" rtlCol="0" anchor="t">
+            <a:off x="7799832" y="4974336"/>
+            <a:ext cx="3145536" cy="576072"/>
+          </a:xfrm>
+          <a:prstGeom prst="rect">
+            <a:avLst/>
+          </a:prstGeom>
+          <a:noFill/>
+          <a:ln/>
+        </p:spPr>
+        <p:txBody>
+          <a:bodyPr wrap="square" lIns="254" tIns="254" rIns="254" bIns="254" rtlCol="0" anchor="t">
             <a:normAutofit/>
           </a:bodyPr>
           <a:lstStyle/>
@@ -17112,7 +17423,7 @@
               <a:buNone/>
             </a:pPr>
             <a:r>
-              <a:rPr lang="en-US" sz="1550" dirty="0">
+              <a:rPr lang="en-US" sz="1320" dirty="0">
                 <a:solidFill>
                   <a:srgbClr val="17364A"/>
                 </a:solidFill>
@@ -17120,9 +17431,9 @@
                 <a:ea typeface="Aptos" pitchFamily="34" charset="-122"/>
                 <a:cs typeface="Aptos" pitchFamily="34" charset="-120"/>
               </a:rPr>
-              <a:t>Identify what could go wrong, who could be affected, what safeguards are needed, and what evidence should be reviewed before use expands.</a:t>
-            </a:r>
-            <a:endParaRPr lang="en-US" sz="1550" dirty="0"/>
+              <a:t>Identify what could go wrong, who could be affected, what safeguards are needed, and what evidence should be reviewed.</a:t>
+            </a:r>
+            <a:endParaRPr lang="en-US" sz="1320" dirty="0"/>
           </a:p>
         </p:txBody>
       </p:sp>

</xml_diff>